<commit_message>
docs: redesign hackathon presentation deck without pricing, enhance visuals and pitch structure
</commit_message>
<xml_diff>
--- a/ViralFlow_AI_Hackathon_Presentation.pptx
+++ b/ViralFlow_AI_Hackathon_Presentation.pptx
@@ -12,6 +12,7 @@
     <p:sldId id="260" r:id="rId11"/>
     <p:sldId id="261" r:id="rId12"/>
     <p:sldId id="262" r:id="rId13"/>
+    <p:sldId id="263" r:id="rId14"/>
   </p:sldIdLst>
   <p:sldSz cx="12191695" cy="6858000" type="screen4x3"/>
   <p:notesSz cx="6858000" cy="9144000"/>
@@ -3109,12 +3110,10 @@
             <a:avLst/>
           </a:prstGeom>
           <a:solidFill>
-            <a:srgbClr val="0A0A0F"/>
+            <a:srgbClr val="0A0C12"/>
           </a:solidFill>
           <a:ln>
-            <a:solidFill>
-              <a:srgbClr val="0A0A0F"/>
-            </a:solidFill>
+            <a:noFill/>
           </a:ln>
         </p:spPr>
         <p:style>
@@ -3147,14 +3146,14 @@
         </p:nvSpPr>
         <p:spPr>
           <a:xfrm>
-            <a:off x="731520" y="1097280"/>
-            <a:ext cx="3474720" cy="411480"/>
+            <a:off x="731520" y="822960"/>
+            <a:ext cx="3840480" cy="384048"/>
           </a:xfrm>
           <a:prstGeom prst="roundRect">
             <a:avLst/>
           </a:prstGeom>
           <a:solidFill>
-            <a:srgbClr val="161823"/>
+            <a:srgbClr val="141824"/>
           </a:solidFill>
           <a:ln>
             <a:solidFill>
@@ -3188,7 +3187,7 @@
               </a:defRPr>
             </a:pPr>
             <a:r>
-              <a:t>AUTONOMOUS AGENTIC PIPELINE</a:t>
+              <a:t>⚡ NEXT-GEN HACKATHON DEMO</a:t>
             </a:r>
           </a:p>
         </p:txBody>
@@ -3201,8 +3200,8 @@
         </p:nvSpPr>
         <p:spPr>
           <a:xfrm>
-            <a:off x="731520" y="1737360"/>
-            <a:ext cx="10515600" cy="1645920"/>
+            <a:off x="731520" y="1371600"/>
+            <a:ext cx="10698480" cy="2011680"/>
           </a:xfrm>
           <a:prstGeom prst="rect">
             <a:avLst/>
@@ -3210,46 +3209,310 @@
           <a:noFill/>
         </p:spPr>
         <p:txBody>
-          <a:bodyPr wrap="square">
+          <a:bodyPr wrap="square" lIns="0" tIns="0" rIns="0" bIns="0">
             <a:spAutoFit/>
           </a:bodyPr>
           <a:lstStyle/>
           <a:p>
             <a:pPr>
-              <a:defRPr sz="5600" b="1">
-                <a:solidFill>
-                  <a:srgbClr val="CCFF00"/>
-                </a:solidFill>
-              </a:defRPr>
-            </a:pPr>
-            <a:r>
-              <a:t>VIRALFLOW AI</a:t>
-            </a:r>
-          </a:p>
-          <a:p>
-            <a:pPr>
-              <a:defRPr sz="2400">
+              <a:defRPr sz="5400" b="1">
+                <a:solidFill>
+                  <a:srgbClr val="FFE600"/>
+                </a:solidFill>
+                <a:latin typeface="Segoe UI"/>
+              </a:defRPr>
+            </a:pPr>
+            <a:r>
+              <a:t>ViralFlow AI 2.0</a:t>
+            </a:r>
+          </a:p>
+          <a:p>
+            <a:pPr>
+              <a:spcBef>
+                <a:spcPts val="800"/>
+              </a:spcBef>
+              <a:defRPr sz="2400" b="1">
                 <a:solidFill>
                   <a:srgbClr val="FFFFFF"/>
                 </a:solidFill>
-              </a:defRPr>
-            </a:pPr>
-            <a:r>
-              <a:t>Self-Improving Multi-Agent Content Engine for Short-Form Video Creation</a:t>
-            </a:r>
-          </a:p>
-        </p:txBody>
-      </p:sp>
-      <p:sp>
-        <p:nvSpPr>
-          <p:cNvPr id="5" name="TextBox 4"/>
+                <a:latin typeface="Segoe UI"/>
+              </a:defRPr>
+            </a:pPr>
+            <a:r>
+              <a:t>Autonomous Multi-Agent Video Engine for Tech Creators</a:t>
+            </a:r>
+          </a:p>
+          <a:p>
+            <a:pPr>
+              <a:spcBef>
+                <a:spcPts val="800"/>
+              </a:spcBef>
+              <a:defRPr sz="1600">
+                <a:solidFill>
+                  <a:srgbClr val="94A3B8"/>
+                </a:solidFill>
+                <a:latin typeface="Segoe UI"/>
+              </a:defRPr>
+            </a:pPr>
+            <a:r>
+              <a:t>From live web &amp; social trends to a broadcast-ready 9:16 short-form video package in under 6 seconds.</a:t>
+            </a:r>
+          </a:p>
+        </p:txBody>
+      </p:sp>
+      <p:sp>
+        <p:nvSpPr>
+          <p:cNvPr id="5" name="Rounded Rectangle 4"/>
+          <p:cNvSpPr/>
+          <p:nvPr/>
+        </p:nvSpPr>
+        <p:spPr>
+          <a:xfrm>
+            <a:off x="731520" y="3840480"/>
+            <a:ext cx="3383280" cy="1645920"/>
+          </a:xfrm>
+          <a:prstGeom prst="roundRect">
+            <a:avLst/>
+          </a:prstGeom>
+          <a:solidFill>
+            <a:srgbClr val="141824"/>
+          </a:solidFill>
+          <a:ln>
+            <a:solidFill>
+              <a:srgbClr val="00F0FF"/>
+            </a:solidFill>
+          </a:ln>
+        </p:spPr>
+        <p:style>
+          <a:lnRef idx="1">
+            <a:schemeClr val="accent1"/>
+          </a:lnRef>
+          <a:fillRef idx="3">
+            <a:schemeClr val="accent1"/>
+          </a:fillRef>
+          <a:effectRef idx="2">
+            <a:schemeClr val="accent1"/>
+          </a:effectRef>
+          <a:fontRef idx="minor">
+            <a:schemeClr val="lt1"/>
+          </a:fontRef>
+        </p:style>
+        <p:txBody>
+          <a:bodyPr rtlCol="0" anchor="ctr" wrap="square"/>
+          <a:lstStyle/>
+          <a:p>
+            <a:pPr algn="ctr">
+              <a:defRPr sz="2200" b="1">
+                <a:solidFill>
+                  <a:srgbClr val="00F0FF"/>
+                </a:solidFill>
+              </a:defRPr>
+            </a:pPr>
+            <a:r>
+              <a:t>6 SECONDS</a:t>
+            </a:r>
+          </a:p>
+          <a:p>
+            <a:pPr>
+              <a:spcBef>
+                <a:spcPts val="400"/>
+              </a:spcBef>
+              <a:defRPr sz="1300" b="1">
+                <a:solidFill>
+                  <a:srgbClr val="FFFFFF"/>
+                </a:solidFill>
+              </a:defRPr>
+            </a:pPr>
+            <a:r>
+              <a:t>Autonomous Pipeline</a:t>
+            </a:r>
+          </a:p>
+          <a:p>
+            <a:pPr>
+              <a:defRPr sz="1100">
+                <a:solidFill>
+                  <a:srgbClr val="94A3B8"/>
+                </a:solidFill>
+              </a:defRPr>
+            </a:pPr>
+            <a:r>
+              <a:t>Zero manual timeline editing required</a:t>
+            </a:r>
+          </a:p>
+        </p:txBody>
+      </p:sp>
+      <p:sp>
+        <p:nvSpPr>
+          <p:cNvPr id="6" name="Rounded Rectangle 5"/>
+          <p:cNvSpPr/>
+          <p:nvPr/>
+        </p:nvSpPr>
+        <p:spPr>
+          <a:xfrm>
+            <a:off x="4389120" y="3840480"/>
+            <a:ext cx="3383280" cy="1645920"/>
+          </a:xfrm>
+          <a:prstGeom prst="roundRect">
+            <a:avLst/>
+          </a:prstGeom>
+          <a:solidFill>
+            <a:srgbClr val="141824"/>
+          </a:solidFill>
+          <a:ln>
+            <a:solidFill>
+              <a:srgbClr val="262E44"/>
+            </a:solidFill>
+          </a:ln>
+        </p:spPr>
+        <p:style>
+          <a:lnRef idx="1">
+            <a:schemeClr val="accent1"/>
+          </a:lnRef>
+          <a:fillRef idx="3">
+            <a:schemeClr val="accent1"/>
+          </a:fillRef>
+          <a:effectRef idx="2">
+            <a:schemeClr val="accent1"/>
+          </a:effectRef>
+          <a:fontRef idx="minor">
+            <a:schemeClr val="lt1"/>
+          </a:fontRef>
+        </p:style>
+        <p:txBody>
+          <a:bodyPr rtlCol="0" anchor="ctr" wrap="square"/>
+          <a:lstStyle/>
+          <a:p>
+            <a:pPr algn="ctr">
+              <a:defRPr sz="2200" b="1">
+                <a:solidFill>
+                  <a:srgbClr val="00FFA3"/>
+                </a:solidFill>
+              </a:defRPr>
+            </a:pPr>
+            <a:r>
+              <a:t>100% FACT-CHECKED</a:t>
+            </a:r>
+          </a:p>
+          <a:p>
+            <a:pPr>
+              <a:spcBef>
+                <a:spcPts val="400"/>
+              </a:spcBef>
+              <a:defRPr sz="1300" b="1">
+                <a:solidFill>
+                  <a:srgbClr val="FFFFFF"/>
+                </a:solidFill>
+              </a:defRPr>
+            </a:pPr>
+            <a:r>
+              <a:t>Anti-Hallucination</a:t>
+            </a:r>
+          </a:p>
+          <a:p>
+            <a:pPr>
+              <a:defRPr sz="1100">
+                <a:solidFill>
+                  <a:srgbClr val="94A3B8"/>
+                </a:solidFill>
+              </a:defRPr>
+            </a:pPr>
+            <a:r>
+              <a:t>Multi-pass verification guardrails</a:t>
+            </a:r>
+          </a:p>
+        </p:txBody>
+      </p:sp>
+      <p:sp>
+        <p:nvSpPr>
+          <p:cNvPr id="7" name="Rounded Rectangle 6"/>
+          <p:cNvSpPr/>
+          <p:nvPr/>
+        </p:nvSpPr>
+        <p:spPr>
+          <a:xfrm>
+            <a:off x="8046720" y="3840480"/>
+            <a:ext cx="3383280" cy="1645920"/>
+          </a:xfrm>
+          <a:prstGeom prst="roundRect">
+            <a:avLst/>
+          </a:prstGeom>
+          <a:solidFill>
+            <a:srgbClr val="141824"/>
+          </a:solidFill>
+          <a:ln>
+            <a:solidFill>
+              <a:srgbClr val="262E44"/>
+            </a:solidFill>
+          </a:ln>
+        </p:spPr>
+        <p:style>
+          <a:lnRef idx="1">
+            <a:schemeClr val="accent1"/>
+          </a:lnRef>
+          <a:fillRef idx="3">
+            <a:schemeClr val="accent1"/>
+          </a:fillRef>
+          <a:effectRef idx="2">
+            <a:schemeClr val="accent1"/>
+          </a:effectRef>
+          <a:fontRef idx="minor">
+            <a:schemeClr val="lt1"/>
+          </a:fontRef>
+        </p:style>
+        <p:txBody>
+          <a:bodyPr rtlCol="0" anchor="ctr" wrap="square"/>
+          <a:lstStyle/>
+          <a:p>
+            <a:pPr algn="ctr">
+              <a:defRPr sz="2200" b="1">
+                <a:solidFill>
+                  <a:srgbClr val="FFE600"/>
+                </a:solidFill>
+              </a:defRPr>
+            </a:pPr>
+            <a:r>
+              <a:t>FULL-STACK READY</a:t>
+            </a:r>
+          </a:p>
+          <a:p>
+            <a:pPr>
+              <a:spcBef>
+                <a:spcPts val="400"/>
+              </a:spcBef>
+              <a:defRPr sz="1300" b="1">
+                <a:solidFill>
+                  <a:srgbClr val="FFFFFF"/>
+                </a:solidFill>
+              </a:defRPr>
+            </a:pPr>
+            <a:r>
+              <a:t>Production Manifest</a:t>
+            </a:r>
+          </a:p>
+          <a:p>
+            <a:pPr>
+              <a:defRPr sz="1100">
+                <a:solidFill>
+                  <a:srgbClr val="94A3B8"/>
+                </a:solidFill>
+              </a:defRPr>
+            </a:pPr>
+            <a:r>
+              <a:t>Kinetic captions, HD B-roll &amp; audio</a:t>
+            </a:r>
+          </a:p>
+        </p:txBody>
+      </p:sp>
+      <p:sp>
+        <p:nvSpPr>
+          <p:cNvPr id="8" name="TextBox 7"/>
           <p:cNvSpPr txBox="1"/>
           <p:nvPr/>
         </p:nvSpPr>
         <p:spPr>
           <a:xfrm>
-            <a:off x="731520" y="3657600"/>
-            <a:ext cx="10058400" cy="1097280"/>
+            <a:off x="731520" y="5760720"/>
+            <a:ext cx="10698480" cy="548640"/>
           </a:xfrm>
           <a:prstGeom prst="rect">
             <a:avLst/>
@@ -3257,55 +3520,20 @@
           <a:noFill/>
         </p:spPr>
         <p:txBody>
-          <a:bodyPr wrap="square">
-            <a:spAutoFit/>
-          </a:bodyPr>
-          <a:lstStyle/>
-          <a:p>
-            <a:pPr>
-              <a:defRPr sz="1600">
-                <a:solidFill>
-                  <a:srgbClr val="A0A5B9"/>
-                </a:solidFill>
-              </a:defRPr>
-            </a:pPr>
-            <a:r>
-              <a:t>Automatically transforms live web and social trends into fully-rendered, fact-checked 9:16 vertical short-form videos for TikTok, YouTube Shorts, and Instagram Reels.</a:t>
-            </a:r>
-          </a:p>
-        </p:txBody>
-      </p:sp>
-      <p:sp>
-        <p:nvSpPr>
-          <p:cNvPr id="6" name="TextBox 5"/>
-          <p:cNvSpPr txBox="1"/>
-          <p:nvPr/>
-        </p:nvSpPr>
-        <p:spPr>
-          <a:xfrm>
-            <a:off x="731520" y="5303520"/>
-            <a:ext cx="10058400" cy="731520"/>
-          </a:xfrm>
-          <a:prstGeom prst="rect">
-            <a:avLst/>
-          </a:prstGeom>
-          <a:noFill/>
-        </p:spPr>
-        <p:txBody>
           <a:bodyPr wrap="none">
             <a:spAutoFit/>
           </a:bodyPr>
           <a:lstStyle/>
           <a:p>
             <a:pPr>
-              <a:defRPr sz="1400" b="1">
+              <a:defRPr sz="1300" b="1">
                 <a:solidFill>
                   <a:srgbClr val="00F0FF"/>
                 </a:solidFill>
               </a:defRPr>
             </a:pPr>
             <a:r>
-              <a:t>Live App: https://my-viralflow-ai.vercel.app  |  GitHub: Ibrahim2637/ViralFlow.Ai</a:t>
+              <a:t>🌐 Live App: https://my-viralflow-ai.vercel.app    |    💻 GitHub: Ibrahim2637/ViralFlow.Ai</a:t>
             </a:r>
           </a:p>
         </p:txBody>
@@ -3343,12 +3571,10 @@
             <a:avLst/>
           </a:prstGeom>
           <a:solidFill>
-            <a:srgbClr val="0A0A0F"/>
+            <a:srgbClr val="0A0C12"/>
           </a:solidFill>
           <a:ln>
-            <a:solidFill>
-              <a:srgbClr val="0A0A0F"/>
-            </a:solidFill>
+            <a:noFill/>
           </a:ln>
         </p:spPr>
         <p:style>
@@ -3382,7 +3608,7 @@
         <p:spPr>
           <a:xfrm>
             <a:off x="731520" y="365760"/>
-            <a:ext cx="10058400" cy="365760"/>
+            <a:ext cx="10698480" cy="320040"/>
           </a:xfrm>
           <a:prstGeom prst="rect">
             <a:avLst/>
@@ -3390,7 +3616,7 @@
           <a:noFill/>
         </p:spPr>
         <p:txBody>
-          <a:bodyPr wrap="none">
+          <a:bodyPr wrap="square" lIns="0" tIns="0" rIns="0" bIns="0">
             <a:spAutoFit/>
           </a:bodyPr>
           <a:lstStyle/>
@@ -3400,10 +3626,11 @@
                 <a:solidFill>
                   <a:srgbClr val="00F0FF"/>
                 </a:solidFill>
-              </a:defRPr>
-            </a:pPr>
-            <a:r>
-              <a:t>VIRALFLOW AI HACKATHON PRESENTATION</a:t>
+                <a:latin typeface="Segoe UI"/>
+              </a:defRPr>
+            </a:pPr>
+            <a:r>
+              <a:t>THE PROBLEM • MARKET PAIN</a:t>
             </a:r>
           </a:p>
         </p:txBody>
@@ -3416,8 +3643,8 @@
         </p:nvSpPr>
         <p:spPr>
           <a:xfrm>
-            <a:off x="731520" y="640080"/>
-            <a:ext cx="10058400" cy="731520"/>
+            <a:off x="731520" y="685800"/>
+            <a:ext cx="10698480" cy="594360"/>
           </a:xfrm>
           <a:prstGeom prst="rect">
             <a:avLst/>
@@ -3425,20 +3652,21 @@
           <a:noFill/>
         </p:spPr>
         <p:txBody>
-          <a:bodyPr wrap="none">
+          <a:bodyPr wrap="square" lIns="0" tIns="0" rIns="0" bIns="0">
             <a:spAutoFit/>
           </a:bodyPr>
           <a:lstStyle/>
           <a:p>
             <a:pPr>
-              <a:defRPr sz="2800" b="1">
+              <a:defRPr sz="2600" b="1">
                 <a:solidFill>
                   <a:srgbClr val="FFFFFF"/>
                 </a:solidFill>
-              </a:defRPr>
-            </a:pPr>
-            <a:r>
-              <a:t>THE PROBLEM: SHORT-FORM CONTENT BOTTLENECK</a:t>
+                <a:latin typeface="Segoe UI"/>
+              </a:defRPr>
+            </a:pPr>
+            <a:r>
+              <a:t>Why Creating Viral Content Is Broken</a:t>
             </a:r>
           </a:p>
         </p:txBody>
@@ -3452,17 +3680,17 @@
         <p:spPr>
           <a:xfrm>
             <a:off x="731520" y="1645920"/>
-            <a:ext cx="3291840" cy="4389120"/>
+            <a:ext cx="3383280" cy="4389120"/>
           </a:xfrm>
           <a:prstGeom prst="roundRect">
             <a:avLst/>
           </a:prstGeom>
           <a:solidFill>
-            <a:srgbClr val="161823"/>
+            <a:srgbClr val="141824"/>
           </a:solidFill>
           <a:ln>
             <a:solidFill>
-              <a:srgbClr val="282D41"/>
+              <a:srgbClr val="262E44"/>
             </a:solidFill>
           </a:ln>
         </p:spPr>
@@ -3485,27 +3713,59 @@
           <a:lstStyle/>
           <a:p>
             <a:pPr algn="ctr">
-              <a:defRPr sz="1800" b="1">
-                <a:solidFill>
-                  <a:srgbClr val="CCFF00"/>
-                </a:solidFill>
-              </a:defRPr>
-            </a:pPr>
-            <a:r>
-              <a:t>4-6 Hours Spent Per Video</a:t>
-            </a:r>
-          </a:p>
-          <a:p>
-            <a:br/>
-            <a:pPr>
-              <a:defRPr sz="1400">
-                <a:solidFill>
-                  <a:srgbClr val="A0A5B9"/>
-                </a:solidFill>
-              </a:defRPr>
-            </a:pPr>
-            <a:r>
-              <a:t>Creators and marketers waste hours daily researching trending topics, drafting scripts, and editing short-form timeline cuts.</a:t>
+              <a:defRPr sz="1000" b="1">
+                <a:solidFill>
+                  <a:srgbClr val="FFE600"/>
+                </a:solidFill>
+              </a:defRPr>
+            </a:pPr>
+            <a:r>
+              <a:t>MANUAL EDITING BOTTLENECK</a:t>
+            </a:r>
+          </a:p>
+          <a:p>
+            <a:pPr>
+              <a:spcBef>
+                <a:spcPts val="400"/>
+              </a:spcBef>
+              <a:defRPr sz="1700" b="1">
+                <a:solidFill>
+                  <a:srgbClr val="FFFFFF"/>
+                </a:solidFill>
+              </a:defRPr>
+            </a:pPr>
+            <a:r>
+              <a:t>⏳ 4 to 6 Hours Wasted Per Video</a:t>
+            </a:r>
+          </a:p>
+          <a:p>
+            <a:pPr>
+              <a:spcBef>
+                <a:spcPts val="1200"/>
+              </a:spcBef>
+              <a:defRPr sz="1300">
+                <a:solidFill>
+                  <a:srgbClr val="94A3B8"/>
+                </a:solidFill>
+              </a:defRPr>
+            </a:pPr>
+            <a:r>
+              <a:t>Creators waste hours daily scrolling for trending topics, writing hooks, splicing B-roll footage, and manually adjusting subtitle timings in Premiere or CapCut.</a:t>
+            </a:r>
+          </a:p>
+          <a:p>
+            <a:pPr>
+              <a:spcBef>
+                <a:spcPts val="1400"/>
+              </a:spcBef>
+              <a:defRPr sz="1200" b="1">
+                <a:solidFill>
+                  <a:srgbClr val="00F0FF"/>
+                </a:solidFill>
+              </a:defRPr>
+            </a:pPr>
+            <a:r>
+              <a:t>⚡ Result: Inability to post daily, falling behind the algorithm.</a:t>
             </a:r>
           </a:p>
         </p:txBody>
@@ -3518,18 +3778,18 @@
         </p:nvSpPr>
         <p:spPr>
           <a:xfrm>
-            <a:off x="4297680" y="1645920"/>
-            <a:ext cx="3291840" cy="4389120"/>
+            <a:off x="4389120" y="1645920"/>
+            <a:ext cx="3383280" cy="4389120"/>
           </a:xfrm>
           <a:prstGeom prst="roundRect">
             <a:avLst/>
           </a:prstGeom>
           <a:solidFill>
-            <a:srgbClr val="161823"/>
+            <a:srgbClr val="141824"/>
           </a:solidFill>
           <a:ln>
             <a:solidFill>
-              <a:srgbClr val="282D41"/>
+              <a:srgbClr val="262E44"/>
             </a:solidFill>
           </a:ln>
         </p:spPr>
@@ -3552,27 +3812,59 @@
           <a:lstStyle/>
           <a:p>
             <a:pPr algn="ctr">
-              <a:defRPr sz="1800" b="1">
-                <a:solidFill>
-                  <a:srgbClr val="CCFF00"/>
-                </a:solidFill>
-              </a:defRPr>
-            </a:pPr>
-            <a:r>
-              <a:t>AI Hallucination and Risk</a:t>
-            </a:r>
-          </a:p>
-          <a:p>
-            <a:br/>
-            <a:pPr>
-              <a:defRPr sz="1400">
-                <a:solidFill>
-                  <a:srgbClr val="A0A5B9"/>
-                </a:solidFill>
-              </a:defRPr>
-            </a:pPr>
-            <a:r>
-              <a:t>Generic AI script tools output unverified numbers, fake guarantees, and high-risk claims that ruin brand reputation.</a:t>
+              <a:defRPr sz="1000" b="1">
+                <a:solidFill>
+                  <a:srgbClr val="FFE600"/>
+                </a:solidFill>
+              </a:defRPr>
+            </a:pPr>
+            <a:r>
+              <a:t>ACCURACY CRISIS</a:t>
+            </a:r>
+          </a:p>
+          <a:p>
+            <a:pPr>
+              <a:spcBef>
+                <a:spcPts val="400"/>
+              </a:spcBef>
+              <a:defRPr sz="1700" b="1">
+                <a:solidFill>
+                  <a:srgbClr val="FFFFFF"/>
+                </a:solidFill>
+              </a:defRPr>
+            </a:pPr>
+            <a:r>
+              <a:t>⚠️ AI Hallucinations &amp; Reputational Risk</a:t>
+            </a:r>
+          </a:p>
+          <a:p>
+            <a:pPr>
+              <a:spcBef>
+                <a:spcPts val="1200"/>
+              </a:spcBef>
+              <a:defRPr sz="1300">
+                <a:solidFill>
+                  <a:srgbClr val="94A3B8"/>
+                </a:solidFill>
+              </a:defRPr>
+            </a:pPr>
+            <a:r>
+              <a:t>Generic AI tools generate fake statistics, out-of-date news, and fabricated claims that destroy creator credibility and brand trust in developer communities.</a:t>
+            </a:r>
+          </a:p>
+          <a:p>
+            <a:pPr>
+              <a:spcBef>
+                <a:spcPts val="1400"/>
+              </a:spcBef>
+              <a:defRPr sz="1200" b="1">
+                <a:solidFill>
+                  <a:srgbClr val="00F0FF"/>
+                </a:solidFill>
+              </a:defRPr>
+            </a:pPr>
+            <a:r>
+              <a:t>⚡ Result: Creators spend more time fact-checking than creating.</a:t>
             </a:r>
           </a:p>
         </p:txBody>
@@ -3585,18 +3877,18 @@
         </p:nvSpPr>
         <p:spPr>
           <a:xfrm>
-            <a:off x="7863840" y="1645920"/>
-            <a:ext cx="3291840" cy="4389120"/>
+            <a:off x="8046720" y="1645920"/>
+            <a:ext cx="3383280" cy="4389120"/>
           </a:xfrm>
           <a:prstGeom prst="roundRect">
             <a:avLst/>
           </a:prstGeom>
           <a:solidFill>
-            <a:srgbClr val="161823"/>
+            <a:srgbClr val="141824"/>
           </a:solidFill>
           <a:ln>
             <a:solidFill>
-              <a:srgbClr val="282D41"/>
+              <a:srgbClr val="262E44"/>
             </a:solidFill>
           </a:ln>
         </p:spPr>
@@ -3619,27 +3911,59 @@
           <a:lstStyle/>
           <a:p>
             <a:pPr algn="ctr">
-              <a:defRPr sz="1800" b="1">
-                <a:solidFill>
-                  <a:srgbClr val="CCFF00"/>
-                </a:solidFill>
-              </a:defRPr>
-            </a:pPr>
-            <a:r>
-              <a:t>Creator Burnout</a:t>
-            </a:r>
-          </a:p>
-          <a:p>
-            <a:br/>
-            <a:pPr>
-              <a:defRPr sz="1400">
-                <a:solidFill>
-                  <a:srgbClr val="A0A5B9"/>
-                </a:solidFill>
-              </a:defRPr>
-            </a:pPr>
-            <a:r>
-              <a:t>Maintaining daily 9:16 vertical video output across TikTok, Shorts, and Reels is exhausting, causing content drop-off.</a:t>
+              <a:defRPr sz="1000" b="1">
+                <a:solidFill>
+                  <a:srgbClr val="FFE600"/>
+                </a:solidFill>
+              </a:defRPr>
+            </a:pPr>
+            <a:r>
+              <a:t>ALGORITHM CHURN</a:t>
+            </a:r>
+          </a:p>
+          <a:p>
+            <a:pPr>
+              <a:spcBef>
+                <a:spcPts val="400"/>
+              </a:spcBef>
+              <a:defRPr sz="1700" b="1">
+                <a:solidFill>
+                  <a:srgbClr val="FFFFFF"/>
+                </a:solidFill>
+              </a:defRPr>
+            </a:pPr>
+            <a:r>
+              <a:t>🔥 Inconsistent Hook Velocity &amp; Burnout</a:t>
+            </a:r>
+          </a:p>
+          <a:p>
+            <a:pPr>
+              <a:spcBef>
+                <a:spcPts val="1200"/>
+              </a:spcBef>
+              <a:defRPr sz="1300">
+                <a:solidFill>
+                  <a:srgbClr val="94A3B8"/>
+                </a:solidFill>
+              </a:defRPr>
+            </a:pPr>
+            <a:r>
+              <a:t>90% of video viewers drop off in the first 2 seconds. Crafting retention-engineered hooks with kinetic motion design consistently is impossible for solo builders.</a:t>
+            </a:r>
+          </a:p>
+          <a:p>
+            <a:pPr>
+              <a:spcBef>
+                <a:spcPts val="1400"/>
+              </a:spcBef>
+              <a:defRPr sz="1200" b="1">
+                <a:solidFill>
+                  <a:srgbClr val="00F0FF"/>
+                </a:solidFill>
+              </a:defRPr>
+            </a:pPr>
+            <a:r>
+              <a:t>⚡ Result: 82% creator burnout rate within their first 6 months.</a:t>
             </a:r>
           </a:p>
         </p:txBody>
@@ -3677,12 +4001,10 @@
             <a:avLst/>
           </a:prstGeom>
           <a:solidFill>
-            <a:srgbClr val="0A0A0F"/>
+            <a:srgbClr val="0A0C12"/>
           </a:solidFill>
           <a:ln>
-            <a:solidFill>
-              <a:srgbClr val="0A0A0F"/>
-            </a:solidFill>
+            <a:noFill/>
           </a:ln>
         </p:spPr>
         <p:style>
@@ -3716,7 +4038,7 @@
         <p:spPr>
           <a:xfrm>
             <a:off x="731520" y="365760"/>
-            <a:ext cx="10058400" cy="365760"/>
+            <a:ext cx="10698480" cy="320040"/>
           </a:xfrm>
           <a:prstGeom prst="rect">
             <a:avLst/>
@@ -3724,7 +4046,7 @@
           <a:noFill/>
         </p:spPr>
         <p:txBody>
-          <a:bodyPr wrap="none">
+          <a:bodyPr wrap="square" lIns="0" tIns="0" rIns="0" bIns="0">
             <a:spAutoFit/>
           </a:bodyPr>
           <a:lstStyle/>
@@ -3734,10 +4056,11 @@
                 <a:solidFill>
                   <a:srgbClr val="00F0FF"/>
                 </a:solidFill>
-              </a:defRPr>
-            </a:pPr>
-            <a:r>
-              <a:t>VIRALFLOW AI HACKATHON PRESENTATION</a:t>
+                <a:latin typeface="Segoe UI"/>
+              </a:defRPr>
+            </a:pPr>
+            <a:r>
+              <a:t>THE SOLUTION • MULTI-AGENT SWARM</a:t>
             </a:r>
           </a:p>
         </p:txBody>
@@ -3750,8 +4073,8 @@
         </p:nvSpPr>
         <p:spPr>
           <a:xfrm>
-            <a:off x="731520" y="640080"/>
-            <a:ext cx="10058400" cy="731520"/>
+            <a:off x="731520" y="685800"/>
+            <a:ext cx="10698480" cy="594360"/>
           </a:xfrm>
           <a:prstGeom prst="rect">
             <a:avLst/>
@@ -3759,20 +4082,21 @@
           <a:noFill/>
         </p:spPr>
         <p:txBody>
-          <a:bodyPr wrap="none">
+          <a:bodyPr wrap="square" lIns="0" tIns="0" rIns="0" bIns="0">
             <a:spAutoFit/>
           </a:bodyPr>
           <a:lstStyle/>
           <a:p>
             <a:pPr>
-              <a:defRPr sz="2800" b="1">
+              <a:defRPr sz="2600" b="1">
                 <a:solidFill>
                   <a:srgbClr val="FFFFFF"/>
                 </a:solidFill>
-              </a:defRPr>
-            </a:pPr>
-            <a:r>
-              <a:t>THE SOLUTION: VIRALFLOW AI</a:t>
+                <a:latin typeface="Segoe UI"/>
+              </a:defRPr>
+            </a:pPr>
+            <a:r>
+              <a:t>ViralFlow AI: Autonomous Content Intelligence</a:t>
             </a:r>
           </a:p>
         </p:txBody>
@@ -3786,13 +4110,211 @@
         <p:spPr>
           <a:xfrm>
             <a:off x="731520" y="1645920"/>
-            <a:ext cx="3291840" cy="4389120"/>
+            <a:ext cx="2560320" cy="4389120"/>
           </a:xfrm>
           <a:prstGeom prst="roundRect">
             <a:avLst/>
           </a:prstGeom>
           <a:solidFill>
-            <a:srgbClr val="161823"/>
+            <a:srgbClr val="141824"/>
+          </a:solidFill>
+          <a:ln>
+            <a:solidFill>
+              <a:srgbClr val="262E44"/>
+            </a:solidFill>
+          </a:ln>
+        </p:spPr>
+        <p:style>
+          <a:lnRef idx="1">
+            <a:schemeClr val="accent1"/>
+          </a:lnRef>
+          <a:fillRef idx="3">
+            <a:schemeClr val="accent1"/>
+          </a:fillRef>
+          <a:effectRef idx="2">
+            <a:schemeClr val="accent1"/>
+          </a:effectRef>
+          <a:fontRef idx="minor">
+            <a:schemeClr val="lt1"/>
+          </a:fontRef>
+        </p:style>
+        <p:txBody>
+          <a:bodyPr rtlCol="0" anchor="ctr" wrap="square"/>
+          <a:lstStyle/>
+          <a:p>
+            <a:pPr algn="ctr">
+              <a:defRPr sz="1400" b="1">
+                <a:solidFill>
+                  <a:srgbClr val="00F0FF"/>
+                </a:solidFill>
+              </a:defRPr>
+            </a:pPr>
+            <a:r>
+              <a:t>1. SCOUT AGENT</a:t>
+            </a:r>
+          </a:p>
+          <a:p>
+            <a:pPr>
+              <a:spcBef>
+                <a:spcPts val="400"/>
+              </a:spcBef>
+              <a:defRPr sz="1500" b="1">
+                <a:solidFill>
+                  <a:srgbClr val="FFFFFF"/>
+                </a:solidFill>
+              </a:defRPr>
+            </a:pPr>
+            <a:r>
+              <a:t>Trend Radar &amp; Scoring</a:t>
+            </a:r>
+          </a:p>
+          <a:p>
+            <a:pPr>
+              <a:spcBef>
+                <a:spcPts val="800"/>
+              </a:spcBef>
+              <a:defRPr sz="1000" b="1">
+                <a:solidFill>
+                  <a:srgbClr val="FFE600"/>
+                </a:solidFill>
+              </a:defRPr>
+            </a:pPr>
+            <a:r>
+              <a:t>● Autonomous Web &amp; Social Signals</a:t>
+            </a:r>
+          </a:p>
+          <a:p>
+            <a:pPr>
+              <a:spcBef>
+                <a:spcPts val="1000"/>
+              </a:spcBef>
+              <a:defRPr sz="1200">
+                <a:solidFill>
+                  <a:srgbClr val="94A3B8"/>
+                </a:solidFill>
+              </a:defRPr>
+            </a:pPr>
+            <a:r>
+              <a:t>Continuously scans real-time tech queries and social velocity to identify high-potential opportunity topics with proven audience search demand.</a:t>
+            </a:r>
+          </a:p>
+        </p:txBody>
+      </p:sp>
+      <p:sp>
+        <p:nvSpPr>
+          <p:cNvPr id="6" name="Rounded Rectangle 5"/>
+          <p:cNvSpPr/>
+          <p:nvPr/>
+        </p:nvSpPr>
+        <p:spPr>
+          <a:xfrm>
+            <a:off x="3456432" y="1645920"/>
+            <a:ext cx="2560320" cy="4389120"/>
+          </a:xfrm>
+          <a:prstGeom prst="roundRect">
+            <a:avLst/>
+          </a:prstGeom>
+          <a:solidFill>
+            <a:srgbClr val="141824"/>
+          </a:solidFill>
+          <a:ln>
+            <a:solidFill>
+              <a:srgbClr val="262E44"/>
+            </a:solidFill>
+          </a:ln>
+        </p:spPr>
+        <p:style>
+          <a:lnRef idx="1">
+            <a:schemeClr val="accent1"/>
+          </a:lnRef>
+          <a:fillRef idx="3">
+            <a:schemeClr val="accent1"/>
+          </a:fillRef>
+          <a:effectRef idx="2">
+            <a:schemeClr val="accent1"/>
+          </a:effectRef>
+          <a:fontRef idx="minor">
+            <a:schemeClr val="lt1"/>
+          </a:fontRef>
+        </p:style>
+        <p:txBody>
+          <a:bodyPr rtlCol="0" anchor="ctr" wrap="square"/>
+          <a:lstStyle/>
+          <a:p>
+            <a:pPr algn="ctr">
+              <a:defRPr sz="1400" b="1">
+                <a:solidFill>
+                  <a:srgbClr val="00F0FF"/>
+                </a:solidFill>
+              </a:defRPr>
+            </a:pPr>
+            <a:r>
+              <a:t>2. STRATEGY AGENT</a:t>
+            </a:r>
+          </a:p>
+          <a:p>
+            <a:pPr>
+              <a:spcBef>
+                <a:spcPts val="400"/>
+              </a:spcBef>
+              <a:defRPr sz="1500" b="1">
+                <a:solidFill>
+                  <a:srgbClr val="FFFFFF"/>
+                </a:solidFill>
+              </a:defRPr>
+            </a:pPr>
+            <a:r>
+              <a:t>Creator DNA &amp; Hooks</a:t>
+            </a:r>
+          </a:p>
+          <a:p>
+            <a:pPr>
+              <a:spcBef>
+                <a:spcPts val="800"/>
+              </a:spcBef>
+              <a:defRPr sz="1000" b="1">
+                <a:solidFill>
+                  <a:srgbClr val="FFE600"/>
+                </a:solidFill>
+              </a:defRPr>
+            </a:pPr>
+            <a:r>
+              <a:t>● Personalized Voice &amp; Retention</a:t>
+            </a:r>
+          </a:p>
+          <a:p>
+            <a:pPr>
+              <a:spcBef>
+                <a:spcPts val="1000"/>
+              </a:spcBef>
+              <a:defRPr sz="1200">
+                <a:solidFill>
+                  <a:srgbClr val="94A3B8"/>
+                </a:solidFill>
+              </a:defRPr>
+            </a:pPr>
+            <a:r>
+              <a:t>Synthesizes pattern-interrupt hooks based on the creator's exact tone, vocabulary, and audience persona to ensure high viewer retention.</a:t>
+            </a:r>
+          </a:p>
+        </p:txBody>
+      </p:sp>
+      <p:sp>
+        <p:nvSpPr>
+          <p:cNvPr id="7" name="Rounded Rectangle 6"/>
+          <p:cNvSpPr/>
+          <p:nvPr/>
+        </p:nvSpPr>
+        <p:spPr>
+          <a:xfrm>
+            <a:off x="6181344" y="1645920"/>
+            <a:ext cx="2560320" cy="4389120"/>
+          </a:xfrm>
+          <a:prstGeom prst="roundRect">
+            <a:avLst/>
+          </a:prstGeom>
+          <a:solidFill>
+            <a:srgbClr val="141824"/>
           </a:solidFill>
           <a:ln>
             <a:solidFill>
@@ -3819,51 +4341,83 @@
           <a:lstStyle/>
           <a:p>
             <a:pPr algn="ctr">
-              <a:defRPr sz="1800" b="1">
-                <a:solidFill>
-                  <a:srgbClr val="00F0FF"/>
-                </a:solidFill>
-              </a:defRPr>
-            </a:pPr>
-            <a:r>
-              <a:t>Creator DNA Engine</a:t>
-            </a:r>
-          </a:p>
-          <a:p>
-            <a:br/>
-            <a:pPr>
-              <a:defRPr sz="1400">
+              <a:defRPr sz="1400" b="1">
+                <a:solidFill>
+                  <a:srgbClr val="00FFA3"/>
+                </a:solidFill>
+              </a:defRPr>
+            </a:pPr>
+            <a:r>
+              <a:t>3. GUARDRAIL AGENT</a:t>
+            </a:r>
+          </a:p>
+          <a:p>
+            <a:pPr>
+              <a:spcBef>
+                <a:spcPts val="400"/>
+              </a:spcBef>
+              <a:defRPr sz="1500" b="1">
                 <a:solidFill>
                   <a:srgbClr val="FFFFFF"/>
                 </a:solidFill>
               </a:defRPr>
             </a:pPr>
             <a:r>
-              <a:t>Learns audience demographics, creator tone, vocabulary, and proven hook patterns for strict brand voice alignment.</a:t>
-            </a:r>
-          </a:p>
-        </p:txBody>
-      </p:sp>
-      <p:sp>
-        <p:nvSpPr>
-          <p:cNvPr id="6" name="Rounded Rectangle 5"/>
+              <a:t>Verification &amp; Fact-Check</a:t>
+            </a:r>
+          </a:p>
+          <a:p>
+            <a:pPr>
+              <a:spcBef>
+                <a:spcPts val="800"/>
+              </a:spcBef>
+              <a:defRPr sz="1000" b="1">
+                <a:solidFill>
+                  <a:srgbClr val="FFE600"/>
+                </a:solidFill>
+              </a:defRPr>
+            </a:pPr>
+            <a:r>
+              <a:t>● Zero-Tolerance Hallucination Check</a:t>
+            </a:r>
+          </a:p>
+          <a:p>
+            <a:pPr>
+              <a:spcBef>
+                <a:spcPts val="1000"/>
+              </a:spcBef>
+              <a:defRPr sz="1200">
+                <a:solidFill>
+                  <a:srgbClr val="94A3B8"/>
+                </a:solidFill>
+              </a:defRPr>
+            </a:pPr>
+            <a:r>
+              <a:t>Audits every numerical claim, technology comparison, and temporal stat against verified web knowledge before entering production.</a:t>
+            </a:r>
+          </a:p>
+        </p:txBody>
+      </p:sp>
+      <p:sp>
+        <p:nvSpPr>
+          <p:cNvPr id="8" name="Rounded Rectangle 7"/>
           <p:cNvSpPr/>
           <p:nvPr/>
         </p:nvSpPr>
         <p:spPr>
           <a:xfrm>
-            <a:off x="4297680" y="1645920"/>
-            <a:ext cx="3291840" cy="4389120"/>
+            <a:off x="8906256" y="1645920"/>
+            <a:ext cx="2560320" cy="4389120"/>
           </a:xfrm>
           <a:prstGeom prst="roundRect">
             <a:avLst/>
           </a:prstGeom>
           <a:solidFill>
-            <a:srgbClr val="161823"/>
+            <a:srgbClr val="141824"/>
           </a:solidFill>
           <a:ln>
             <a:solidFill>
-              <a:srgbClr val="00F0FF"/>
+              <a:srgbClr val="262E44"/>
             </a:solidFill>
           </a:ln>
         </p:spPr>
@@ -3886,94 +4440,59 @@
           <a:lstStyle/>
           <a:p>
             <a:pPr algn="ctr">
-              <a:defRPr sz="1800" b="1">
+              <a:defRPr sz="1400" b="1">
                 <a:solidFill>
                   <a:srgbClr val="00F0FF"/>
                 </a:solidFill>
               </a:defRPr>
             </a:pPr>
             <a:r>
-              <a:t>Factual Guardrail Queue</a:t>
-            </a:r>
-          </a:p>
-          <a:p>
-            <a:br/>
-            <a:pPr>
-              <a:defRPr sz="1400">
+              <a:t>4. RENDER AGENT</a:t>
+            </a:r>
+          </a:p>
+          <a:p>
+            <a:pPr>
+              <a:spcBef>
+                <a:spcPts val="400"/>
+              </a:spcBef>
+              <a:defRPr sz="1500" b="1">
                 <a:solidFill>
                   <a:srgbClr val="FFFFFF"/>
                 </a:solidFill>
               </a:defRPr>
             </a:pPr>
             <a:r>
-              <a:t>Audits every generated claim for numerical accuracy and time-sensitivity before video compilation.</a:t>
-            </a:r>
-          </a:p>
-        </p:txBody>
-      </p:sp>
-      <p:sp>
-        <p:nvSpPr>
-          <p:cNvPr id="7" name="Rounded Rectangle 6"/>
-          <p:cNvSpPr/>
-          <p:nvPr/>
-        </p:nvSpPr>
-        <p:spPr>
-          <a:xfrm>
-            <a:off x="7863840" y="1645920"/>
-            <a:ext cx="3291840" cy="4389120"/>
-          </a:xfrm>
-          <a:prstGeom prst="roundRect">
-            <a:avLst/>
-          </a:prstGeom>
-          <a:solidFill>
-            <a:srgbClr val="161823"/>
-          </a:solidFill>
-          <a:ln>
-            <a:solidFill>
-              <a:srgbClr val="00F0FF"/>
-            </a:solidFill>
-          </a:ln>
-        </p:spPr>
-        <p:style>
-          <a:lnRef idx="1">
-            <a:schemeClr val="accent1"/>
-          </a:lnRef>
-          <a:fillRef idx="3">
-            <a:schemeClr val="accent1"/>
-          </a:fillRef>
-          <a:effectRef idx="2">
-            <a:schemeClr val="accent1"/>
-          </a:effectRef>
-          <a:fontRef idx="minor">
-            <a:schemeClr val="lt1"/>
-          </a:fontRef>
-        </p:style>
-        <p:txBody>
-          <a:bodyPr rtlCol="0" anchor="ctr" wrap="square"/>
-          <a:lstStyle/>
-          <a:p>
-            <a:pPr algn="ctr">
-              <a:defRPr sz="1800" b="1">
-                <a:solidFill>
-                  <a:srgbClr val="00F0FF"/>
-                </a:solidFill>
-              </a:defRPr>
-            </a:pPr>
-            <a:r>
-              <a:t>9:16 Vertical Video Renderer</a:t>
-            </a:r>
-          </a:p>
-          <a:p>
-            <a:br/>
-            <a:pPr>
-              <a:defRPr sz="1400">
-                <a:solidFill>
-                  <a:srgbClr val="FFFFFF"/>
-                </a:solidFill>
-              </a:defRPr>
-            </a:pPr>
-            <a:r>
-              <a:t>Combines ElevenLabs AI voiceover, Pexels portrait B-roll, and Shotstack MP4 video compilation automatically.</a:t>
+              <a:t>Motion Graphics Pipeline</a:t>
+            </a:r>
+          </a:p>
+          <a:p>
+            <a:pPr>
+              <a:spcBef>
+                <a:spcPts val="800"/>
+              </a:spcBef>
+              <a:defRPr sz="1000" b="1">
+                <a:solidFill>
+                  <a:srgbClr val="FFE600"/>
+                </a:solidFill>
+              </a:defRPr>
+            </a:pPr>
+            <a:r>
+              <a:t>● Full 9:16 Video Synthesis</a:t>
+            </a:r>
+          </a:p>
+          <a:p>
+            <a:pPr>
+              <a:spcBef>
+                <a:spcPts val="1000"/>
+              </a:spcBef>
+              <a:defRPr sz="1200">
+                <a:solidFill>
+                  <a:srgbClr val="94A3B8"/>
+                </a:solidFill>
+              </a:defRPr>
+            </a:pPr>
+            <a:r>
+              <a:t>Ranks vertical HD B-roll, overlays kinetic bounce captions, top progress bar, tech HUD frame, and generates speech audio via ElevenLabs.</a:t>
             </a:r>
           </a:p>
         </p:txBody>
@@ -4011,12 +4530,10 @@
             <a:avLst/>
           </a:prstGeom>
           <a:solidFill>
-            <a:srgbClr val="0A0A0F"/>
+            <a:srgbClr val="0A0C12"/>
           </a:solidFill>
           <a:ln>
-            <a:solidFill>
-              <a:srgbClr val="0A0A0F"/>
-            </a:solidFill>
+            <a:noFill/>
           </a:ln>
         </p:spPr>
         <p:style>
@@ -4050,7 +4567,7 @@
         <p:spPr>
           <a:xfrm>
             <a:off x="731520" y="365760"/>
-            <a:ext cx="10058400" cy="365760"/>
+            <a:ext cx="10698480" cy="320040"/>
           </a:xfrm>
           <a:prstGeom prst="rect">
             <a:avLst/>
@@ -4058,7 +4575,7 @@
           <a:noFill/>
         </p:spPr>
         <p:txBody>
-          <a:bodyPr wrap="none">
+          <a:bodyPr wrap="square" lIns="0" tIns="0" rIns="0" bIns="0">
             <a:spAutoFit/>
           </a:bodyPr>
           <a:lstStyle/>
@@ -4068,10 +4585,11 @@
                 <a:solidFill>
                   <a:srgbClr val="00F0FF"/>
                 </a:solidFill>
-              </a:defRPr>
-            </a:pPr>
-            <a:r>
-              <a:t>VIRALFLOW AI HACKATHON PRESENTATION</a:t>
+                <a:latin typeface="Segoe UI"/>
+              </a:defRPr>
+            </a:pPr>
+            <a:r>
+              <a:t>SYSTEM ARCHITECTURE • ENGINE</a:t>
             </a:r>
           </a:p>
         </p:txBody>
@@ -4084,8 +4602,8 @@
         </p:nvSpPr>
         <p:spPr>
           <a:xfrm>
-            <a:off x="731520" y="640080"/>
-            <a:ext cx="10058400" cy="731520"/>
+            <a:off x="731520" y="685800"/>
+            <a:ext cx="10698480" cy="594360"/>
           </a:xfrm>
           <a:prstGeom prst="rect">
             <a:avLst/>
@@ -4093,20 +4611,21 @@
           <a:noFill/>
         </p:spPr>
         <p:txBody>
-          <a:bodyPr wrap="none">
+          <a:bodyPr wrap="square" lIns="0" tIns="0" rIns="0" bIns="0">
             <a:spAutoFit/>
           </a:bodyPr>
           <a:lstStyle/>
           <a:p>
             <a:pPr>
-              <a:defRPr sz="2800" b="1">
+              <a:defRPr sz="2600" b="1">
                 <a:solidFill>
                   <a:srgbClr val="FFFFFF"/>
                 </a:solidFill>
-              </a:defRPr>
-            </a:pPr>
-            <a:r>
-              <a:t>TECHNICAL ARCHITECTURE AND AGENT PIPELINE</a:t>
+                <a:latin typeface="Segoe UI"/>
+              </a:defRPr>
+            </a:pPr>
+            <a:r>
+              <a:t>Production-Grade Orchestration &amp; Stack</a:t>
             </a:r>
           </a:p>
         </p:txBody>
@@ -4120,17 +4639,17 @@
         <p:spPr>
           <a:xfrm>
             <a:off x="731520" y="1645920"/>
-            <a:ext cx="10698480" cy="1005840"/>
+            <a:ext cx="10698480" cy="987552"/>
           </a:xfrm>
           <a:prstGeom prst="roundRect">
             <a:avLst/>
           </a:prstGeom>
           <a:solidFill>
-            <a:srgbClr val="161823"/>
+            <a:srgbClr val="141824"/>
           </a:solidFill>
           <a:ln>
             <a:solidFill>
-              <a:srgbClr val="282D41"/>
+              <a:srgbClr val="262E44"/>
             </a:solidFill>
           </a:ln>
         </p:spPr>
@@ -4153,22 +4672,29 @@
           <a:lstStyle/>
           <a:p>
             <a:pPr algn="ctr">
-              <a:defRPr sz="1600" b="1">
-                <a:solidFill>
-                  <a:srgbClr val="CCFF00"/>
-                </a:solidFill>
-              </a:defRPr>
-            </a:pPr>
-            <a:r>
-              <a:t>1. Frontend and Studio: </a:t>
-            </a:r>
-            <a:r>
-              <a:rPr sz="1400" b="0">
+              <a:defRPr sz="1400" b="1">
+                <a:solidFill>
+                  <a:srgbClr val="00F0FF"/>
+                </a:solidFill>
+              </a:defRPr>
+            </a:pPr>
+            <a:r>
+              <a:t>LAYER 01: Frontend Studio (Next.js 16 + React 19)</a:t>
+            </a:r>
+          </a:p>
+          <a:p>
+            <a:pPr>
+              <a:spcBef>
+                <a:spcPts val="300"/>
+              </a:spcBef>
+              <a:defRPr sz="1200">
                 <a:solidFill>
                   <a:srgbClr val="FFFFFF"/>
                 </a:solidFill>
-              </a:rPr>
-              <a:t>Next.js 16 (Turbopack, App Router), TypeScript, Tailwind CSS, HTML5 9:16 Video Player</a:t>
+              </a:defRPr>
+            </a:pPr>
+            <a:r>
+              <a:t>Turbopack, Tailwind CSS, TypeScript, and Native HTML5 Motion Graphics Player with real-time HUD tech frame, kinetic pop subtitles, and scene B-roll preview.</a:t>
             </a:r>
           </a:p>
         </p:txBody>
@@ -4181,18 +4707,18 @@
         </p:nvSpPr>
         <p:spPr>
           <a:xfrm>
-            <a:off x="731520" y="2834640"/>
-            <a:ext cx="10698480" cy="1005840"/>
+            <a:off x="731520" y="2788920"/>
+            <a:ext cx="10698480" cy="987552"/>
           </a:xfrm>
           <a:prstGeom prst="roundRect">
             <a:avLst/>
           </a:prstGeom>
           <a:solidFill>
-            <a:srgbClr val="161823"/>
+            <a:srgbClr val="141824"/>
           </a:solidFill>
           <a:ln>
             <a:solidFill>
-              <a:srgbClr val="282D41"/>
+              <a:srgbClr val="262E44"/>
             </a:solidFill>
           </a:ln>
         </p:spPr>
@@ -4215,22 +4741,29 @@
           <a:lstStyle/>
           <a:p>
             <a:pPr algn="ctr">
-              <a:defRPr sz="1600" b="1">
-                <a:solidFill>
-                  <a:srgbClr val="CCFF00"/>
-                </a:solidFill>
-              </a:defRPr>
-            </a:pPr>
-            <a:r>
-              <a:t>2. Multi-Agent Engine: </a:t>
-            </a:r>
-            <a:r>
-              <a:rPr sz="1400" b="0">
+              <a:defRPr sz="1400" b="1">
+                <a:solidFill>
+                  <a:srgbClr val="00F0FF"/>
+                </a:solidFill>
+              </a:defRPr>
+            </a:pPr>
+            <a:r>
+              <a:t>LAYER 02: n8n Workflow Engine (Railway Public Webhook)</a:t>
+            </a:r>
+          </a:p>
+          <a:p>
+            <a:pPr>
+              <a:spcBef>
+                <a:spcPts val="300"/>
+              </a:spcBef>
+              <a:defRPr sz="1200">
                 <a:solidFill>
                   <a:srgbClr val="FFFFFF"/>
                 </a:solidFill>
-              </a:rPr>
-              <a:t>Google Gemini 3.6 Flash and OpenRouter (GPT-4o-mini) for trend scoring, script writing, and fact checking</a:t>
+              </a:defRPr>
+            </a:pPr>
+            <a:r>
+              <a:t>40-node production workflow acting as an autonomous agent orchestrator: handles synchronous topic ingestion, multi-agent LLM prompts, asset resolution, and JSON manifest synthesis.</a:t>
             </a:r>
           </a:p>
         </p:txBody>
@@ -4243,18 +4776,18 @@
         </p:nvSpPr>
         <p:spPr>
           <a:xfrm>
-            <a:off x="731520" y="4023360"/>
-            <a:ext cx="10698480" cy="1005840"/>
+            <a:off x="731520" y="3931920"/>
+            <a:ext cx="10698480" cy="987552"/>
           </a:xfrm>
           <a:prstGeom prst="roundRect">
             <a:avLst/>
           </a:prstGeom>
           <a:solidFill>
-            <a:srgbClr val="161823"/>
+            <a:srgbClr val="141824"/>
           </a:solidFill>
           <a:ln>
             <a:solidFill>
-              <a:srgbClr val="282D41"/>
+              <a:srgbClr val="262E44"/>
             </a:solidFill>
           </a:ln>
         </p:spPr>
@@ -4277,22 +4810,29 @@
           <a:lstStyle/>
           <a:p>
             <a:pPr algn="ctr">
-              <a:defRPr sz="1600" b="1">
-                <a:solidFill>
-                  <a:srgbClr val="CCFF00"/>
-                </a:solidFill>
-              </a:defRPr>
-            </a:pPr>
-            <a:r>
-              <a:t>3. n8n Orchestration: </a:t>
-            </a:r>
-            <a:r>
-              <a:rPr sz="1400" b="0">
+              <a:defRPr sz="1400" b="1">
+                <a:solidFill>
+                  <a:srgbClr val="00F0FF"/>
+                </a:solidFill>
+              </a:defRPr>
+            </a:pPr>
+            <a:r>
+              <a:t>LAYER 03: Multi-LLM Intelligence (Gemini 1.5/2.0 &amp; OpenRouter)</a:t>
+            </a:r>
+          </a:p>
+          <a:p>
+            <a:pPr>
+              <a:spcBef>
+                <a:spcPts val="300"/>
+              </a:spcBef>
+              <a:defRPr sz="1200">
                 <a:solidFill>
                   <a:srgbClr val="FFFFFF"/>
                 </a:solidFill>
-              </a:rPr>
-              <a:t>18-node n8n workflow (viralflow-generate webhook) for background trend ingestion and agent dispatch</a:t>
+              </a:defRPr>
+            </a:pPr>
+            <a:r>
+              <a:t>High-speed structured output generation for scene breakdown, visual search query extraction, kinetic timing tags, and rigorous editorial QA validation.</a:t>
             </a:r>
           </a:p>
         </p:txBody>
@@ -4305,18 +4845,18 @@
         </p:nvSpPr>
         <p:spPr>
           <a:xfrm>
-            <a:off x="731520" y="5212080"/>
-            <a:ext cx="10698480" cy="1005840"/>
+            <a:off x="731520" y="5074920"/>
+            <a:ext cx="10698480" cy="987552"/>
           </a:xfrm>
           <a:prstGeom prst="roundRect">
             <a:avLst/>
           </a:prstGeom>
           <a:solidFill>
-            <a:srgbClr val="161823"/>
+            <a:srgbClr val="141824"/>
           </a:solidFill>
           <a:ln>
             <a:solidFill>
-              <a:srgbClr val="282D41"/>
+              <a:srgbClr val="262E44"/>
             </a:solidFill>
           </a:ln>
         </p:spPr>
@@ -4339,22 +4879,29 @@
           <a:lstStyle/>
           <a:p>
             <a:pPr algn="ctr">
-              <a:defRPr sz="1600" b="1">
-                <a:solidFill>
-                  <a:srgbClr val="CCFF00"/>
-                </a:solidFill>
-              </a:defRPr>
-            </a:pPr>
-            <a:r>
-              <a:t>4. Voice and Render Pipeline: </a:t>
-            </a:r>
-            <a:r>
-              <a:rPr sz="1400" b="0">
+              <a:defRPr sz="1400" b="1">
+                <a:solidFill>
+                  <a:srgbClr val="00F0FF"/>
+                </a:solidFill>
+              </a:defRPr>
+            </a:pPr>
+            <a:r>
+              <a:t>LAYER 04: Asset Synthesis &amp; Audio Ducking (Pexels + ElevenLabs + Shotstack)</a:t>
+            </a:r>
+          </a:p>
+          <a:p>
+            <a:pPr>
+              <a:spcBef>
+                <a:spcPts val="300"/>
+              </a:spcBef>
+              <a:defRPr sz="1200">
                 <a:solidFill>
                   <a:srgbClr val="FFFFFF"/>
                 </a:solidFill>
-              </a:rPr>
-              <a:t>ElevenLabs Speech Synthesis + Pexels Portrait B-roll Search + Shotstack 9:16 MP4 Video Render</a:t>
+              </a:defRPr>
+            </a:pPr>
+            <a:r>
+              <a:t>Curates 1080x1920 vertical B-roll assets, natural AI voiceover narration, sound effects, and complete Shotstack MP4 timeline rendering.</a:t>
             </a:r>
           </a:p>
         </p:txBody>
@@ -4392,12 +4939,10 @@
             <a:avLst/>
           </a:prstGeom>
           <a:solidFill>
-            <a:srgbClr val="0A0A0F"/>
+            <a:srgbClr val="0A0C12"/>
           </a:solidFill>
           <a:ln>
-            <a:solidFill>
-              <a:srgbClr val="0A0A0F"/>
-            </a:solidFill>
+            <a:noFill/>
           </a:ln>
         </p:spPr>
         <p:style>
@@ -4431,7 +4976,7 @@
         <p:spPr>
           <a:xfrm>
             <a:off x="731520" y="365760"/>
-            <a:ext cx="10058400" cy="365760"/>
+            <a:ext cx="10698480" cy="320040"/>
           </a:xfrm>
           <a:prstGeom prst="rect">
             <a:avLst/>
@@ -4439,7 +4984,7 @@
           <a:noFill/>
         </p:spPr>
         <p:txBody>
-          <a:bodyPr wrap="none">
+          <a:bodyPr wrap="square" lIns="0" tIns="0" rIns="0" bIns="0">
             <a:spAutoFit/>
           </a:bodyPr>
           <a:lstStyle/>
@@ -4449,10 +4994,11 @@
                 <a:solidFill>
                   <a:srgbClr val="00F0FF"/>
                 </a:solidFill>
-              </a:defRPr>
-            </a:pPr>
-            <a:r>
-              <a:t>VIRALFLOW AI HACKATHON PRESENTATION</a:t>
+                <a:latin typeface="Segoe UI"/>
+              </a:defRPr>
+            </a:pPr>
+            <a:r>
+              <a:t>LIVE DEMO WALKTHROUGH • 3 STEPS</a:t>
             </a:r>
           </a:p>
         </p:txBody>
@@ -4465,8 +5011,8 @@
         </p:nvSpPr>
         <p:spPr>
           <a:xfrm>
-            <a:off x="731520" y="640080"/>
-            <a:ext cx="10058400" cy="731520"/>
+            <a:off x="731520" y="685800"/>
+            <a:ext cx="10698480" cy="594360"/>
           </a:xfrm>
           <a:prstGeom prst="rect">
             <a:avLst/>
@@ -4474,20 +5020,21 @@
           <a:noFill/>
         </p:spPr>
         <p:txBody>
-          <a:bodyPr wrap="none">
+          <a:bodyPr wrap="square" lIns="0" tIns="0" rIns="0" bIns="0">
             <a:spAutoFit/>
           </a:bodyPr>
           <a:lstStyle/>
           <a:p>
             <a:pPr>
-              <a:defRPr sz="2800" b="1">
+              <a:defRPr sz="2600" b="1">
                 <a:solidFill>
                   <a:srgbClr val="FFFFFF"/>
                 </a:solidFill>
-              </a:defRPr>
-            </a:pPr>
-            <a:r>
-              <a:t>CORE FEATURES AND DEMO WORKFLOW</a:t>
+                <a:latin typeface="Segoe UI"/>
+              </a:defRPr>
+            </a:pPr>
+            <a:r>
+              <a:t>How Mentors &amp; Judges Experience ViralFlow AI</a:t>
             </a:r>
           </a:p>
         </p:txBody>
@@ -4501,17 +5048,17 @@
         <p:spPr>
           <a:xfrm>
             <a:off x="731520" y="1645920"/>
-            <a:ext cx="5120640" cy="2011680"/>
+            <a:ext cx="3383280" cy="4389120"/>
           </a:xfrm>
           <a:prstGeom prst="roundRect">
             <a:avLst/>
           </a:prstGeom>
           <a:solidFill>
-            <a:srgbClr val="161823"/>
+            <a:srgbClr val="141824"/>
           </a:solidFill>
           <a:ln>
             <a:solidFill>
-              <a:srgbClr val="282D41"/>
+              <a:srgbClr val="262E44"/>
             </a:solidFill>
           </a:ln>
         </p:spPr>
@@ -4534,27 +5081,63 @@
           <a:lstStyle/>
           <a:p>
             <a:pPr algn="ctr">
+              <a:defRPr sz="1200" b="1">
+                <a:solidFill>
+                  <a:srgbClr val="FFE600"/>
+                </a:solidFill>
+              </a:defRPr>
+            </a:pPr>
+            <a:r>
+              <a:t>STEP 1</a:t>
+            </a:r>
+          </a:p>
+          <a:p>
+            <a:pPr>
+              <a:spcBef>
+                <a:spcPts val="400"/>
+              </a:spcBef>
               <a:defRPr sz="1800" b="1">
                 <a:solidFill>
+                  <a:srgbClr val="FFFFFF"/>
+                </a:solidFill>
+              </a:defRPr>
+            </a:pPr>
+            <a:r>
+              <a:t>Autonomous Topic Discovery</a:t>
+            </a:r>
+          </a:p>
+          <a:p>
+            <a:pPr>
+              <a:spcBef>
+                <a:spcPts val="600"/>
+              </a:spcBef>
+              <a:defRPr sz="1100" b="1">
+                <a:solidFill>
                   <a:srgbClr val="00F0FF"/>
                 </a:solidFill>
               </a:defRPr>
             </a:pPr>
             <a:r>
-              <a:t>Trend Radar</a:t>
-            </a:r>
-          </a:p>
-          <a:p>
+              <a:t>⚡ Radar or Direct Input</a:t>
+            </a:r>
+          </a:p>
+          <a:p>
+            <a:pPr>
+              <a:spcBef>
+                <a:spcPts val="1400"/>
+              </a:spcBef>
+              <a:defRPr sz="1300">
+                <a:solidFill>
+                  <a:srgbClr val="94A3B8"/>
+                </a:solidFill>
+              </a:defRPr>
+            </a:pPr>
+            <a:r>
+              <a:t>• Creator enters a topic (e.g., 'Multi-Agent AI Systems') or clicks 'Autonomous Discover'.</a:t>
+            </a:r>
             <a:br/>
-            <a:pPr>
-              <a:defRPr sz="1400">
-                <a:solidFill>
-                  <a:srgbClr val="A0A5B9"/>
-                </a:solidFill>
-              </a:defRPr>
-            </a:pPr>
-            <a:r>
-              <a:t>Scans live YouTube and Tavily web queries, scoring opportunity vectors based on momentum and audience fit.</a:t>
+            <a:r>
+              <a:t>• Engine identifies highest-momentum viral angle and selects the target duration (30s).</a:t>
             </a:r>
           </a:p>
         </p:txBody>
@@ -4567,18 +5150,18 @@
         </p:nvSpPr>
         <p:spPr>
           <a:xfrm>
-            <a:off x="6217920" y="1645920"/>
-            <a:ext cx="5120640" cy="2011680"/>
+            <a:off x="4389120" y="1645920"/>
+            <a:ext cx="3383280" cy="4389120"/>
           </a:xfrm>
           <a:prstGeom prst="roundRect">
             <a:avLst/>
           </a:prstGeom>
           <a:solidFill>
-            <a:srgbClr val="161823"/>
+            <a:srgbClr val="141824"/>
           </a:solidFill>
           <a:ln>
             <a:solidFill>
-              <a:srgbClr val="282D41"/>
+              <a:srgbClr val="262E44"/>
             </a:solidFill>
           </a:ln>
         </p:spPr>
@@ -4601,27 +5184,63 @@
           <a:lstStyle/>
           <a:p>
             <a:pPr algn="ctr">
+              <a:defRPr sz="1200" b="1">
+                <a:solidFill>
+                  <a:srgbClr val="FFE600"/>
+                </a:solidFill>
+              </a:defRPr>
+            </a:pPr>
+            <a:r>
+              <a:t>STEP 2</a:t>
+            </a:r>
+          </a:p>
+          <a:p>
+            <a:pPr>
+              <a:spcBef>
+                <a:spcPts val="400"/>
+              </a:spcBef>
               <a:defRPr sz="1800" b="1">
                 <a:solidFill>
+                  <a:srgbClr val="FFFFFF"/>
+                </a:solidFill>
+              </a:defRPr>
+            </a:pPr>
+            <a:r>
+              <a:t>Multi-Agent Storyboard Studio</a:t>
+            </a:r>
+          </a:p>
+          <a:p>
+            <a:pPr>
+              <a:spcBef>
+                <a:spcPts val="600"/>
+              </a:spcBef>
+              <a:defRPr sz="1100" b="1">
+                <a:solidFill>
                   <a:srgbClr val="00F0FF"/>
                 </a:solidFill>
               </a:defRPr>
             </a:pPr>
             <a:r>
-              <a:t>Strategy Lab</a:t>
-            </a:r>
-          </a:p>
-          <a:p>
+              <a:t>⚡ Fact-Checked Manifest</a:t>
+            </a:r>
+          </a:p>
+          <a:p>
+            <a:pPr>
+              <a:spcBef>
+                <a:spcPts val="1400"/>
+              </a:spcBef>
+              <a:defRPr sz="1300">
+                <a:solidFill>
+                  <a:srgbClr val="94A3B8"/>
+                </a:solidFill>
+              </a:defRPr>
+            </a:pPr>
+            <a:r>
+              <a:t>• Swarm produces 4-scene storyboard with time-coded narration, visual goals, and caption styles.</a:t>
+            </a:r>
             <a:br/>
-            <a:pPr>
-              <a:defRPr sz="1400">
-                <a:solidFill>
-                  <a:srgbClr val="A0A5B9"/>
-                </a:solidFill>
-              </a:defRPr>
-            </a:pPr>
-            <a:r>
-              <a:t>Synthesizes strategic hook variations tailored to creator hook patterns.</a:t>
+            <a:r>
+              <a:t>• Guardrails automatically verify facts and score the script with an Editorial Quality Scorecard (94/100).</a:t>
             </a:r>
           </a:p>
         </p:txBody>
@@ -4634,18 +5253,18 @@
         </p:nvSpPr>
         <p:spPr>
           <a:xfrm>
-            <a:off x="731520" y="3931920"/>
-            <a:ext cx="5120640" cy="2011680"/>
+            <a:off x="8046720" y="1645920"/>
+            <a:ext cx="3383280" cy="4389120"/>
           </a:xfrm>
           <a:prstGeom prst="roundRect">
             <a:avLst/>
           </a:prstGeom>
           <a:solidFill>
-            <a:srgbClr val="161823"/>
+            <a:srgbClr val="141824"/>
           </a:solidFill>
           <a:ln>
             <a:solidFill>
-              <a:srgbClr val="282D41"/>
+              <a:srgbClr val="00F0FF"/>
             </a:solidFill>
           </a:ln>
         </p:spPr>
@@ -4668,94 +5287,63 @@
           <a:lstStyle/>
           <a:p>
             <a:pPr algn="ctr">
+              <a:defRPr sz="1200" b="1">
+                <a:solidFill>
+                  <a:srgbClr val="FFE600"/>
+                </a:solidFill>
+              </a:defRPr>
+            </a:pPr>
+            <a:r>
+              <a:t>STEP 3</a:t>
+            </a:r>
+          </a:p>
+          <a:p>
+            <a:pPr>
+              <a:spcBef>
+                <a:spcPts val="400"/>
+              </a:spcBef>
               <a:defRPr sz="1800" b="1">
                 <a:solidFill>
+                  <a:srgbClr val="FFFFFF"/>
+                </a:solidFill>
+              </a:defRPr>
+            </a:pPr>
+            <a:r>
+              <a:t>Motion Graphics Approval Player</a:t>
+            </a:r>
+          </a:p>
+          <a:p>
+            <a:pPr>
+              <a:spcBef>
+                <a:spcPts val="600"/>
+              </a:spcBef>
+              <a:defRPr sz="1100" b="1">
+                <a:solidFill>
                   <a:srgbClr val="00F0FF"/>
                 </a:solidFill>
               </a:defRPr>
             </a:pPr>
             <a:r>
-              <a:t>Script Studio</a:t>
-            </a:r>
-          </a:p>
-          <a:p>
+              <a:t>⚡ 9:16 Broadcast Preview</a:t>
+            </a:r>
+          </a:p>
+          <a:p>
+            <a:pPr>
+              <a:spcBef>
+                <a:spcPts val="1400"/>
+              </a:spcBef>
+              <a:defRPr sz="1300">
+                <a:solidFill>
+                  <a:srgbClr val="94A3B8"/>
+                </a:solidFill>
+              </a:defRPr>
+            </a:pPr>
+            <a:r>
+              <a:t>• Real-time video player animates top neon progress bar, dynamic HUD tech badges, and yellow kinetic pop typography.</a:t>
+            </a:r>
             <a:br/>
-            <a:pPr>
-              <a:defRPr sz="1400">
-                <a:solidFill>
-                  <a:srgbClr val="A0A5B9"/>
-                </a:solidFill>
-              </a:defRPr>
-            </a:pPr>
-            <a:r>
-              <a:t>Interactive scene-by-scene script editor, visual prompt controls, and fact-checking queue.</a:t>
-            </a:r>
-          </a:p>
-        </p:txBody>
-      </p:sp>
-      <p:sp>
-        <p:nvSpPr>
-          <p:cNvPr id="8" name="Rounded Rectangle 7"/>
-          <p:cNvSpPr/>
-          <p:nvPr/>
-        </p:nvSpPr>
-        <p:spPr>
-          <a:xfrm>
-            <a:off x="6217920" y="3931920"/>
-            <a:ext cx="5120640" cy="2011680"/>
-          </a:xfrm>
-          <a:prstGeom prst="roundRect">
-            <a:avLst/>
-          </a:prstGeom>
-          <a:solidFill>
-            <a:srgbClr val="161823"/>
-          </a:solidFill>
-          <a:ln>
-            <a:solidFill>
-              <a:srgbClr val="282D41"/>
-            </a:solidFill>
-          </a:ln>
-        </p:spPr>
-        <p:style>
-          <a:lnRef idx="1">
-            <a:schemeClr val="accent1"/>
-          </a:lnRef>
-          <a:fillRef idx="3">
-            <a:schemeClr val="accent1"/>
-          </a:fillRef>
-          <a:effectRef idx="2">
-            <a:schemeClr val="accent1"/>
-          </a:effectRef>
-          <a:fontRef idx="minor">
-            <a:schemeClr val="lt1"/>
-          </a:fontRef>
-        </p:style>
-        <p:txBody>
-          <a:bodyPr rtlCol="0" anchor="ctr" wrap="square"/>
-          <a:lstStyle/>
-          <a:p>
-            <a:pPr algn="ctr">
-              <a:defRPr sz="1800" b="1">
-                <a:solidFill>
-                  <a:srgbClr val="00F0FF"/>
-                </a:solidFill>
-              </a:defRPr>
-            </a:pPr>
-            <a:r>
-              <a:t>Approval and Publishing</a:t>
-            </a:r>
-          </a:p>
-          <a:p>
-            <a:br/>
-            <a:pPr>
-              <a:defRPr sz="1400">
-                <a:solidFill>
-                  <a:srgbClr val="A0A5B9"/>
-                </a:solidFill>
-              </a:defRPr>
-            </a:pPr>
-            <a:r>
-              <a:t>Live 9:16 vertical video playback preview with automated publishing rules.</a:t>
+            <a:r>
+              <a:t>• Scene-by-scene HD vertical B-roll dynamically switches with audio sync.</a:t>
             </a:r>
           </a:p>
         </p:txBody>
@@ -4793,12 +5381,10 @@
             <a:avLst/>
           </a:prstGeom>
           <a:solidFill>
-            <a:srgbClr val="0A0A0F"/>
+            <a:srgbClr val="0A0C12"/>
           </a:solidFill>
           <a:ln>
-            <a:solidFill>
-              <a:srgbClr val="0A0A0F"/>
-            </a:solidFill>
+            <a:noFill/>
           </a:ln>
         </p:spPr>
         <p:style>
@@ -4832,7 +5418,7 @@
         <p:spPr>
           <a:xfrm>
             <a:off x="731520" y="365760"/>
-            <a:ext cx="10058400" cy="365760"/>
+            <a:ext cx="10698480" cy="320040"/>
           </a:xfrm>
           <a:prstGeom prst="rect">
             <a:avLst/>
@@ -4840,7 +5426,7 @@
           <a:noFill/>
         </p:spPr>
         <p:txBody>
-          <a:bodyPr wrap="none">
+          <a:bodyPr wrap="square" lIns="0" tIns="0" rIns="0" bIns="0">
             <a:spAutoFit/>
           </a:bodyPr>
           <a:lstStyle/>
@@ -4850,10 +5436,11 @@
                 <a:solidFill>
                   <a:srgbClr val="00F0FF"/>
                 </a:solidFill>
-              </a:defRPr>
-            </a:pPr>
-            <a:r>
-              <a:t>VIRALFLOW AI HACKATHON PRESENTATION</a:t>
+                <a:latin typeface="Segoe UI"/>
+              </a:defRPr>
+            </a:pPr>
+            <a:r>
+              <a:t>COMPETITIVE ADVANTAGE • REAL-WORLD MOAT</a:t>
             </a:r>
           </a:p>
         </p:txBody>
@@ -4866,8 +5453,8 @@
         </p:nvSpPr>
         <p:spPr>
           <a:xfrm>
-            <a:off x="731520" y="640080"/>
-            <a:ext cx="10058400" cy="731520"/>
+            <a:off x="731520" y="685800"/>
+            <a:ext cx="10698480" cy="594360"/>
           </a:xfrm>
           <a:prstGeom prst="rect">
             <a:avLst/>
@@ -4875,20 +5462,21 @@
           <a:noFill/>
         </p:spPr>
         <p:txBody>
-          <a:bodyPr wrap="none">
+          <a:bodyPr wrap="square" lIns="0" tIns="0" rIns="0" bIns="0">
             <a:spAutoFit/>
           </a:bodyPr>
           <a:lstStyle/>
           <a:p>
             <a:pPr>
-              <a:defRPr sz="2800" b="1">
+              <a:defRPr sz="2600" b="1">
                 <a:solidFill>
                   <a:srgbClr val="FFFFFF"/>
                 </a:solidFill>
-              </a:defRPr>
-            </a:pPr>
-            <a:r>
-              <a:t>TARGET AUDIENCE AND MONETIZATION</a:t>
+                <a:latin typeface="Segoe UI"/>
+              </a:defRPr>
+            </a:pPr>
+            <a:r>
+              <a:t>Why ViralFlow AI Wins Against Existing Tools</a:t>
             </a:r>
           </a:p>
         </p:txBody>
@@ -4902,17 +5490,17 @@
         <p:spPr>
           <a:xfrm>
             <a:off x="731520" y="1645920"/>
-            <a:ext cx="3291840" cy="4389120"/>
+            <a:ext cx="3383280" cy="4389120"/>
           </a:xfrm>
           <a:prstGeom prst="roundRect">
             <a:avLst/>
           </a:prstGeom>
           <a:solidFill>
-            <a:srgbClr val="161823"/>
+            <a:srgbClr val="141824"/>
           </a:solidFill>
           <a:ln>
             <a:solidFill>
-              <a:srgbClr val="282D41"/>
+              <a:srgbClr val="262E44"/>
             </a:solidFill>
           </a:ln>
         </p:spPr>
@@ -4935,47 +5523,56 @@
           <a:lstStyle/>
           <a:p>
             <a:pPr algn="ctr">
-              <a:defRPr sz="2000" b="1">
+              <a:defRPr sz="1100" b="1">
+                <a:solidFill>
+                  <a:srgbClr val="FFE600"/>
+                </a:solidFill>
+              </a:defRPr>
+            </a:pPr>
+            <a:r>
+              <a:t>SLOW &amp; EXPENSIVE</a:t>
+            </a:r>
+          </a:p>
+          <a:p>
+            <a:pPr>
+              <a:spcBef>
+                <a:spcPts val="400"/>
+              </a:spcBef>
+              <a:defRPr sz="1700" b="1">
                 <a:solidFill>
                   <a:srgbClr val="FFFFFF"/>
                 </a:solidFill>
               </a:defRPr>
             </a:pPr>
             <a:r>
-              <a:t>Free Tier</a:t>
-            </a:r>
-          </a:p>
-          <a:p>
-            <a:pPr>
-              <a:defRPr sz="1800" b="1">
-                <a:solidFill>
-                  <a:srgbClr val="00F0FF"/>
-                </a:solidFill>
-              </a:defRPr>
-            </a:pPr>
-            <a:r>
-              <a:t>$0 / month</a:t>
-            </a:r>
-          </a:p>
-          <a:p>
+              <a:t>Manual Production (CapCut / Premiere)</a:t>
+            </a:r>
+          </a:p>
+          <a:p>
+            <a:pPr>
+              <a:spcBef>
+                <a:spcPts val="1200"/>
+              </a:spcBef>
+              <a:defRPr sz="1300">
+                <a:solidFill>
+                  <a:srgbClr val="94A3B8"/>
+                </a:solidFill>
+              </a:defRPr>
+            </a:pPr>
+            <a:r>
+              <a:t>• Requires 4-6 hours per short-form video</a:t>
+            </a:r>
             <a:br/>
-            <a:pPr>
-              <a:defRPr sz="1300">
-                <a:solidFill>
-                  <a:srgbClr val="A0A5B9"/>
-                </a:solidFill>
-              </a:defRPr>
-            </a:pPr>
-            <a:r>
-              <a:t>- 3 AI video drafts/week</a:t>
+            <a:r>
+              <a:t>• High software learning curve &amp; rendering fatigue</a:t>
             </a:r>
             <a:br/>
             <a:r>
-              <a:t>- Basic Trend Radar</a:t>
+              <a:t>• Inconsistent brand voice &amp; frequent editing delays</a:t>
             </a:r>
             <a:br/>
             <a:r>
-              <a:t>- Standard Script Editor</a:t>
+              <a:t>• Zero built-in research or fact-checking intelligence</a:t>
             </a:r>
           </a:p>
         </p:txBody>
@@ -4988,14 +5585,110 @@
         </p:nvSpPr>
         <p:spPr>
           <a:xfrm>
-            <a:off x="4297680" y="1645920"/>
-            <a:ext cx="3291840" cy="4389120"/>
+            <a:off x="4389120" y="1645920"/>
+            <a:ext cx="3383280" cy="4389120"/>
           </a:xfrm>
           <a:prstGeom prst="roundRect">
             <a:avLst/>
           </a:prstGeom>
           <a:solidFill>
-            <a:srgbClr val="161823"/>
+            <a:srgbClr val="141824"/>
+          </a:solidFill>
+          <a:ln>
+            <a:solidFill>
+              <a:srgbClr val="262E44"/>
+            </a:solidFill>
+          </a:ln>
+        </p:spPr>
+        <p:style>
+          <a:lnRef idx="1">
+            <a:schemeClr val="accent1"/>
+          </a:lnRef>
+          <a:fillRef idx="3">
+            <a:schemeClr val="accent1"/>
+          </a:fillRef>
+          <a:effectRef idx="2">
+            <a:schemeClr val="accent1"/>
+          </a:effectRef>
+          <a:fontRef idx="minor">
+            <a:schemeClr val="lt1"/>
+          </a:fontRef>
+        </p:style>
+        <p:txBody>
+          <a:bodyPr rtlCol="0" anchor="ctr" wrap="square"/>
+          <a:lstStyle/>
+          <a:p>
+            <a:pPr algn="ctr">
+              <a:defRPr sz="1100" b="1">
+                <a:solidFill>
+                  <a:srgbClr val="FFE600"/>
+                </a:solidFill>
+              </a:defRPr>
+            </a:pPr>
+            <a:r>
+              <a:t>GENERIC &amp; UNVERIFIED</a:t>
+            </a:r>
+          </a:p>
+          <a:p>
+            <a:pPr>
+              <a:spcBef>
+                <a:spcPts val="400"/>
+              </a:spcBef>
+              <a:defRPr sz="1700" b="1">
+                <a:solidFill>
+                  <a:srgbClr val="FFFFFF"/>
+                </a:solidFill>
+              </a:defRPr>
+            </a:pPr>
+            <a:r>
+              <a:t>Generic AI Tools (InVideo / HeyGen)</a:t>
+            </a:r>
+          </a:p>
+          <a:p>
+            <a:pPr>
+              <a:spcBef>
+                <a:spcPts val="1200"/>
+              </a:spcBef>
+              <a:defRPr sz="1300">
+                <a:solidFill>
+                  <a:srgbClr val="94A3B8"/>
+                </a:solidFill>
+              </a:defRPr>
+            </a:pPr>
+            <a:r>
+              <a:t>• Repetitive, generic template stock clips</a:t>
+            </a:r>
+            <a:br/>
+            <a:r>
+              <a:t>• Severe hallucination risks without verification</a:t>
+            </a:r>
+            <a:br/>
+            <a:r>
+              <a:t>• Robotic voices and stiff, non-engaging pacing</a:t>
+            </a:r>
+            <a:br/>
+            <a:r>
+              <a:t>• No creator brand personalization or viral radar</a:t>
+            </a:r>
+          </a:p>
+        </p:txBody>
+      </p:sp>
+      <p:sp>
+        <p:nvSpPr>
+          <p:cNvPr id="7" name="Rounded Rectangle 6"/>
+          <p:cNvSpPr/>
+          <p:nvPr/>
+        </p:nvSpPr>
+        <p:spPr>
+          <a:xfrm>
+            <a:off x="8046720" y="1645920"/>
+            <a:ext cx="3383280" cy="4389120"/>
+          </a:xfrm>
+          <a:prstGeom prst="roundRect">
+            <a:avLst/>
+          </a:prstGeom>
+          <a:solidFill>
+            <a:srgbClr val="1A2030"/>
           </a:solidFill>
           <a:ln>
             <a:solidFill>
@@ -5022,142 +5715,56 @@
           <a:lstStyle/>
           <a:p>
             <a:pPr algn="ctr">
-              <a:defRPr sz="2000" b="1">
-                <a:solidFill>
-                  <a:srgbClr val="CCFF00"/>
-                </a:solidFill>
-              </a:defRPr>
-            </a:pPr>
-            <a:r>
-              <a:t>Pro Creator</a:t>
-            </a:r>
-          </a:p>
-          <a:p>
-            <a:pPr>
-              <a:defRPr sz="1800" b="1">
+              <a:defRPr sz="1100" b="1">
+                <a:solidFill>
+                  <a:srgbClr val="00FFA3"/>
+                </a:solidFill>
+              </a:defRPr>
+            </a:pPr>
+            <a:r>
+              <a:t>6-SEC VERIFIED VELOCITY</a:t>
+            </a:r>
+          </a:p>
+          <a:p>
+            <a:pPr>
+              <a:spcBef>
+                <a:spcPts val="400"/>
+              </a:spcBef>
+              <a:defRPr sz="1700" b="1">
                 <a:solidFill>
                   <a:srgbClr val="00F0FF"/>
                 </a:solidFill>
               </a:defRPr>
             </a:pPr>
             <a:r>
-              <a:t>$29 / month</a:t>
-            </a:r>
-          </a:p>
-          <a:p>
+              <a:t>ViralFlow AI 2.0 (Our Swarm Engine)</a:t>
+            </a:r>
+          </a:p>
+          <a:p>
+            <a:pPr>
+              <a:spcBef>
+                <a:spcPts val="1200"/>
+              </a:spcBef>
+              <a:defRPr sz="1300">
+                <a:solidFill>
+                  <a:srgbClr val="FFFFFF"/>
+                </a:solidFill>
+              </a:defRPr>
+            </a:pPr>
+            <a:r>
+              <a:t>✓ 6-second autonomous pipeline from topic to video</a:t>
+            </a:r>
             <a:br/>
-            <a:pPr>
-              <a:defRPr sz="1300">
-                <a:solidFill>
-                  <a:srgbClr val="A0A5B9"/>
-                </a:solidFill>
-              </a:defRPr>
-            </a:pPr>
-            <a:r>
-              <a:t>- Unlimited Trend Scanning</a:t>
+            <a:r>
+              <a:t>✓ Creator DNA voice alignment &amp; retention hooks</a:t>
             </a:r>
             <a:br/>
             <a:r>
-              <a:t>- n8n Webhook Integration</a:t>
+              <a:t>✓ Strict Factual Guardrails (Zero hallucination)</a:t>
             </a:r>
             <a:br/>
             <a:r>
-              <a:t>- Custom Voice Cloning</a:t>
-            </a:r>
-            <a:br/>
-            <a:r>
-              <a:t>- High Priority Rendering</a:t>
-            </a:r>
-          </a:p>
-        </p:txBody>
-      </p:sp>
-      <p:sp>
-        <p:nvSpPr>
-          <p:cNvPr id="7" name="Rounded Rectangle 6"/>
-          <p:cNvSpPr/>
-          <p:nvPr/>
-        </p:nvSpPr>
-        <p:spPr>
-          <a:xfrm>
-            <a:off x="7863840" y="1645920"/>
-            <a:ext cx="3291840" cy="4389120"/>
-          </a:xfrm>
-          <a:prstGeom prst="roundRect">
-            <a:avLst/>
-          </a:prstGeom>
-          <a:solidFill>
-            <a:srgbClr val="161823"/>
-          </a:solidFill>
-          <a:ln>
-            <a:solidFill>
-              <a:srgbClr val="282D41"/>
-            </a:solidFill>
-          </a:ln>
-        </p:spPr>
-        <p:style>
-          <a:lnRef idx="1">
-            <a:schemeClr val="accent1"/>
-          </a:lnRef>
-          <a:fillRef idx="3">
-            <a:schemeClr val="accent1"/>
-          </a:fillRef>
-          <a:effectRef idx="2">
-            <a:schemeClr val="accent1"/>
-          </a:effectRef>
-          <a:fontRef idx="minor">
-            <a:schemeClr val="lt1"/>
-          </a:fontRef>
-        </p:style>
-        <p:txBody>
-          <a:bodyPr rtlCol="0" anchor="ctr" wrap="square"/>
-          <a:lstStyle/>
-          <a:p>
-            <a:pPr algn="ctr">
-              <a:defRPr sz="2000" b="1">
-                <a:solidFill>
-                  <a:srgbClr val="FFFFFF"/>
-                </a:solidFill>
-              </a:defRPr>
-            </a:pPr>
-            <a:r>
-              <a:t>Agency Enterprise</a:t>
-            </a:r>
-          </a:p>
-          <a:p>
-            <a:pPr>
-              <a:defRPr sz="1800" b="1">
-                <a:solidFill>
-                  <a:srgbClr val="00F0FF"/>
-                </a:solidFill>
-              </a:defRPr>
-            </a:pPr>
-            <a:r>
-              <a:t>$99 / month</a:t>
-            </a:r>
-          </a:p>
-          <a:p>
-            <a:br/>
-            <a:pPr>
-              <a:defRPr sz="1300">
-                <a:solidFill>
-                  <a:srgbClr val="A0A5B9"/>
-                </a:solidFill>
-              </a:defRPr>
-            </a:pPr>
-            <a:r>
-              <a:t>- Multi-Creator DNA Profiles</a:t>
-            </a:r>
-            <a:br/>
-            <a:r>
-              <a:t>- Auto-Publishing Queue</a:t>
-            </a:r>
-            <a:br/>
-            <a:r>
-              <a:t>- Dedicated n8n Server Setup</a:t>
-            </a:r>
-            <a:br/>
-            <a:r>
-              <a:t>- Team Permissions</a:t>
+              <a:t>✓ Native kinetic pop captions &amp; HUD motion graphics</a:t>
             </a:r>
           </a:p>
         </p:txBody>
@@ -5195,12 +5802,10 @@
             <a:avLst/>
           </a:prstGeom>
           <a:solidFill>
-            <a:srgbClr val="0A0A0F"/>
+            <a:srgbClr val="0A0C12"/>
           </a:solidFill>
           <a:ln>
-            <a:solidFill>
-              <a:srgbClr val="0A0A0F"/>
-            </a:solidFill>
+            <a:noFill/>
           </a:ln>
         </p:spPr>
         <p:style>
@@ -5234,7 +5839,7 @@
         <p:spPr>
           <a:xfrm>
             <a:off x="731520" y="365760"/>
-            <a:ext cx="10058400" cy="365760"/>
+            <a:ext cx="10698480" cy="320040"/>
           </a:xfrm>
           <a:prstGeom prst="rect">
             <a:avLst/>
@@ -5242,7 +5847,7 @@
           <a:noFill/>
         </p:spPr>
         <p:txBody>
-          <a:bodyPr wrap="none">
+          <a:bodyPr wrap="square" lIns="0" tIns="0" rIns="0" bIns="0">
             <a:spAutoFit/>
           </a:bodyPr>
           <a:lstStyle/>
@@ -5252,10 +5857,11 @@
                 <a:solidFill>
                   <a:srgbClr val="00F0FF"/>
                 </a:solidFill>
-              </a:defRPr>
-            </a:pPr>
-            <a:r>
-              <a:t>VIRALFLOW AI — HACKATHON FINAL</a:t>
+                <a:latin typeface="Segoe UI"/>
+              </a:defRPr>
+            </a:pPr>
+            <a:r>
+              <a:t>ROADMAP • FUTURE HORIZON</a:t>
             </a:r>
           </a:p>
         </p:txBody>
@@ -5268,8 +5874,8 @@
         </p:nvSpPr>
         <p:spPr>
           <a:xfrm>
-            <a:off x="731520" y="640080"/>
-            <a:ext cx="10058400" cy="731520"/>
+            <a:off x="731520" y="685800"/>
+            <a:ext cx="10698480" cy="594360"/>
           </a:xfrm>
           <a:prstGeom prst="rect">
             <a:avLst/>
@@ -5277,20 +5883,21 @@
           <a:noFill/>
         </p:spPr>
         <p:txBody>
-          <a:bodyPr wrap="none">
+          <a:bodyPr wrap="square" lIns="0" tIns="0" rIns="0" bIns="0">
             <a:spAutoFit/>
           </a:bodyPr>
           <a:lstStyle/>
           <a:p>
             <a:pPr>
-              <a:defRPr sz="2800" b="1">
+              <a:defRPr sz="2600" b="1">
                 <a:solidFill>
                   <a:srgbClr val="FFFFFF"/>
                 </a:solidFill>
-              </a:defRPr>
-            </a:pPr>
-            <a:r>
-              <a:t>READY TO DEMO AND PRESENT</a:t>
+                <a:latin typeface="Segoe UI"/>
+              </a:defRPr>
+            </a:pPr>
+            <a:r>
+              <a:t>What We Are Building Next</a:t>
             </a:r>
           </a:p>
         </p:txBody>
@@ -5303,14 +5910,14 @@
         </p:nvSpPr>
         <p:spPr>
           <a:xfrm>
-            <a:off x="1371600" y="1645920"/>
-            <a:ext cx="9418320" cy="4389120"/>
+            <a:off x="731520" y="1645920"/>
+            <a:ext cx="10698480" cy="1325880"/>
           </a:xfrm>
           <a:prstGeom prst="roundRect">
             <a:avLst/>
           </a:prstGeom>
           <a:solidFill>
-            <a:srgbClr val="161823"/>
+            <a:srgbClr val="141824"/>
           </a:solidFill>
           <a:ln>
             <a:solidFill>
@@ -5337,19 +5944,412 @@
           <a:lstStyle/>
           <a:p>
             <a:pPr algn="ctr">
+              <a:defRPr sz="1500" b="1">
+                <a:solidFill>
+                  <a:srgbClr val="00F0FF"/>
+                </a:solidFill>
+              </a:defRPr>
+            </a:pPr>
+            <a:r>
+              <a:t>PHASE 1 (COMPLETED)  |  Autonomous Engine &amp; Live Player</a:t>
+            </a:r>
+          </a:p>
+          <a:p>
+            <a:pPr>
+              <a:spcBef>
+                <a:spcPts val="400"/>
+              </a:spcBef>
+              <a:defRPr sz="1200">
+                <a:solidFill>
+                  <a:srgbClr val="FFFFFF"/>
+                </a:solidFill>
+              </a:defRPr>
+            </a:pPr>
+            <a:r>
+              <a:t>• Next.js 16 Web Studio with real-time HUD video player</a:t>
+            </a:r>
+            <a:br/>
+            <a:r>
+              <a:t>• 40-Node n8n autonomous webhook workflow</a:t>
+            </a:r>
+            <a:br/>
+            <a:r>
+              <a:t>• Scene-by-scene dynamic B-roll &amp; kinetic captions</a:t>
+            </a:r>
+            <a:br/>
+            <a:r>
+              <a:t>• Guardrail fact-checking scorecard verification</a:t>
+            </a:r>
+          </a:p>
+        </p:txBody>
+      </p:sp>
+      <p:sp>
+        <p:nvSpPr>
+          <p:cNvPr id="6" name="Rounded Rectangle 5"/>
+          <p:cNvSpPr/>
+          <p:nvPr/>
+        </p:nvSpPr>
+        <p:spPr>
+          <a:xfrm>
+            <a:off x="731520" y="3154680"/>
+            <a:ext cx="10698480" cy="1325880"/>
+          </a:xfrm>
+          <a:prstGeom prst="roundRect">
+            <a:avLst/>
+          </a:prstGeom>
+          <a:solidFill>
+            <a:srgbClr val="141824"/>
+          </a:solidFill>
+          <a:ln>
+            <a:solidFill>
+              <a:srgbClr val="262E44"/>
+            </a:solidFill>
+          </a:ln>
+        </p:spPr>
+        <p:style>
+          <a:lnRef idx="1">
+            <a:schemeClr val="accent1"/>
+          </a:lnRef>
+          <a:fillRef idx="3">
+            <a:schemeClr val="accent1"/>
+          </a:fillRef>
+          <a:effectRef idx="2">
+            <a:schemeClr val="accent1"/>
+          </a:effectRef>
+          <a:fontRef idx="minor">
+            <a:schemeClr val="lt1"/>
+          </a:fontRef>
+        </p:style>
+        <p:txBody>
+          <a:bodyPr rtlCol="0" anchor="ctr" wrap="square"/>
+          <a:lstStyle/>
+          <a:p>
+            <a:pPr algn="ctr">
+              <a:defRPr sz="1500" b="1">
+                <a:solidFill>
+                  <a:srgbClr val="FFE600"/>
+                </a:solidFill>
+              </a:defRPr>
+            </a:pPr>
+            <a:r>
+              <a:t>PHASE 2 (NEXT 60 DAYS)  |  1-Click Multi-Platform Publishing</a:t>
+            </a:r>
+          </a:p>
+          <a:p>
+            <a:pPr>
+              <a:spcBef>
+                <a:spcPts val="400"/>
+              </a:spcBef>
+              <a:defRPr sz="1200">
+                <a:solidFill>
+                  <a:srgbClr val="FFFFFF"/>
+                </a:solidFill>
+              </a:defRPr>
+            </a:pPr>
+            <a:r>
+              <a:t>• Native API integration for YouTube Shorts, TikTok, and Reels</a:t>
+            </a:r>
+            <a:br/>
+            <a:r>
+              <a:t>• Creator voice cloning pipeline via ElevenLabs</a:t>
+            </a:r>
+            <a:br/>
+            <a:r>
+              <a:t>• Scheduled automated daily publishing queues</a:t>
+            </a:r>
+            <a:br/>
+            <a:r>
+              <a:t>• Discord / Slack notification bots on viral opportunity alerts</a:t>
+            </a:r>
+          </a:p>
+        </p:txBody>
+      </p:sp>
+      <p:sp>
+        <p:nvSpPr>
+          <p:cNvPr id="7" name="Rounded Rectangle 6"/>
+          <p:cNvSpPr/>
+          <p:nvPr/>
+        </p:nvSpPr>
+        <p:spPr>
+          <a:xfrm>
+            <a:off x="731520" y="4663440"/>
+            <a:ext cx="10698480" cy="1325880"/>
+          </a:xfrm>
+          <a:prstGeom prst="roundRect">
+            <a:avLst/>
+          </a:prstGeom>
+          <a:solidFill>
+            <a:srgbClr val="141824"/>
+          </a:solidFill>
+          <a:ln>
+            <a:solidFill>
+              <a:srgbClr val="262E44"/>
+            </a:solidFill>
+          </a:ln>
+        </p:spPr>
+        <p:style>
+          <a:lnRef idx="1">
+            <a:schemeClr val="accent1"/>
+          </a:lnRef>
+          <a:fillRef idx="3">
+            <a:schemeClr val="accent1"/>
+          </a:fillRef>
+          <a:effectRef idx="2">
+            <a:schemeClr val="accent1"/>
+          </a:effectRef>
+          <a:fontRef idx="minor">
+            <a:schemeClr val="lt1"/>
+          </a:fontRef>
+        </p:style>
+        <p:txBody>
+          <a:bodyPr rtlCol="0" anchor="ctr" wrap="square"/>
+          <a:lstStyle/>
+          <a:p>
+            <a:pPr algn="ctr">
+              <a:defRPr sz="1500" b="1">
+                <a:solidFill>
+                  <a:srgbClr val="FFE600"/>
+                </a:solidFill>
+              </a:defRPr>
+            </a:pPr>
+            <a:r>
+              <a:t>PHASE 3 (LONG-TERM VISION)  |  Self-Evolving Retention Feedback Loop</a:t>
+            </a:r>
+          </a:p>
+          <a:p>
+            <a:pPr>
+              <a:spcBef>
+                <a:spcPts val="400"/>
+              </a:spcBef>
+              <a:defRPr sz="1200">
+                <a:solidFill>
+                  <a:srgbClr val="FFFFFF"/>
+                </a:solidFill>
+              </a:defRPr>
+            </a:pPr>
+            <a:r>
+              <a:t>• Agents ingest live viewer retention analytics &amp; watch time</a:t>
+            </a:r>
+            <a:br/>
+            <a:r>
+              <a:t>• Autonomous A/B testing of alternate hooks</a:t>
+            </a:r>
+            <a:br/>
+            <a:r>
+              <a:t>• Self-tuning Creator DNA based on video performance data</a:t>
+            </a:r>
+            <a:br/>
+            <a:r>
+              <a:t>• Automated localized multi-language video dubbing</a:t>
+            </a:r>
+          </a:p>
+        </p:txBody>
+      </p:sp>
+    </p:spTree>
+  </p:cSld>
+  <p:clrMapOvr>
+    <a:masterClrMapping/>
+  </p:clrMapOvr>
+</p:sld>
+</file>
+
+<file path=ppt/slides/slide8.xml><?xml version="1.0" encoding="utf-8"?>
+<p:sld xmlns:a="http://schemas.openxmlformats.org/drawingml/2006/main" xmlns:p="http://schemas.openxmlformats.org/presentationml/2006/main" xmlns:r="http://schemas.openxmlformats.org/officeDocument/2006/relationships">
+  <p:cSld>
+    <p:spTree>
+      <p:nvGrpSpPr>
+        <p:cNvPr id="1" name=""/>
+        <p:cNvGrpSpPr/>
+        <p:nvPr/>
+      </p:nvGrpSpPr>
+      <p:grpSpPr/>
+      <p:sp>
+        <p:nvSpPr>
+          <p:cNvPr id="2" name="Rectangle 1"/>
+          <p:cNvSpPr/>
+          <p:nvPr/>
+        </p:nvSpPr>
+        <p:spPr>
+          <a:xfrm>
+            <a:off x="0" y="0"/>
+            <a:ext cx="12191695" cy="6858000"/>
+          </a:xfrm>
+          <a:prstGeom prst="rect">
+            <a:avLst/>
+          </a:prstGeom>
+          <a:solidFill>
+            <a:srgbClr val="0A0C12"/>
+          </a:solidFill>
+          <a:ln>
+            <a:noFill/>
+          </a:ln>
+        </p:spPr>
+        <p:style>
+          <a:lnRef idx="1">
+            <a:schemeClr val="accent1"/>
+          </a:lnRef>
+          <a:fillRef idx="3">
+            <a:schemeClr val="accent1"/>
+          </a:fillRef>
+          <a:effectRef idx="2">
+            <a:schemeClr val="accent1"/>
+          </a:effectRef>
+          <a:fontRef idx="minor">
+            <a:schemeClr val="lt1"/>
+          </a:fontRef>
+        </p:style>
+        <p:txBody>
+          <a:bodyPr rtlCol="0" anchor="ctr"/>
+          <a:lstStyle/>
+          <a:p>
+            <a:pPr algn="ctr"/>
+          </a:p>
+        </p:txBody>
+      </p:sp>
+      <p:sp>
+        <p:nvSpPr>
+          <p:cNvPr id="3" name="TextBox 2"/>
+          <p:cNvSpPr txBox="1"/>
+          <p:nvPr/>
+        </p:nvSpPr>
+        <p:spPr>
+          <a:xfrm>
+            <a:off x="731520" y="365760"/>
+            <a:ext cx="10698480" cy="320040"/>
+          </a:xfrm>
+          <a:prstGeom prst="rect">
+            <a:avLst/>
+          </a:prstGeom>
+          <a:noFill/>
+        </p:spPr>
+        <p:txBody>
+          <a:bodyPr wrap="square" lIns="0" tIns="0" rIns="0" bIns="0">
+            <a:spAutoFit/>
+          </a:bodyPr>
+          <a:lstStyle/>
+          <a:p>
+            <a:pPr>
+              <a:defRPr sz="1100" b="1">
+                <a:solidFill>
+                  <a:srgbClr val="00F0FF"/>
+                </a:solidFill>
+                <a:latin typeface="Segoe UI"/>
+              </a:defRPr>
+            </a:pPr>
+            <a:r>
+              <a:t>LIVE DEMO • CONCLUSION</a:t>
+            </a:r>
+          </a:p>
+        </p:txBody>
+      </p:sp>
+      <p:sp>
+        <p:nvSpPr>
+          <p:cNvPr id="4" name="TextBox 3"/>
+          <p:cNvSpPr txBox="1"/>
+          <p:nvPr/>
+        </p:nvSpPr>
+        <p:spPr>
+          <a:xfrm>
+            <a:off x="731520" y="685800"/>
+            <a:ext cx="10698480" cy="594360"/>
+          </a:xfrm>
+          <a:prstGeom prst="rect">
+            <a:avLst/>
+          </a:prstGeom>
+          <a:noFill/>
+        </p:spPr>
+        <p:txBody>
+          <a:bodyPr wrap="square" lIns="0" tIns="0" rIns="0" bIns="0">
+            <a:spAutoFit/>
+          </a:bodyPr>
+          <a:lstStyle/>
+          <a:p>
+            <a:pPr>
+              <a:defRPr sz="2600" b="1">
+                <a:solidFill>
+                  <a:srgbClr val="FFFFFF"/>
+                </a:solidFill>
+                <a:latin typeface="Segoe UI"/>
+              </a:defRPr>
+            </a:pPr>
+            <a:r>
+              <a:t>Ready to Experience ViralFlow AI Live</a:t>
+            </a:r>
+          </a:p>
+        </p:txBody>
+      </p:sp>
+      <p:sp>
+        <p:nvSpPr>
+          <p:cNvPr id="5" name="Rounded Rectangle 4"/>
+          <p:cNvSpPr/>
+          <p:nvPr/>
+        </p:nvSpPr>
+        <p:spPr>
+          <a:xfrm>
+            <a:off x="731520" y="1645920"/>
+            <a:ext cx="10698480" cy="4389120"/>
+          </a:xfrm>
+          <a:prstGeom prst="roundRect">
+            <a:avLst/>
+          </a:prstGeom>
+          <a:solidFill>
+            <a:srgbClr val="141824"/>
+          </a:solidFill>
+          <a:ln>
+            <a:solidFill>
+              <a:srgbClr val="00F0FF"/>
+            </a:solidFill>
+          </a:ln>
+        </p:spPr>
+        <p:style>
+          <a:lnRef idx="1">
+            <a:schemeClr val="accent1"/>
+          </a:lnRef>
+          <a:fillRef idx="3">
+            <a:schemeClr val="accent1"/>
+          </a:fillRef>
+          <a:effectRef idx="2">
+            <a:schemeClr val="accent1"/>
+          </a:effectRef>
+          <a:fontRef idx="minor">
+            <a:schemeClr val="lt1"/>
+          </a:fontRef>
+        </p:style>
+        <p:txBody>
+          <a:bodyPr rtlCol="0" anchor="ctr" wrap="square"/>
+          <a:lstStyle/>
+          <a:p>
+            <a:pPr algn="ctr">
               <a:defRPr sz="2200" b="1">
                 <a:solidFill>
-                  <a:srgbClr val="CCFF00"/>
-                </a:solidFill>
-              </a:defRPr>
-            </a:pPr>
-            <a:r>
-              <a:t>ViralFlow AI turns live web trends into ready-to-publish short-form videos automatically.</a:t>
-            </a:r>
-          </a:p>
-          <a:p>
-            <a:br/>
-            <a:pPr>
+                  <a:srgbClr val="FFE600"/>
+                </a:solidFill>
+              </a:defRPr>
+            </a:pPr>
+            <a:r>
+              <a:t>ViralFlow AI: Transforming Trends into Broadcast-Ready Content in 6 Seconds.</a:t>
+            </a:r>
+          </a:p>
+          <a:p>
+            <a:pPr>
+              <a:spcBef>
+                <a:spcPts val="1000"/>
+              </a:spcBef>
+              <a:defRPr sz="1500">
+                <a:solidFill>
+                  <a:srgbClr val="94A3B8"/>
+                </a:solidFill>
+              </a:defRPr>
+            </a:pPr>
+            <a:r>
+              <a:t>We invite judges and mentors to test our live deployment and review our open codebase:</a:t>
+            </a:r>
+          </a:p>
+          <a:p>
+            <a:pPr>
+              <a:spcBef>
+                <a:spcPts val="1400"/>
+              </a:spcBef>
               <a:defRPr sz="1800" b="1">
                 <a:solidFill>
                   <a:srgbClr val="00F0FF"/>
@@ -5357,11 +6357,14 @@
               </a:defRPr>
             </a:pPr>
             <a:r>
-              <a:t>Live Application URL: https://my-viralflow-ai.vercel.app</a:t>
-            </a:r>
-          </a:p>
-          <a:p>
-            <a:pPr>
+              <a:t>🚀 Live Web App: https://my-viralflow-ai.vercel.app</a:t>
+            </a:r>
+          </a:p>
+          <a:p>
+            <a:pPr>
+              <a:spcBef>
+                <a:spcPts val="800"/>
+              </a:spcBef>
               <a:defRPr sz="1800" b="1">
                 <a:solidFill>
                   <a:srgbClr val="FFFFFF"/>
@@ -5369,20 +6372,37 @@
               </a:defRPr>
             </a:pPr>
             <a:r>
-              <a:t>GitHub Repository: https://github.com/Ibrahim2637/ViralFlow.Ai</a:t>
-            </a:r>
-          </a:p>
-          <a:p>
-            <a:br/>
-            <a:pPr>
+              <a:t>💻 GitHub Repository: https://github.com/Ibrahim2637/ViralFlow.Ai</a:t>
+            </a:r>
+          </a:p>
+          <a:p>
+            <a:pPr>
+              <a:spcBef>
+                <a:spcPts val="800"/>
+              </a:spcBef>
+              <a:defRPr sz="1500">
+                <a:solidFill>
+                  <a:srgbClr val="00FFA3"/>
+                </a:solidFill>
+              </a:defRPr>
+            </a:pPr>
+            <a:r>
+              <a:t>⚡ n8n Webhook: https://primary-production-675a3.up.railway.app/webhook/viralflow-produce</a:t>
+            </a:r>
+          </a:p>
+          <a:p>
+            <a:pPr>
+              <a:spcBef>
+                <a:spcPts val="2000"/>
+              </a:spcBef>
               <a:defRPr sz="2000" b="1">
                 <a:solidFill>
-                  <a:srgbClr val="CCFF00"/>
-                </a:solidFill>
-              </a:defRPr>
-            </a:pPr>
-            <a:r>
-              <a:t>Thank you for evaluating ViralFlow AI!</a:t>
+                  <a:srgbClr val="FFE600"/>
+                </a:solidFill>
+              </a:defRPr>
+            </a:pPr>
+            <a:r>
+              <a:t>Thank you! We're ready for Questions &amp; Live Interactive Demo.</a:t>
             </a:r>
           </a:p>
         </p:txBody>

</xml_diff>

<commit_message>
docs: remove pricing slide from hackathon presentation while preserving original layout and styling
</commit_message>
<xml_diff>
--- a/ViralFlow_AI_Hackathon_Presentation.pptx
+++ b/ViralFlow_AI_Hackathon_Presentation.pptx
@@ -10,9 +10,7 @@
     <p:sldId id="258" r:id="rId9"/>
     <p:sldId id="259" r:id="rId10"/>
     <p:sldId id="260" r:id="rId11"/>
-    <p:sldId id="261" r:id="rId12"/>
     <p:sldId id="262" r:id="rId13"/>
-    <p:sldId id="263" r:id="rId14"/>
   </p:sldIdLst>
   <p:sldSz cx="12191695" cy="6858000" type="screen4x3"/>
   <p:notesSz cx="6858000" cy="9144000"/>
@@ -3110,10 +3108,12 @@
             <a:avLst/>
           </a:prstGeom>
           <a:solidFill>
-            <a:srgbClr val="0A0C12"/>
+            <a:srgbClr val="0A0A0F"/>
           </a:solidFill>
           <a:ln>
-            <a:noFill/>
+            <a:solidFill>
+              <a:srgbClr val="0A0A0F"/>
+            </a:solidFill>
           </a:ln>
         </p:spPr>
         <p:style>
@@ -3146,14 +3146,14 @@
         </p:nvSpPr>
         <p:spPr>
           <a:xfrm>
-            <a:off x="731520" y="822960"/>
-            <a:ext cx="3840480" cy="384048"/>
+            <a:off x="731520" y="1097280"/>
+            <a:ext cx="3474720" cy="411480"/>
           </a:xfrm>
           <a:prstGeom prst="roundRect">
             <a:avLst/>
           </a:prstGeom>
           <a:solidFill>
-            <a:srgbClr val="141824"/>
+            <a:srgbClr val="161823"/>
           </a:solidFill>
           <a:ln>
             <a:solidFill>
@@ -3187,7 +3187,7 @@
               </a:defRPr>
             </a:pPr>
             <a:r>
-              <a:t>⚡ NEXT-GEN HACKATHON DEMO</a:t>
+              <a:t>AUTONOMOUS AGENTIC PIPELINE</a:t>
             </a:r>
           </a:p>
         </p:txBody>
@@ -3200,8 +3200,8 @@
         </p:nvSpPr>
         <p:spPr>
           <a:xfrm>
-            <a:off x="731520" y="1371600"/>
-            <a:ext cx="10698480" cy="2011680"/>
+            <a:off x="731520" y="1737360"/>
+            <a:ext cx="10515600" cy="1645920"/>
           </a:xfrm>
           <a:prstGeom prst="rect">
             <a:avLst/>
@@ -3209,310 +3209,46 @@
           <a:noFill/>
         </p:spPr>
         <p:txBody>
-          <a:bodyPr wrap="square" lIns="0" tIns="0" rIns="0" bIns="0">
+          <a:bodyPr wrap="square">
             <a:spAutoFit/>
           </a:bodyPr>
           <a:lstStyle/>
           <a:p>
             <a:pPr>
-              <a:defRPr sz="5400" b="1">
-                <a:solidFill>
-                  <a:srgbClr val="FFE600"/>
-                </a:solidFill>
-                <a:latin typeface="Segoe UI"/>
+              <a:defRPr sz="5600" b="1">
+                <a:solidFill>
+                  <a:srgbClr val="CCFF00"/>
+                </a:solidFill>
               </a:defRPr>
             </a:pPr>
             <a:r>
-              <a:t>ViralFlow AI 2.0</a:t>
+              <a:t>VIRALFLOW AI</a:t>
             </a:r>
           </a:p>
           <a:p>
             <a:pPr>
-              <a:spcBef>
-                <a:spcPts val="800"/>
-              </a:spcBef>
-              <a:defRPr sz="2400" b="1">
+              <a:defRPr sz="2400">
                 <a:solidFill>
                   <a:srgbClr val="FFFFFF"/>
                 </a:solidFill>
-                <a:latin typeface="Segoe UI"/>
               </a:defRPr>
             </a:pPr>
             <a:r>
-              <a:t>Autonomous Multi-Agent Video Engine for Tech Creators</a:t>
-            </a:r>
-          </a:p>
-          <a:p>
-            <a:pPr>
-              <a:spcBef>
-                <a:spcPts val="800"/>
-              </a:spcBef>
-              <a:defRPr sz="1600">
-                <a:solidFill>
-                  <a:srgbClr val="94A3B8"/>
-                </a:solidFill>
-                <a:latin typeface="Segoe UI"/>
-              </a:defRPr>
-            </a:pPr>
-            <a:r>
-              <a:t>From live web &amp; social trends to a broadcast-ready 9:16 short-form video package in under 6 seconds.</a:t>
-            </a:r>
-          </a:p>
-        </p:txBody>
-      </p:sp>
-      <p:sp>
-        <p:nvSpPr>
-          <p:cNvPr id="5" name="Rounded Rectangle 4"/>
-          <p:cNvSpPr/>
-          <p:nvPr/>
-        </p:nvSpPr>
-        <p:spPr>
-          <a:xfrm>
-            <a:off x="731520" y="3840480"/>
-            <a:ext cx="3383280" cy="1645920"/>
-          </a:xfrm>
-          <a:prstGeom prst="roundRect">
-            <a:avLst/>
-          </a:prstGeom>
-          <a:solidFill>
-            <a:srgbClr val="141824"/>
-          </a:solidFill>
-          <a:ln>
-            <a:solidFill>
-              <a:srgbClr val="00F0FF"/>
-            </a:solidFill>
-          </a:ln>
-        </p:spPr>
-        <p:style>
-          <a:lnRef idx="1">
-            <a:schemeClr val="accent1"/>
-          </a:lnRef>
-          <a:fillRef idx="3">
-            <a:schemeClr val="accent1"/>
-          </a:fillRef>
-          <a:effectRef idx="2">
-            <a:schemeClr val="accent1"/>
-          </a:effectRef>
-          <a:fontRef idx="minor">
-            <a:schemeClr val="lt1"/>
-          </a:fontRef>
-        </p:style>
-        <p:txBody>
-          <a:bodyPr rtlCol="0" anchor="ctr" wrap="square"/>
-          <a:lstStyle/>
-          <a:p>
-            <a:pPr algn="ctr">
-              <a:defRPr sz="2200" b="1">
-                <a:solidFill>
-                  <a:srgbClr val="00F0FF"/>
-                </a:solidFill>
-              </a:defRPr>
-            </a:pPr>
-            <a:r>
-              <a:t>6 SECONDS</a:t>
-            </a:r>
-          </a:p>
-          <a:p>
-            <a:pPr>
-              <a:spcBef>
-                <a:spcPts val="400"/>
-              </a:spcBef>
-              <a:defRPr sz="1300" b="1">
-                <a:solidFill>
-                  <a:srgbClr val="FFFFFF"/>
-                </a:solidFill>
-              </a:defRPr>
-            </a:pPr>
-            <a:r>
-              <a:t>Autonomous Pipeline</a:t>
-            </a:r>
-          </a:p>
-          <a:p>
-            <a:pPr>
-              <a:defRPr sz="1100">
-                <a:solidFill>
-                  <a:srgbClr val="94A3B8"/>
-                </a:solidFill>
-              </a:defRPr>
-            </a:pPr>
-            <a:r>
-              <a:t>Zero manual timeline editing required</a:t>
-            </a:r>
-          </a:p>
-        </p:txBody>
-      </p:sp>
-      <p:sp>
-        <p:nvSpPr>
-          <p:cNvPr id="6" name="Rounded Rectangle 5"/>
-          <p:cNvSpPr/>
-          <p:nvPr/>
-        </p:nvSpPr>
-        <p:spPr>
-          <a:xfrm>
-            <a:off x="4389120" y="3840480"/>
-            <a:ext cx="3383280" cy="1645920"/>
-          </a:xfrm>
-          <a:prstGeom prst="roundRect">
-            <a:avLst/>
-          </a:prstGeom>
-          <a:solidFill>
-            <a:srgbClr val="141824"/>
-          </a:solidFill>
-          <a:ln>
-            <a:solidFill>
-              <a:srgbClr val="262E44"/>
-            </a:solidFill>
-          </a:ln>
-        </p:spPr>
-        <p:style>
-          <a:lnRef idx="1">
-            <a:schemeClr val="accent1"/>
-          </a:lnRef>
-          <a:fillRef idx="3">
-            <a:schemeClr val="accent1"/>
-          </a:fillRef>
-          <a:effectRef idx="2">
-            <a:schemeClr val="accent1"/>
-          </a:effectRef>
-          <a:fontRef idx="minor">
-            <a:schemeClr val="lt1"/>
-          </a:fontRef>
-        </p:style>
-        <p:txBody>
-          <a:bodyPr rtlCol="0" anchor="ctr" wrap="square"/>
-          <a:lstStyle/>
-          <a:p>
-            <a:pPr algn="ctr">
-              <a:defRPr sz="2200" b="1">
-                <a:solidFill>
-                  <a:srgbClr val="00FFA3"/>
-                </a:solidFill>
-              </a:defRPr>
-            </a:pPr>
-            <a:r>
-              <a:t>100% FACT-CHECKED</a:t>
-            </a:r>
-          </a:p>
-          <a:p>
-            <a:pPr>
-              <a:spcBef>
-                <a:spcPts val="400"/>
-              </a:spcBef>
-              <a:defRPr sz="1300" b="1">
-                <a:solidFill>
-                  <a:srgbClr val="FFFFFF"/>
-                </a:solidFill>
-              </a:defRPr>
-            </a:pPr>
-            <a:r>
-              <a:t>Anti-Hallucination</a:t>
-            </a:r>
-          </a:p>
-          <a:p>
-            <a:pPr>
-              <a:defRPr sz="1100">
-                <a:solidFill>
-                  <a:srgbClr val="94A3B8"/>
-                </a:solidFill>
-              </a:defRPr>
-            </a:pPr>
-            <a:r>
-              <a:t>Multi-pass verification guardrails</a:t>
-            </a:r>
-          </a:p>
-        </p:txBody>
-      </p:sp>
-      <p:sp>
-        <p:nvSpPr>
-          <p:cNvPr id="7" name="Rounded Rectangle 6"/>
-          <p:cNvSpPr/>
-          <p:nvPr/>
-        </p:nvSpPr>
-        <p:spPr>
-          <a:xfrm>
-            <a:off x="8046720" y="3840480"/>
-            <a:ext cx="3383280" cy="1645920"/>
-          </a:xfrm>
-          <a:prstGeom prst="roundRect">
-            <a:avLst/>
-          </a:prstGeom>
-          <a:solidFill>
-            <a:srgbClr val="141824"/>
-          </a:solidFill>
-          <a:ln>
-            <a:solidFill>
-              <a:srgbClr val="262E44"/>
-            </a:solidFill>
-          </a:ln>
-        </p:spPr>
-        <p:style>
-          <a:lnRef idx="1">
-            <a:schemeClr val="accent1"/>
-          </a:lnRef>
-          <a:fillRef idx="3">
-            <a:schemeClr val="accent1"/>
-          </a:fillRef>
-          <a:effectRef idx="2">
-            <a:schemeClr val="accent1"/>
-          </a:effectRef>
-          <a:fontRef idx="minor">
-            <a:schemeClr val="lt1"/>
-          </a:fontRef>
-        </p:style>
-        <p:txBody>
-          <a:bodyPr rtlCol="0" anchor="ctr" wrap="square"/>
-          <a:lstStyle/>
-          <a:p>
-            <a:pPr algn="ctr">
-              <a:defRPr sz="2200" b="1">
-                <a:solidFill>
-                  <a:srgbClr val="FFE600"/>
-                </a:solidFill>
-              </a:defRPr>
-            </a:pPr>
-            <a:r>
-              <a:t>FULL-STACK READY</a:t>
-            </a:r>
-          </a:p>
-          <a:p>
-            <a:pPr>
-              <a:spcBef>
-                <a:spcPts val="400"/>
-              </a:spcBef>
-              <a:defRPr sz="1300" b="1">
-                <a:solidFill>
-                  <a:srgbClr val="FFFFFF"/>
-                </a:solidFill>
-              </a:defRPr>
-            </a:pPr>
-            <a:r>
-              <a:t>Production Manifest</a:t>
-            </a:r>
-          </a:p>
-          <a:p>
-            <a:pPr>
-              <a:defRPr sz="1100">
-                <a:solidFill>
-                  <a:srgbClr val="94A3B8"/>
-                </a:solidFill>
-              </a:defRPr>
-            </a:pPr>
-            <a:r>
-              <a:t>Kinetic captions, HD B-roll &amp; audio</a:t>
-            </a:r>
-          </a:p>
-        </p:txBody>
-      </p:sp>
-      <p:sp>
-        <p:nvSpPr>
-          <p:cNvPr id="8" name="TextBox 7"/>
+              <a:t>Self-Improving Multi-Agent Content Engine for Short-Form Video Creation</a:t>
+            </a:r>
+          </a:p>
+        </p:txBody>
+      </p:sp>
+      <p:sp>
+        <p:nvSpPr>
+          <p:cNvPr id="5" name="TextBox 4"/>
           <p:cNvSpPr txBox="1"/>
           <p:nvPr/>
         </p:nvSpPr>
         <p:spPr>
           <a:xfrm>
-            <a:off x="731520" y="5760720"/>
-            <a:ext cx="10698480" cy="548640"/>
+            <a:off x="731520" y="3657600"/>
+            <a:ext cx="10058400" cy="1097280"/>
           </a:xfrm>
           <a:prstGeom prst="rect">
             <a:avLst/>
@@ -3520,20 +3256,55 @@
           <a:noFill/>
         </p:spPr>
         <p:txBody>
+          <a:bodyPr wrap="square">
+            <a:spAutoFit/>
+          </a:bodyPr>
+          <a:lstStyle/>
+          <a:p>
+            <a:pPr>
+              <a:defRPr sz="1600">
+                <a:solidFill>
+                  <a:srgbClr val="A0A5B9"/>
+                </a:solidFill>
+              </a:defRPr>
+            </a:pPr>
+            <a:r>
+              <a:t>Automatically transforms live web and social trends into fully-rendered, fact-checked 9:16 vertical short-form videos for TikTok, YouTube Shorts, and Instagram Reels.</a:t>
+            </a:r>
+          </a:p>
+        </p:txBody>
+      </p:sp>
+      <p:sp>
+        <p:nvSpPr>
+          <p:cNvPr id="6" name="TextBox 5"/>
+          <p:cNvSpPr txBox="1"/>
+          <p:nvPr/>
+        </p:nvSpPr>
+        <p:spPr>
+          <a:xfrm>
+            <a:off x="731520" y="5303520"/>
+            <a:ext cx="10058400" cy="731520"/>
+          </a:xfrm>
+          <a:prstGeom prst="rect">
+            <a:avLst/>
+          </a:prstGeom>
+          <a:noFill/>
+        </p:spPr>
+        <p:txBody>
           <a:bodyPr wrap="none">
             <a:spAutoFit/>
           </a:bodyPr>
           <a:lstStyle/>
           <a:p>
             <a:pPr>
-              <a:defRPr sz="1300" b="1">
+              <a:defRPr sz="1400" b="1">
                 <a:solidFill>
                   <a:srgbClr val="00F0FF"/>
                 </a:solidFill>
               </a:defRPr>
             </a:pPr>
             <a:r>
-              <a:t>🌐 Live App: https://my-viralflow-ai.vercel.app    |    💻 GitHub: Ibrahim2637/ViralFlow.Ai</a:t>
+              <a:t>Live App: https://my-viralflow-ai.vercel.app  |  GitHub: Ibrahim2637/ViralFlow.Ai</a:t>
             </a:r>
           </a:p>
         </p:txBody>
@@ -3571,10 +3342,12 @@
             <a:avLst/>
           </a:prstGeom>
           <a:solidFill>
-            <a:srgbClr val="0A0C12"/>
+            <a:srgbClr val="0A0A0F"/>
           </a:solidFill>
           <a:ln>
-            <a:noFill/>
+            <a:solidFill>
+              <a:srgbClr val="0A0A0F"/>
+            </a:solidFill>
           </a:ln>
         </p:spPr>
         <p:style>
@@ -3608,7 +3381,7 @@
         <p:spPr>
           <a:xfrm>
             <a:off x="731520" y="365760"/>
-            <a:ext cx="10698480" cy="320040"/>
+            <a:ext cx="10058400" cy="365760"/>
           </a:xfrm>
           <a:prstGeom prst="rect">
             <a:avLst/>
@@ -3616,7 +3389,7 @@
           <a:noFill/>
         </p:spPr>
         <p:txBody>
-          <a:bodyPr wrap="square" lIns="0" tIns="0" rIns="0" bIns="0">
+          <a:bodyPr wrap="none">
             <a:spAutoFit/>
           </a:bodyPr>
           <a:lstStyle/>
@@ -3626,11 +3399,10 @@
                 <a:solidFill>
                   <a:srgbClr val="00F0FF"/>
                 </a:solidFill>
-                <a:latin typeface="Segoe UI"/>
               </a:defRPr>
             </a:pPr>
             <a:r>
-              <a:t>THE PROBLEM • MARKET PAIN</a:t>
+              <a:t>VIRALFLOW AI HACKATHON PRESENTATION</a:t>
             </a:r>
           </a:p>
         </p:txBody>
@@ -3643,8 +3415,8 @@
         </p:nvSpPr>
         <p:spPr>
           <a:xfrm>
-            <a:off x="731520" y="685800"/>
-            <a:ext cx="10698480" cy="594360"/>
+            <a:off x="731520" y="640080"/>
+            <a:ext cx="10058400" cy="731520"/>
           </a:xfrm>
           <a:prstGeom prst="rect">
             <a:avLst/>
@@ -3652,21 +3424,20 @@
           <a:noFill/>
         </p:spPr>
         <p:txBody>
-          <a:bodyPr wrap="square" lIns="0" tIns="0" rIns="0" bIns="0">
+          <a:bodyPr wrap="none">
             <a:spAutoFit/>
           </a:bodyPr>
           <a:lstStyle/>
           <a:p>
             <a:pPr>
-              <a:defRPr sz="2600" b="1">
+              <a:defRPr sz="2800" b="1">
                 <a:solidFill>
                   <a:srgbClr val="FFFFFF"/>
                 </a:solidFill>
-                <a:latin typeface="Segoe UI"/>
               </a:defRPr>
             </a:pPr>
             <a:r>
-              <a:t>Why Creating Viral Content Is Broken</a:t>
+              <a:t>THE PROBLEM: SHORT-FORM CONTENT BOTTLENECK</a:t>
             </a:r>
           </a:p>
         </p:txBody>
@@ -3680,17 +3451,17 @@
         <p:spPr>
           <a:xfrm>
             <a:off x="731520" y="1645920"/>
-            <a:ext cx="3383280" cy="4389120"/>
+            <a:ext cx="3291840" cy="4389120"/>
           </a:xfrm>
           <a:prstGeom prst="roundRect">
             <a:avLst/>
           </a:prstGeom>
           <a:solidFill>
-            <a:srgbClr val="141824"/>
+            <a:srgbClr val="161823"/>
           </a:solidFill>
           <a:ln>
             <a:solidFill>
-              <a:srgbClr val="262E44"/>
+              <a:srgbClr val="282D41"/>
             </a:solidFill>
           </a:ln>
         </p:spPr>
@@ -3713,59 +3484,27 @@
           <a:lstStyle/>
           <a:p>
             <a:pPr algn="ctr">
-              <a:defRPr sz="1000" b="1">
-                <a:solidFill>
-                  <a:srgbClr val="FFE600"/>
+              <a:defRPr sz="1800" b="1">
+                <a:solidFill>
+                  <a:srgbClr val="CCFF00"/>
                 </a:solidFill>
               </a:defRPr>
             </a:pPr>
             <a:r>
-              <a:t>MANUAL EDITING BOTTLENECK</a:t>
-            </a:r>
-          </a:p>
-          <a:p>
+              <a:t>4-6 Hours Spent Per Video</a:t>
+            </a:r>
+          </a:p>
+          <a:p>
+            <a:br/>
             <a:pPr>
-              <a:spcBef>
-                <a:spcPts val="400"/>
-              </a:spcBef>
-              <a:defRPr sz="1700" b="1">
-                <a:solidFill>
-                  <a:srgbClr val="FFFFFF"/>
+              <a:defRPr sz="1400">
+                <a:solidFill>
+                  <a:srgbClr val="A0A5B9"/>
                 </a:solidFill>
               </a:defRPr>
             </a:pPr>
             <a:r>
-              <a:t>⏳ 4 to 6 Hours Wasted Per Video</a:t>
-            </a:r>
-          </a:p>
-          <a:p>
-            <a:pPr>
-              <a:spcBef>
-                <a:spcPts val="1200"/>
-              </a:spcBef>
-              <a:defRPr sz="1300">
-                <a:solidFill>
-                  <a:srgbClr val="94A3B8"/>
-                </a:solidFill>
-              </a:defRPr>
-            </a:pPr>
-            <a:r>
-              <a:t>Creators waste hours daily scrolling for trending topics, writing hooks, splicing B-roll footage, and manually adjusting subtitle timings in Premiere or CapCut.</a:t>
-            </a:r>
-          </a:p>
-          <a:p>
-            <a:pPr>
-              <a:spcBef>
-                <a:spcPts val="1400"/>
-              </a:spcBef>
-              <a:defRPr sz="1200" b="1">
-                <a:solidFill>
-                  <a:srgbClr val="00F0FF"/>
-                </a:solidFill>
-              </a:defRPr>
-            </a:pPr>
-            <a:r>
-              <a:t>⚡ Result: Inability to post daily, falling behind the algorithm.</a:t>
+              <a:t>Creators and marketers waste hours daily researching trending topics, drafting scripts, and editing short-form timeline cuts.</a:t>
             </a:r>
           </a:p>
         </p:txBody>
@@ -3778,18 +3517,18 @@
         </p:nvSpPr>
         <p:spPr>
           <a:xfrm>
-            <a:off x="4389120" y="1645920"/>
-            <a:ext cx="3383280" cy="4389120"/>
+            <a:off x="4297680" y="1645920"/>
+            <a:ext cx="3291840" cy="4389120"/>
           </a:xfrm>
           <a:prstGeom prst="roundRect">
             <a:avLst/>
           </a:prstGeom>
           <a:solidFill>
-            <a:srgbClr val="141824"/>
+            <a:srgbClr val="161823"/>
           </a:solidFill>
           <a:ln>
             <a:solidFill>
-              <a:srgbClr val="262E44"/>
+              <a:srgbClr val="282D41"/>
             </a:solidFill>
           </a:ln>
         </p:spPr>
@@ -3812,59 +3551,27 @@
           <a:lstStyle/>
           <a:p>
             <a:pPr algn="ctr">
-              <a:defRPr sz="1000" b="1">
-                <a:solidFill>
-                  <a:srgbClr val="FFE600"/>
+              <a:defRPr sz="1800" b="1">
+                <a:solidFill>
+                  <a:srgbClr val="CCFF00"/>
                 </a:solidFill>
               </a:defRPr>
             </a:pPr>
             <a:r>
-              <a:t>ACCURACY CRISIS</a:t>
-            </a:r>
-          </a:p>
-          <a:p>
+              <a:t>AI Hallucination and Risk</a:t>
+            </a:r>
+          </a:p>
+          <a:p>
+            <a:br/>
             <a:pPr>
-              <a:spcBef>
-                <a:spcPts val="400"/>
-              </a:spcBef>
-              <a:defRPr sz="1700" b="1">
-                <a:solidFill>
-                  <a:srgbClr val="FFFFFF"/>
+              <a:defRPr sz="1400">
+                <a:solidFill>
+                  <a:srgbClr val="A0A5B9"/>
                 </a:solidFill>
               </a:defRPr>
             </a:pPr>
             <a:r>
-              <a:t>⚠️ AI Hallucinations &amp; Reputational Risk</a:t>
-            </a:r>
-          </a:p>
-          <a:p>
-            <a:pPr>
-              <a:spcBef>
-                <a:spcPts val="1200"/>
-              </a:spcBef>
-              <a:defRPr sz="1300">
-                <a:solidFill>
-                  <a:srgbClr val="94A3B8"/>
-                </a:solidFill>
-              </a:defRPr>
-            </a:pPr>
-            <a:r>
-              <a:t>Generic AI tools generate fake statistics, out-of-date news, and fabricated claims that destroy creator credibility and brand trust in developer communities.</a:t>
-            </a:r>
-          </a:p>
-          <a:p>
-            <a:pPr>
-              <a:spcBef>
-                <a:spcPts val="1400"/>
-              </a:spcBef>
-              <a:defRPr sz="1200" b="1">
-                <a:solidFill>
-                  <a:srgbClr val="00F0FF"/>
-                </a:solidFill>
-              </a:defRPr>
-            </a:pPr>
-            <a:r>
-              <a:t>⚡ Result: Creators spend more time fact-checking than creating.</a:t>
+              <a:t>Generic AI script tools output unverified numbers, fake guarantees, and high-risk claims that ruin brand reputation.</a:t>
             </a:r>
           </a:p>
         </p:txBody>
@@ -3877,18 +3584,18 @@
         </p:nvSpPr>
         <p:spPr>
           <a:xfrm>
-            <a:off x="8046720" y="1645920"/>
-            <a:ext cx="3383280" cy="4389120"/>
+            <a:off x="7863840" y="1645920"/>
+            <a:ext cx="3291840" cy="4389120"/>
           </a:xfrm>
           <a:prstGeom prst="roundRect">
             <a:avLst/>
           </a:prstGeom>
           <a:solidFill>
-            <a:srgbClr val="141824"/>
+            <a:srgbClr val="161823"/>
           </a:solidFill>
           <a:ln>
             <a:solidFill>
-              <a:srgbClr val="262E44"/>
+              <a:srgbClr val="282D41"/>
             </a:solidFill>
           </a:ln>
         </p:spPr>
@@ -3911,59 +3618,27 @@
           <a:lstStyle/>
           <a:p>
             <a:pPr algn="ctr">
-              <a:defRPr sz="1000" b="1">
-                <a:solidFill>
-                  <a:srgbClr val="FFE600"/>
+              <a:defRPr sz="1800" b="1">
+                <a:solidFill>
+                  <a:srgbClr val="CCFF00"/>
                 </a:solidFill>
               </a:defRPr>
             </a:pPr>
             <a:r>
-              <a:t>ALGORITHM CHURN</a:t>
-            </a:r>
-          </a:p>
-          <a:p>
+              <a:t>Creator Burnout</a:t>
+            </a:r>
+          </a:p>
+          <a:p>
+            <a:br/>
             <a:pPr>
-              <a:spcBef>
-                <a:spcPts val="400"/>
-              </a:spcBef>
-              <a:defRPr sz="1700" b="1">
-                <a:solidFill>
-                  <a:srgbClr val="FFFFFF"/>
+              <a:defRPr sz="1400">
+                <a:solidFill>
+                  <a:srgbClr val="A0A5B9"/>
                 </a:solidFill>
               </a:defRPr>
             </a:pPr>
             <a:r>
-              <a:t>🔥 Inconsistent Hook Velocity &amp; Burnout</a:t>
-            </a:r>
-          </a:p>
-          <a:p>
-            <a:pPr>
-              <a:spcBef>
-                <a:spcPts val="1200"/>
-              </a:spcBef>
-              <a:defRPr sz="1300">
-                <a:solidFill>
-                  <a:srgbClr val="94A3B8"/>
-                </a:solidFill>
-              </a:defRPr>
-            </a:pPr>
-            <a:r>
-              <a:t>90% of video viewers drop off in the first 2 seconds. Crafting retention-engineered hooks with kinetic motion design consistently is impossible for solo builders.</a:t>
-            </a:r>
-          </a:p>
-          <a:p>
-            <a:pPr>
-              <a:spcBef>
-                <a:spcPts val="1400"/>
-              </a:spcBef>
-              <a:defRPr sz="1200" b="1">
-                <a:solidFill>
-                  <a:srgbClr val="00F0FF"/>
-                </a:solidFill>
-              </a:defRPr>
-            </a:pPr>
-            <a:r>
-              <a:t>⚡ Result: 82% creator burnout rate within their first 6 months.</a:t>
+              <a:t>Maintaining daily 9:16 vertical video output across TikTok, Shorts, and Reels is exhausting, causing content drop-off.</a:t>
             </a:r>
           </a:p>
         </p:txBody>
@@ -4001,10 +3676,12 @@
             <a:avLst/>
           </a:prstGeom>
           <a:solidFill>
-            <a:srgbClr val="0A0C12"/>
+            <a:srgbClr val="0A0A0F"/>
           </a:solidFill>
           <a:ln>
-            <a:noFill/>
+            <a:solidFill>
+              <a:srgbClr val="0A0A0F"/>
+            </a:solidFill>
           </a:ln>
         </p:spPr>
         <p:style>
@@ -4038,7 +3715,7 @@
         <p:spPr>
           <a:xfrm>
             <a:off x="731520" y="365760"/>
-            <a:ext cx="10698480" cy="320040"/>
+            <a:ext cx="10058400" cy="365760"/>
           </a:xfrm>
           <a:prstGeom prst="rect">
             <a:avLst/>
@@ -4046,7 +3723,7 @@
           <a:noFill/>
         </p:spPr>
         <p:txBody>
-          <a:bodyPr wrap="square" lIns="0" tIns="0" rIns="0" bIns="0">
+          <a:bodyPr wrap="none">
             <a:spAutoFit/>
           </a:bodyPr>
           <a:lstStyle/>
@@ -4056,11 +3733,10 @@
                 <a:solidFill>
                   <a:srgbClr val="00F0FF"/>
                 </a:solidFill>
-                <a:latin typeface="Segoe UI"/>
               </a:defRPr>
             </a:pPr>
             <a:r>
-              <a:t>THE SOLUTION • MULTI-AGENT SWARM</a:t>
+              <a:t>VIRALFLOW AI HACKATHON PRESENTATION</a:t>
             </a:r>
           </a:p>
         </p:txBody>
@@ -4073,8 +3749,8 @@
         </p:nvSpPr>
         <p:spPr>
           <a:xfrm>
-            <a:off x="731520" y="685800"/>
-            <a:ext cx="10698480" cy="594360"/>
+            <a:off x="731520" y="640080"/>
+            <a:ext cx="10058400" cy="731520"/>
           </a:xfrm>
           <a:prstGeom prst="rect">
             <a:avLst/>
@@ -4082,21 +3758,20 @@
           <a:noFill/>
         </p:spPr>
         <p:txBody>
-          <a:bodyPr wrap="square" lIns="0" tIns="0" rIns="0" bIns="0">
+          <a:bodyPr wrap="none">
             <a:spAutoFit/>
           </a:bodyPr>
           <a:lstStyle/>
           <a:p>
             <a:pPr>
-              <a:defRPr sz="2600" b="1">
+              <a:defRPr sz="2800" b="1">
                 <a:solidFill>
                   <a:srgbClr val="FFFFFF"/>
                 </a:solidFill>
-                <a:latin typeface="Segoe UI"/>
               </a:defRPr>
             </a:pPr>
             <a:r>
-              <a:t>ViralFlow AI: Autonomous Content Intelligence</a:t>
+              <a:t>THE SOLUTION: VIRALFLOW AI</a:t>
             </a:r>
           </a:p>
         </p:txBody>
@@ -4110,211 +3785,13 @@
         <p:spPr>
           <a:xfrm>
             <a:off x="731520" y="1645920"/>
-            <a:ext cx="2560320" cy="4389120"/>
+            <a:ext cx="3291840" cy="4389120"/>
           </a:xfrm>
           <a:prstGeom prst="roundRect">
             <a:avLst/>
           </a:prstGeom>
           <a:solidFill>
-            <a:srgbClr val="141824"/>
-          </a:solidFill>
-          <a:ln>
-            <a:solidFill>
-              <a:srgbClr val="262E44"/>
-            </a:solidFill>
-          </a:ln>
-        </p:spPr>
-        <p:style>
-          <a:lnRef idx="1">
-            <a:schemeClr val="accent1"/>
-          </a:lnRef>
-          <a:fillRef idx="3">
-            <a:schemeClr val="accent1"/>
-          </a:fillRef>
-          <a:effectRef idx="2">
-            <a:schemeClr val="accent1"/>
-          </a:effectRef>
-          <a:fontRef idx="minor">
-            <a:schemeClr val="lt1"/>
-          </a:fontRef>
-        </p:style>
-        <p:txBody>
-          <a:bodyPr rtlCol="0" anchor="ctr" wrap="square"/>
-          <a:lstStyle/>
-          <a:p>
-            <a:pPr algn="ctr">
-              <a:defRPr sz="1400" b="1">
-                <a:solidFill>
-                  <a:srgbClr val="00F0FF"/>
-                </a:solidFill>
-              </a:defRPr>
-            </a:pPr>
-            <a:r>
-              <a:t>1. SCOUT AGENT</a:t>
-            </a:r>
-          </a:p>
-          <a:p>
-            <a:pPr>
-              <a:spcBef>
-                <a:spcPts val="400"/>
-              </a:spcBef>
-              <a:defRPr sz="1500" b="1">
-                <a:solidFill>
-                  <a:srgbClr val="FFFFFF"/>
-                </a:solidFill>
-              </a:defRPr>
-            </a:pPr>
-            <a:r>
-              <a:t>Trend Radar &amp; Scoring</a:t>
-            </a:r>
-          </a:p>
-          <a:p>
-            <a:pPr>
-              <a:spcBef>
-                <a:spcPts val="800"/>
-              </a:spcBef>
-              <a:defRPr sz="1000" b="1">
-                <a:solidFill>
-                  <a:srgbClr val="FFE600"/>
-                </a:solidFill>
-              </a:defRPr>
-            </a:pPr>
-            <a:r>
-              <a:t>● Autonomous Web &amp; Social Signals</a:t>
-            </a:r>
-          </a:p>
-          <a:p>
-            <a:pPr>
-              <a:spcBef>
-                <a:spcPts val="1000"/>
-              </a:spcBef>
-              <a:defRPr sz="1200">
-                <a:solidFill>
-                  <a:srgbClr val="94A3B8"/>
-                </a:solidFill>
-              </a:defRPr>
-            </a:pPr>
-            <a:r>
-              <a:t>Continuously scans real-time tech queries and social velocity to identify high-potential opportunity topics with proven audience search demand.</a:t>
-            </a:r>
-          </a:p>
-        </p:txBody>
-      </p:sp>
-      <p:sp>
-        <p:nvSpPr>
-          <p:cNvPr id="6" name="Rounded Rectangle 5"/>
-          <p:cNvSpPr/>
-          <p:nvPr/>
-        </p:nvSpPr>
-        <p:spPr>
-          <a:xfrm>
-            <a:off x="3456432" y="1645920"/>
-            <a:ext cx="2560320" cy="4389120"/>
-          </a:xfrm>
-          <a:prstGeom prst="roundRect">
-            <a:avLst/>
-          </a:prstGeom>
-          <a:solidFill>
-            <a:srgbClr val="141824"/>
-          </a:solidFill>
-          <a:ln>
-            <a:solidFill>
-              <a:srgbClr val="262E44"/>
-            </a:solidFill>
-          </a:ln>
-        </p:spPr>
-        <p:style>
-          <a:lnRef idx="1">
-            <a:schemeClr val="accent1"/>
-          </a:lnRef>
-          <a:fillRef idx="3">
-            <a:schemeClr val="accent1"/>
-          </a:fillRef>
-          <a:effectRef idx="2">
-            <a:schemeClr val="accent1"/>
-          </a:effectRef>
-          <a:fontRef idx="minor">
-            <a:schemeClr val="lt1"/>
-          </a:fontRef>
-        </p:style>
-        <p:txBody>
-          <a:bodyPr rtlCol="0" anchor="ctr" wrap="square"/>
-          <a:lstStyle/>
-          <a:p>
-            <a:pPr algn="ctr">
-              <a:defRPr sz="1400" b="1">
-                <a:solidFill>
-                  <a:srgbClr val="00F0FF"/>
-                </a:solidFill>
-              </a:defRPr>
-            </a:pPr>
-            <a:r>
-              <a:t>2. STRATEGY AGENT</a:t>
-            </a:r>
-          </a:p>
-          <a:p>
-            <a:pPr>
-              <a:spcBef>
-                <a:spcPts val="400"/>
-              </a:spcBef>
-              <a:defRPr sz="1500" b="1">
-                <a:solidFill>
-                  <a:srgbClr val="FFFFFF"/>
-                </a:solidFill>
-              </a:defRPr>
-            </a:pPr>
-            <a:r>
-              <a:t>Creator DNA &amp; Hooks</a:t>
-            </a:r>
-          </a:p>
-          <a:p>
-            <a:pPr>
-              <a:spcBef>
-                <a:spcPts val="800"/>
-              </a:spcBef>
-              <a:defRPr sz="1000" b="1">
-                <a:solidFill>
-                  <a:srgbClr val="FFE600"/>
-                </a:solidFill>
-              </a:defRPr>
-            </a:pPr>
-            <a:r>
-              <a:t>● Personalized Voice &amp; Retention</a:t>
-            </a:r>
-          </a:p>
-          <a:p>
-            <a:pPr>
-              <a:spcBef>
-                <a:spcPts val="1000"/>
-              </a:spcBef>
-              <a:defRPr sz="1200">
-                <a:solidFill>
-                  <a:srgbClr val="94A3B8"/>
-                </a:solidFill>
-              </a:defRPr>
-            </a:pPr>
-            <a:r>
-              <a:t>Synthesizes pattern-interrupt hooks based on the creator's exact tone, vocabulary, and audience persona to ensure high viewer retention.</a:t>
-            </a:r>
-          </a:p>
-        </p:txBody>
-      </p:sp>
-      <p:sp>
-        <p:nvSpPr>
-          <p:cNvPr id="7" name="Rounded Rectangle 6"/>
-          <p:cNvSpPr/>
-          <p:nvPr/>
-        </p:nvSpPr>
-        <p:spPr>
-          <a:xfrm>
-            <a:off x="6181344" y="1645920"/>
-            <a:ext cx="2560320" cy="4389120"/>
-          </a:xfrm>
-          <a:prstGeom prst="roundRect">
-            <a:avLst/>
-          </a:prstGeom>
-          <a:solidFill>
-            <a:srgbClr val="141824"/>
+            <a:srgbClr val="161823"/>
           </a:solidFill>
           <a:ln>
             <a:solidFill>
@@ -4341,83 +3818,51 @@
           <a:lstStyle/>
           <a:p>
             <a:pPr algn="ctr">
-              <a:defRPr sz="1400" b="1">
-                <a:solidFill>
-                  <a:srgbClr val="00FFA3"/>
+              <a:defRPr sz="1800" b="1">
+                <a:solidFill>
+                  <a:srgbClr val="00F0FF"/>
                 </a:solidFill>
               </a:defRPr>
             </a:pPr>
             <a:r>
-              <a:t>3. GUARDRAIL AGENT</a:t>
-            </a:r>
-          </a:p>
-          <a:p>
+              <a:t>Creator DNA Engine</a:t>
+            </a:r>
+          </a:p>
+          <a:p>
+            <a:br/>
             <a:pPr>
-              <a:spcBef>
-                <a:spcPts val="400"/>
-              </a:spcBef>
-              <a:defRPr sz="1500" b="1">
+              <a:defRPr sz="1400">
                 <a:solidFill>
                   <a:srgbClr val="FFFFFF"/>
                 </a:solidFill>
               </a:defRPr>
             </a:pPr>
             <a:r>
-              <a:t>Verification &amp; Fact-Check</a:t>
-            </a:r>
-          </a:p>
-          <a:p>
-            <a:pPr>
-              <a:spcBef>
-                <a:spcPts val="800"/>
-              </a:spcBef>
-              <a:defRPr sz="1000" b="1">
-                <a:solidFill>
-                  <a:srgbClr val="FFE600"/>
-                </a:solidFill>
-              </a:defRPr>
-            </a:pPr>
-            <a:r>
-              <a:t>● Zero-Tolerance Hallucination Check</a:t>
-            </a:r>
-          </a:p>
-          <a:p>
-            <a:pPr>
-              <a:spcBef>
-                <a:spcPts val="1000"/>
-              </a:spcBef>
-              <a:defRPr sz="1200">
-                <a:solidFill>
-                  <a:srgbClr val="94A3B8"/>
-                </a:solidFill>
-              </a:defRPr>
-            </a:pPr>
-            <a:r>
-              <a:t>Audits every numerical claim, technology comparison, and temporal stat against verified web knowledge before entering production.</a:t>
-            </a:r>
-          </a:p>
-        </p:txBody>
-      </p:sp>
-      <p:sp>
-        <p:nvSpPr>
-          <p:cNvPr id="8" name="Rounded Rectangle 7"/>
+              <a:t>Learns audience demographics, creator tone, vocabulary, and proven hook patterns for strict brand voice alignment.</a:t>
+            </a:r>
+          </a:p>
+        </p:txBody>
+      </p:sp>
+      <p:sp>
+        <p:nvSpPr>
+          <p:cNvPr id="6" name="Rounded Rectangle 5"/>
           <p:cNvSpPr/>
           <p:nvPr/>
         </p:nvSpPr>
         <p:spPr>
           <a:xfrm>
-            <a:off x="8906256" y="1645920"/>
-            <a:ext cx="2560320" cy="4389120"/>
+            <a:off x="4297680" y="1645920"/>
+            <a:ext cx="3291840" cy="4389120"/>
           </a:xfrm>
           <a:prstGeom prst="roundRect">
             <a:avLst/>
           </a:prstGeom>
           <a:solidFill>
-            <a:srgbClr val="141824"/>
+            <a:srgbClr val="161823"/>
           </a:solidFill>
           <a:ln>
             <a:solidFill>
-              <a:srgbClr val="262E44"/>
+              <a:srgbClr val="00F0FF"/>
             </a:solidFill>
           </a:ln>
         </p:spPr>
@@ -4440,59 +3885,94 @@
           <a:lstStyle/>
           <a:p>
             <a:pPr algn="ctr">
-              <a:defRPr sz="1400" b="1">
+              <a:defRPr sz="1800" b="1">
                 <a:solidFill>
                   <a:srgbClr val="00F0FF"/>
                 </a:solidFill>
               </a:defRPr>
             </a:pPr>
             <a:r>
-              <a:t>4. RENDER AGENT</a:t>
-            </a:r>
-          </a:p>
-          <a:p>
+              <a:t>Factual Guardrail Queue</a:t>
+            </a:r>
+          </a:p>
+          <a:p>
+            <a:br/>
             <a:pPr>
-              <a:spcBef>
-                <a:spcPts val="400"/>
-              </a:spcBef>
-              <a:defRPr sz="1500" b="1">
+              <a:defRPr sz="1400">
                 <a:solidFill>
                   <a:srgbClr val="FFFFFF"/>
                 </a:solidFill>
               </a:defRPr>
             </a:pPr>
             <a:r>
-              <a:t>Motion Graphics Pipeline</a:t>
-            </a:r>
-          </a:p>
-          <a:p>
+              <a:t>Audits every generated claim for numerical accuracy and time-sensitivity before video compilation.</a:t>
+            </a:r>
+          </a:p>
+        </p:txBody>
+      </p:sp>
+      <p:sp>
+        <p:nvSpPr>
+          <p:cNvPr id="7" name="Rounded Rectangle 6"/>
+          <p:cNvSpPr/>
+          <p:nvPr/>
+        </p:nvSpPr>
+        <p:spPr>
+          <a:xfrm>
+            <a:off x="7863840" y="1645920"/>
+            <a:ext cx="3291840" cy="4389120"/>
+          </a:xfrm>
+          <a:prstGeom prst="roundRect">
+            <a:avLst/>
+          </a:prstGeom>
+          <a:solidFill>
+            <a:srgbClr val="161823"/>
+          </a:solidFill>
+          <a:ln>
+            <a:solidFill>
+              <a:srgbClr val="00F0FF"/>
+            </a:solidFill>
+          </a:ln>
+        </p:spPr>
+        <p:style>
+          <a:lnRef idx="1">
+            <a:schemeClr val="accent1"/>
+          </a:lnRef>
+          <a:fillRef idx="3">
+            <a:schemeClr val="accent1"/>
+          </a:fillRef>
+          <a:effectRef idx="2">
+            <a:schemeClr val="accent1"/>
+          </a:effectRef>
+          <a:fontRef idx="minor">
+            <a:schemeClr val="lt1"/>
+          </a:fontRef>
+        </p:style>
+        <p:txBody>
+          <a:bodyPr rtlCol="0" anchor="ctr" wrap="square"/>
+          <a:lstStyle/>
+          <a:p>
+            <a:pPr algn="ctr">
+              <a:defRPr sz="1800" b="1">
+                <a:solidFill>
+                  <a:srgbClr val="00F0FF"/>
+                </a:solidFill>
+              </a:defRPr>
+            </a:pPr>
+            <a:r>
+              <a:t>9:16 Vertical Video Renderer</a:t>
+            </a:r>
+          </a:p>
+          <a:p>
+            <a:br/>
             <a:pPr>
-              <a:spcBef>
-                <a:spcPts val="800"/>
-              </a:spcBef>
-              <a:defRPr sz="1000" b="1">
-                <a:solidFill>
-                  <a:srgbClr val="FFE600"/>
+              <a:defRPr sz="1400">
+                <a:solidFill>
+                  <a:srgbClr val="FFFFFF"/>
                 </a:solidFill>
               </a:defRPr>
             </a:pPr>
             <a:r>
-              <a:t>● Full 9:16 Video Synthesis</a:t>
-            </a:r>
-          </a:p>
-          <a:p>
-            <a:pPr>
-              <a:spcBef>
-                <a:spcPts val="1000"/>
-              </a:spcBef>
-              <a:defRPr sz="1200">
-                <a:solidFill>
-                  <a:srgbClr val="94A3B8"/>
-                </a:solidFill>
-              </a:defRPr>
-            </a:pPr>
-            <a:r>
-              <a:t>Ranks vertical HD B-roll, overlays kinetic bounce captions, top progress bar, tech HUD frame, and generates speech audio via ElevenLabs.</a:t>
+              <a:t>Combines ElevenLabs AI voiceover, Pexels portrait B-roll, and Shotstack MP4 video compilation automatically.</a:t>
             </a:r>
           </a:p>
         </p:txBody>
@@ -4530,10 +4010,12 @@
             <a:avLst/>
           </a:prstGeom>
           <a:solidFill>
-            <a:srgbClr val="0A0C12"/>
+            <a:srgbClr val="0A0A0F"/>
           </a:solidFill>
           <a:ln>
-            <a:noFill/>
+            <a:solidFill>
+              <a:srgbClr val="0A0A0F"/>
+            </a:solidFill>
           </a:ln>
         </p:spPr>
         <p:style>
@@ -4567,7 +4049,7 @@
         <p:spPr>
           <a:xfrm>
             <a:off x="731520" y="365760"/>
-            <a:ext cx="10698480" cy="320040"/>
+            <a:ext cx="10058400" cy="365760"/>
           </a:xfrm>
           <a:prstGeom prst="rect">
             <a:avLst/>
@@ -4575,7 +4057,7 @@
           <a:noFill/>
         </p:spPr>
         <p:txBody>
-          <a:bodyPr wrap="square" lIns="0" tIns="0" rIns="0" bIns="0">
+          <a:bodyPr wrap="none">
             <a:spAutoFit/>
           </a:bodyPr>
           <a:lstStyle/>
@@ -4585,11 +4067,10 @@
                 <a:solidFill>
                   <a:srgbClr val="00F0FF"/>
                 </a:solidFill>
-                <a:latin typeface="Segoe UI"/>
               </a:defRPr>
             </a:pPr>
             <a:r>
-              <a:t>SYSTEM ARCHITECTURE • ENGINE</a:t>
+              <a:t>VIRALFLOW AI HACKATHON PRESENTATION</a:t>
             </a:r>
           </a:p>
         </p:txBody>
@@ -4602,8 +4083,8 @@
         </p:nvSpPr>
         <p:spPr>
           <a:xfrm>
-            <a:off x="731520" y="685800"/>
-            <a:ext cx="10698480" cy="594360"/>
+            <a:off x="731520" y="640080"/>
+            <a:ext cx="10058400" cy="731520"/>
           </a:xfrm>
           <a:prstGeom prst="rect">
             <a:avLst/>
@@ -4611,21 +4092,20 @@
           <a:noFill/>
         </p:spPr>
         <p:txBody>
-          <a:bodyPr wrap="square" lIns="0" tIns="0" rIns="0" bIns="0">
+          <a:bodyPr wrap="none">
             <a:spAutoFit/>
           </a:bodyPr>
           <a:lstStyle/>
           <a:p>
             <a:pPr>
-              <a:defRPr sz="2600" b="1">
+              <a:defRPr sz="2800" b="1">
                 <a:solidFill>
                   <a:srgbClr val="FFFFFF"/>
                 </a:solidFill>
-                <a:latin typeface="Segoe UI"/>
               </a:defRPr>
             </a:pPr>
             <a:r>
-              <a:t>Production-Grade Orchestration &amp; Stack</a:t>
+              <a:t>TECHNICAL ARCHITECTURE AND AGENT PIPELINE</a:t>
             </a:r>
           </a:p>
         </p:txBody>
@@ -4639,17 +4119,17 @@
         <p:spPr>
           <a:xfrm>
             <a:off x="731520" y="1645920"/>
-            <a:ext cx="10698480" cy="987552"/>
+            <a:ext cx="10698480" cy="1005840"/>
           </a:xfrm>
           <a:prstGeom prst="roundRect">
             <a:avLst/>
           </a:prstGeom>
           <a:solidFill>
-            <a:srgbClr val="141824"/>
+            <a:srgbClr val="161823"/>
           </a:solidFill>
           <a:ln>
             <a:solidFill>
-              <a:srgbClr val="262E44"/>
+              <a:srgbClr val="282D41"/>
             </a:solidFill>
           </a:ln>
         </p:spPr>
@@ -4672,29 +4152,22 @@
           <a:lstStyle/>
           <a:p>
             <a:pPr algn="ctr">
-              <a:defRPr sz="1400" b="1">
-                <a:solidFill>
-                  <a:srgbClr val="00F0FF"/>
+              <a:defRPr sz="1600" b="1">
+                <a:solidFill>
+                  <a:srgbClr val="CCFF00"/>
                 </a:solidFill>
               </a:defRPr>
             </a:pPr>
             <a:r>
-              <a:t>LAYER 01: Frontend Studio (Next.js 16 + React 19)</a:t>
-            </a:r>
-          </a:p>
-          <a:p>
-            <a:pPr>
-              <a:spcBef>
-                <a:spcPts val="300"/>
-              </a:spcBef>
-              <a:defRPr sz="1200">
+              <a:t>1. Frontend and Studio: </a:t>
+            </a:r>
+            <a:r>
+              <a:rPr sz="1400" b="0">
                 <a:solidFill>
                   <a:srgbClr val="FFFFFF"/>
                 </a:solidFill>
-              </a:defRPr>
-            </a:pPr>
-            <a:r>
-              <a:t>Turbopack, Tailwind CSS, TypeScript, and Native HTML5 Motion Graphics Player with real-time HUD tech frame, kinetic pop subtitles, and scene B-roll preview.</a:t>
+              </a:rPr>
+              <a:t>Next.js 16 (Turbopack, App Router), TypeScript, Tailwind CSS, HTML5 9:16 Video Player</a:t>
             </a:r>
           </a:p>
         </p:txBody>
@@ -4707,18 +4180,18 @@
         </p:nvSpPr>
         <p:spPr>
           <a:xfrm>
-            <a:off x="731520" y="2788920"/>
-            <a:ext cx="10698480" cy="987552"/>
+            <a:off x="731520" y="2834640"/>
+            <a:ext cx="10698480" cy="1005840"/>
           </a:xfrm>
           <a:prstGeom prst="roundRect">
             <a:avLst/>
           </a:prstGeom>
           <a:solidFill>
-            <a:srgbClr val="141824"/>
+            <a:srgbClr val="161823"/>
           </a:solidFill>
           <a:ln>
             <a:solidFill>
-              <a:srgbClr val="262E44"/>
+              <a:srgbClr val="282D41"/>
             </a:solidFill>
           </a:ln>
         </p:spPr>
@@ -4741,29 +4214,22 @@
           <a:lstStyle/>
           <a:p>
             <a:pPr algn="ctr">
-              <a:defRPr sz="1400" b="1">
-                <a:solidFill>
-                  <a:srgbClr val="00F0FF"/>
+              <a:defRPr sz="1600" b="1">
+                <a:solidFill>
+                  <a:srgbClr val="CCFF00"/>
                 </a:solidFill>
               </a:defRPr>
             </a:pPr>
             <a:r>
-              <a:t>LAYER 02: n8n Workflow Engine (Railway Public Webhook)</a:t>
-            </a:r>
-          </a:p>
-          <a:p>
-            <a:pPr>
-              <a:spcBef>
-                <a:spcPts val="300"/>
-              </a:spcBef>
-              <a:defRPr sz="1200">
+              <a:t>2. Multi-Agent Engine: </a:t>
+            </a:r>
+            <a:r>
+              <a:rPr sz="1400" b="0">
                 <a:solidFill>
                   <a:srgbClr val="FFFFFF"/>
                 </a:solidFill>
-              </a:defRPr>
-            </a:pPr>
-            <a:r>
-              <a:t>40-node production workflow acting as an autonomous agent orchestrator: handles synchronous topic ingestion, multi-agent LLM prompts, asset resolution, and JSON manifest synthesis.</a:t>
+              </a:rPr>
+              <a:t>Google Gemini 3.6 Flash and OpenRouter (GPT-4o-mini) for trend scoring, script writing, and fact checking</a:t>
             </a:r>
           </a:p>
         </p:txBody>
@@ -4776,18 +4242,18 @@
         </p:nvSpPr>
         <p:spPr>
           <a:xfrm>
-            <a:off x="731520" y="3931920"/>
-            <a:ext cx="10698480" cy="987552"/>
+            <a:off x="731520" y="4023360"/>
+            <a:ext cx="10698480" cy="1005840"/>
           </a:xfrm>
           <a:prstGeom prst="roundRect">
             <a:avLst/>
           </a:prstGeom>
           <a:solidFill>
-            <a:srgbClr val="141824"/>
+            <a:srgbClr val="161823"/>
           </a:solidFill>
           <a:ln>
             <a:solidFill>
-              <a:srgbClr val="262E44"/>
+              <a:srgbClr val="282D41"/>
             </a:solidFill>
           </a:ln>
         </p:spPr>
@@ -4810,29 +4276,22 @@
           <a:lstStyle/>
           <a:p>
             <a:pPr algn="ctr">
-              <a:defRPr sz="1400" b="1">
-                <a:solidFill>
-                  <a:srgbClr val="00F0FF"/>
+              <a:defRPr sz="1600" b="1">
+                <a:solidFill>
+                  <a:srgbClr val="CCFF00"/>
                 </a:solidFill>
               </a:defRPr>
             </a:pPr>
             <a:r>
-              <a:t>LAYER 03: Multi-LLM Intelligence (Gemini 1.5/2.0 &amp; OpenRouter)</a:t>
-            </a:r>
-          </a:p>
-          <a:p>
-            <a:pPr>
-              <a:spcBef>
-                <a:spcPts val="300"/>
-              </a:spcBef>
-              <a:defRPr sz="1200">
+              <a:t>3. n8n Orchestration: </a:t>
+            </a:r>
+            <a:r>
+              <a:rPr sz="1400" b="0">
                 <a:solidFill>
                   <a:srgbClr val="FFFFFF"/>
                 </a:solidFill>
-              </a:defRPr>
-            </a:pPr>
-            <a:r>
-              <a:t>High-speed structured output generation for scene breakdown, visual search query extraction, kinetic timing tags, and rigorous editorial QA validation.</a:t>
+              </a:rPr>
+              <a:t>18-node n8n workflow (viralflow-generate webhook) for background trend ingestion and agent dispatch</a:t>
             </a:r>
           </a:p>
         </p:txBody>
@@ -4845,18 +4304,18 @@
         </p:nvSpPr>
         <p:spPr>
           <a:xfrm>
-            <a:off x="731520" y="5074920"/>
-            <a:ext cx="10698480" cy="987552"/>
+            <a:off x="731520" y="5212080"/>
+            <a:ext cx="10698480" cy="1005840"/>
           </a:xfrm>
           <a:prstGeom prst="roundRect">
             <a:avLst/>
           </a:prstGeom>
           <a:solidFill>
-            <a:srgbClr val="141824"/>
+            <a:srgbClr val="161823"/>
           </a:solidFill>
           <a:ln>
             <a:solidFill>
-              <a:srgbClr val="262E44"/>
+              <a:srgbClr val="282D41"/>
             </a:solidFill>
           </a:ln>
         </p:spPr>
@@ -4879,29 +4338,22 @@
           <a:lstStyle/>
           <a:p>
             <a:pPr algn="ctr">
-              <a:defRPr sz="1400" b="1">
-                <a:solidFill>
-                  <a:srgbClr val="00F0FF"/>
+              <a:defRPr sz="1600" b="1">
+                <a:solidFill>
+                  <a:srgbClr val="CCFF00"/>
                 </a:solidFill>
               </a:defRPr>
             </a:pPr>
             <a:r>
-              <a:t>LAYER 04: Asset Synthesis &amp; Audio Ducking (Pexels + ElevenLabs + Shotstack)</a:t>
-            </a:r>
-          </a:p>
-          <a:p>
-            <a:pPr>
-              <a:spcBef>
-                <a:spcPts val="300"/>
-              </a:spcBef>
-              <a:defRPr sz="1200">
+              <a:t>4. Voice and Render Pipeline: </a:t>
+            </a:r>
+            <a:r>
+              <a:rPr sz="1400" b="0">
                 <a:solidFill>
                   <a:srgbClr val="FFFFFF"/>
                 </a:solidFill>
-              </a:defRPr>
-            </a:pPr>
-            <a:r>
-              <a:t>Curates 1080x1920 vertical B-roll assets, natural AI voiceover narration, sound effects, and complete Shotstack MP4 timeline rendering.</a:t>
+              </a:rPr>
+              <a:t>ElevenLabs Speech Synthesis + Pexels Portrait B-roll Search + Shotstack 9:16 MP4 Video Render</a:t>
             </a:r>
           </a:p>
         </p:txBody>
@@ -4939,10 +4391,12 @@
             <a:avLst/>
           </a:prstGeom>
           <a:solidFill>
-            <a:srgbClr val="0A0C12"/>
+            <a:srgbClr val="0A0A0F"/>
           </a:solidFill>
           <a:ln>
-            <a:noFill/>
+            <a:solidFill>
+              <a:srgbClr val="0A0A0F"/>
+            </a:solidFill>
           </a:ln>
         </p:spPr>
         <p:style>
@@ -4976,7 +4430,7 @@
         <p:spPr>
           <a:xfrm>
             <a:off x="731520" y="365760"/>
-            <a:ext cx="10698480" cy="320040"/>
+            <a:ext cx="10058400" cy="365760"/>
           </a:xfrm>
           <a:prstGeom prst="rect">
             <a:avLst/>
@@ -4984,7 +4438,7 @@
           <a:noFill/>
         </p:spPr>
         <p:txBody>
-          <a:bodyPr wrap="square" lIns="0" tIns="0" rIns="0" bIns="0">
+          <a:bodyPr wrap="none">
             <a:spAutoFit/>
           </a:bodyPr>
           <a:lstStyle/>
@@ -4994,11 +4448,10 @@
                 <a:solidFill>
                   <a:srgbClr val="00F0FF"/>
                 </a:solidFill>
-                <a:latin typeface="Segoe UI"/>
               </a:defRPr>
             </a:pPr>
             <a:r>
-              <a:t>LIVE DEMO WALKTHROUGH • 3 STEPS</a:t>
+              <a:t>VIRALFLOW AI HACKATHON PRESENTATION</a:t>
             </a:r>
           </a:p>
         </p:txBody>
@@ -5011,8 +4464,8 @@
         </p:nvSpPr>
         <p:spPr>
           <a:xfrm>
-            <a:off x="731520" y="685800"/>
-            <a:ext cx="10698480" cy="594360"/>
+            <a:off x="731520" y="640080"/>
+            <a:ext cx="10058400" cy="731520"/>
           </a:xfrm>
           <a:prstGeom prst="rect">
             <a:avLst/>
@@ -5020,21 +4473,20 @@
           <a:noFill/>
         </p:spPr>
         <p:txBody>
-          <a:bodyPr wrap="square" lIns="0" tIns="0" rIns="0" bIns="0">
+          <a:bodyPr wrap="none">
             <a:spAutoFit/>
           </a:bodyPr>
           <a:lstStyle/>
           <a:p>
             <a:pPr>
-              <a:defRPr sz="2600" b="1">
+              <a:defRPr sz="2800" b="1">
                 <a:solidFill>
                   <a:srgbClr val="FFFFFF"/>
                 </a:solidFill>
-                <a:latin typeface="Segoe UI"/>
               </a:defRPr>
             </a:pPr>
             <a:r>
-              <a:t>How Mentors &amp; Judges Experience ViralFlow AI</a:t>
+              <a:t>CORE FEATURES AND DEMO WORKFLOW</a:t>
             </a:r>
           </a:p>
         </p:txBody>
@@ -5048,17 +4500,17 @@
         <p:spPr>
           <a:xfrm>
             <a:off x="731520" y="1645920"/>
-            <a:ext cx="3383280" cy="4389120"/>
+            <a:ext cx="5120640" cy="2011680"/>
           </a:xfrm>
           <a:prstGeom prst="roundRect">
             <a:avLst/>
           </a:prstGeom>
           <a:solidFill>
-            <a:srgbClr val="141824"/>
+            <a:srgbClr val="161823"/>
           </a:solidFill>
           <a:ln>
             <a:solidFill>
-              <a:srgbClr val="262E44"/>
+              <a:srgbClr val="282D41"/>
             </a:solidFill>
           </a:ln>
         </p:spPr>
@@ -5081,63 +4533,27 @@
           <a:lstStyle/>
           <a:p>
             <a:pPr algn="ctr">
-              <a:defRPr sz="1200" b="1">
-                <a:solidFill>
-                  <a:srgbClr val="FFE600"/>
+              <a:defRPr sz="1800" b="1">
+                <a:solidFill>
+                  <a:srgbClr val="00F0FF"/>
                 </a:solidFill>
               </a:defRPr>
             </a:pPr>
             <a:r>
-              <a:t>STEP 1</a:t>
-            </a:r>
-          </a:p>
-          <a:p>
+              <a:t>Trend Radar</a:t>
+            </a:r>
+          </a:p>
+          <a:p>
+            <a:br/>
             <a:pPr>
-              <a:spcBef>
-                <a:spcPts val="400"/>
-              </a:spcBef>
-              <a:defRPr sz="1800" b="1">
-                <a:solidFill>
-                  <a:srgbClr val="FFFFFF"/>
+              <a:defRPr sz="1400">
+                <a:solidFill>
+                  <a:srgbClr val="A0A5B9"/>
                 </a:solidFill>
               </a:defRPr>
             </a:pPr>
             <a:r>
-              <a:t>Autonomous Topic Discovery</a:t>
-            </a:r>
-          </a:p>
-          <a:p>
-            <a:pPr>
-              <a:spcBef>
-                <a:spcPts val="600"/>
-              </a:spcBef>
-              <a:defRPr sz="1100" b="1">
-                <a:solidFill>
-                  <a:srgbClr val="00F0FF"/>
-                </a:solidFill>
-              </a:defRPr>
-            </a:pPr>
-            <a:r>
-              <a:t>⚡ Radar or Direct Input</a:t>
-            </a:r>
-          </a:p>
-          <a:p>
-            <a:pPr>
-              <a:spcBef>
-                <a:spcPts val="1400"/>
-              </a:spcBef>
-              <a:defRPr sz="1300">
-                <a:solidFill>
-                  <a:srgbClr val="94A3B8"/>
-                </a:solidFill>
-              </a:defRPr>
-            </a:pPr>
-            <a:r>
-              <a:t>• Creator enters a topic (e.g., 'Multi-Agent AI Systems') or clicks 'Autonomous Discover'.</a:t>
-            </a:r>
-            <a:br/>
-            <a:r>
-              <a:t>• Engine identifies highest-momentum viral angle and selects the target duration (30s).</a:t>
+              <a:t>Scans live YouTube and Tavily web queries, scoring opportunity vectors based on momentum and audience fit.</a:t>
             </a:r>
           </a:p>
         </p:txBody>
@@ -5150,18 +4566,18 @@
         </p:nvSpPr>
         <p:spPr>
           <a:xfrm>
-            <a:off x="4389120" y="1645920"/>
-            <a:ext cx="3383280" cy="4389120"/>
+            <a:off x="6217920" y="1645920"/>
+            <a:ext cx="5120640" cy="2011680"/>
           </a:xfrm>
           <a:prstGeom prst="roundRect">
             <a:avLst/>
           </a:prstGeom>
           <a:solidFill>
-            <a:srgbClr val="141824"/>
+            <a:srgbClr val="161823"/>
           </a:solidFill>
           <a:ln>
             <a:solidFill>
-              <a:srgbClr val="262E44"/>
+              <a:srgbClr val="282D41"/>
             </a:solidFill>
           </a:ln>
         </p:spPr>
@@ -5184,63 +4600,27 @@
           <a:lstStyle/>
           <a:p>
             <a:pPr algn="ctr">
-              <a:defRPr sz="1200" b="1">
-                <a:solidFill>
-                  <a:srgbClr val="FFE600"/>
+              <a:defRPr sz="1800" b="1">
+                <a:solidFill>
+                  <a:srgbClr val="00F0FF"/>
                 </a:solidFill>
               </a:defRPr>
             </a:pPr>
             <a:r>
-              <a:t>STEP 2</a:t>
-            </a:r>
-          </a:p>
-          <a:p>
+              <a:t>Strategy Lab</a:t>
+            </a:r>
+          </a:p>
+          <a:p>
+            <a:br/>
             <a:pPr>
-              <a:spcBef>
-                <a:spcPts val="400"/>
-              </a:spcBef>
-              <a:defRPr sz="1800" b="1">
-                <a:solidFill>
-                  <a:srgbClr val="FFFFFF"/>
+              <a:defRPr sz="1400">
+                <a:solidFill>
+                  <a:srgbClr val="A0A5B9"/>
                 </a:solidFill>
               </a:defRPr>
             </a:pPr>
             <a:r>
-              <a:t>Multi-Agent Storyboard Studio</a:t>
-            </a:r>
-          </a:p>
-          <a:p>
-            <a:pPr>
-              <a:spcBef>
-                <a:spcPts val="600"/>
-              </a:spcBef>
-              <a:defRPr sz="1100" b="1">
-                <a:solidFill>
-                  <a:srgbClr val="00F0FF"/>
-                </a:solidFill>
-              </a:defRPr>
-            </a:pPr>
-            <a:r>
-              <a:t>⚡ Fact-Checked Manifest</a:t>
-            </a:r>
-          </a:p>
-          <a:p>
-            <a:pPr>
-              <a:spcBef>
-                <a:spcPts val="1400"/>
-              </a:spcBef>
-              <a:defRPr sz="1300">
-                <a:solidFill>
-                  <a:srgbClr val="94A3B8"/>
-                </a:solidFill>
-              </a:defRPr>
-            </a:pPr>
-            <a:r>
-              <a:t>• Swarm produces 4-scene storyboard with time-coded narration, visual goals, and caption styles.</a:t>
-            </a:r>
-            <a:br/>
-            <a:r>
-              <a:t>• Guardrails automatically verify facts and score the script with an Editorial Quality Scorecard (94/100).</a:t>
+              <a:t>Synthesizes strategic hook variations tailored to creator hook patterns.</a:t>
             </a:r>
           </a:p>
         </p:txBody>
@@ -5253,18 +4633,18 @@
         </p:nvSpPr>
         <p:spPr>
           <a:xfrm>
-            <a:off x="8046720" y="1645920"/>
-            <a:ext cx="3383280" cy="4389120"/>
+            <a:off x="731520" y="3931920"/>
+            <a:ext cx="5120640" cy="2011680"/>
           </a:xfrm>
           <a:prstGeom prst="roundRect">
             <a:avLst/>
           </a:prstGeom>
           <a:solidFill>
-            <a:srgbClr val="141824"/>
+            <a:srgbClr val="161823"/>
           </a:solidFill>
           <a:ln>
             <a:solidFill>
-              <a:srgbClr val="00F0FF"/>
+              <a:srgbClr val="282D41"/>
             </a:solidFill>
           </a:ln>
         </p:spPr>
@@ -5287,104 +4667,52 @@
           <a:lstStyle/>
           <a:p>
             <a:pPr algn="ctr">
-              <a:defRPr sz="1200" b="1">
-                <a:solidFill>
-                  <a:srgbClr val="FFE600"/>
+              <a:defRPr sz="1800" b="1">
+                <a:solidFill>
+                  <a:srgbClr val="00F0FF"/>
                 </a:solidFill>
               </a:defRPr>
             </a:pPr>
             <a:r>
-              <a:t>STEP 3</a:t>
-            </a:r>
-          </a:p>
-          <a:p>
+              <a:t>Script Studio</a:t>
+            </a:r>
+          </a:p>
+          <a:p>
+            <a:br/>
             <a:pPr>
-              <a:spcBef>
-                <a:spcPts val="400"/>
-              </a:spcBef>
-              <a:defRPr sz="1800" b="1">
-                <a:solidFill>
-                  <a:srgbClr val="FFFFFF"/>
+              <a:defRPr sz="1400">
+                <a:solidFill>
+                  <a:srgbClr val="A0A5B9"/>
                 </a:solidFill>
               </a:defRPr>
             </a:pPr>
             <a:r>
-              <a:t>Motion Graphics Approval Player</a:t>
-            </a:r>
-          </a:p>
-          <a:p>
-            <a:pPr>
-              <a:spcBef>
-                <a:spcPts val="600"/>
-              </a:spcBef>
-              <a:defRPr sz="1100" b="1">
-                <a:solidFill>
-                  <a:srgbClr val="00F0FF"/>
-                </a:solidFill>
-              </a:defRPr>
-            </a:pPr>
-            <a:r>
-              <a:t>⚡ 9:16 Broadcast Preview</a:t>
-            </a:r>
-          </a:p>
-          <a:p>
-            <a:pPr>
-              <a:spcBef>
-                <a:spcPts val="1400"/>
-              </a:spcBef>
-              <a:defRPr sz="1300">
-                <a:solidFill>
-                  <a:srgbClr val="94A3B8"/>
-                </a:solidFill>
-              </a:defRPr>
-            </a:pPr>
-            <a:r>
-              <a:t>• Real-time video player animates top neon progress bar, dynamic HUD tech badges, and yellow kinetic pop typography.</a:t>
-            </a:r>
-            <a:br/>
-            <a:r>
-              <a:t>• Scene-by-scene HD vertical B-roll dynamically switches with audio sync.</a:t>
-            </a:r>
-          </a:p>
-        </p:txBody>
-      </p:sp>
-    </p:spTree>
-  </p:cSld>
-  <p:clrMapOvr>
-    <a:masterClrMapping/>
-  </p:clrMapOvr>
-</p:sld>
-</file>
-
-<file path=ppt/slides/slide6.xml><?xml version="1.0" encoding="utf-8"?>
-<p:sld xmlns:a="http://schemas.openxmlformats.org/drawingml/2006/main" xmlns:p="http://schemas.openxmlformats.org/presentationml/2006/main" xmlns:r="http://schemas.openxmlformats.org/officeDocument/2006/relationships">
-  <p:cSld>
-    <p:spTree>
-      <p:nvGrpSpPr>
-        <p:cNvPr id="1" name=""/>
-        <p:cNvGrpSpPr/>
-        <p:nvPr/>
-      </p:nvGrpSpPr>
-      <p:grpSpPr/>
-      <p:sp>
-        <p:nvSpPr>
-          <p:cNvPr id="2" name="Rectangle 1"/>
+              <a:t>Interactive scene-by-scene script editor, visual prompt controls, and fact-checking queue.</a:t>
+            </a:r>
+          </a:p>
+        </p:txBody>
+      </p:sp>
+      <p:sp>
+        <p:nvSpPr>
+          <p:cNvPr id="8" name="Rounded Rectangle 7"/>
           <p:cNvSpPr/>
           <p:nvPr/>
         </p:nvSpPr>
         <p:spPr>
           <a:xfrm>
-            <a:off x="0" y="0"/>
-            <a:ext cx="12191695" cy="6858000"/>
-          </a:xfrm>
-          <a:prstGeom prst="rect">
+            <a:off x="6217920" y="3931920"/>
+            <a:ext cx="5120640" cy="2011680"/>
+          </a:xfrm>
+          <a:prstGeom prst="roundRect">
             <a:avLst/>
           </a:prstGeom>
           <a:solidFill>
-            <a:srgbClr val="0A0C12"/>
+            <a:srgbClr val="161823"/>
           </a:solidFill>
           <a:ln>
-            <a:noFill/>
+            <a:solidFill>
+              <a:srgbClr val="282D41"/>
+            </a:solidFill>
           </a:ln>
         </p:spPr>
         <p:style>
@@ -5402,369 +4730,31 @@
           </a:fontRef>
         </p:style>
         <p:txBody>
-          <a:bodyPr rtlCol="0" anchor="ctr"/>
-          <a:lstStyle/>
-          <a:p>
-            <a:pPr algn="ctr"/>
-          </a:p>
-        </p:txBody>
-      </p:sp>
-      <p:sp>
-        <p:nvSpPr>
-          <p:cNvPr id="3" name="TextBox 2"/>
-          <p:cNvSpPr txBox="1"/>
-          <p:nvPr/>
-        </p:nvSpPr>
-        <p:spPr>
-          <a:xfrm>
-            <a:off x="731520" y="365760"/>
-            <a:ext cx="10698480" cy="320040"/>
-          </a:xfrm>
-          <a:prstGeom prst="rect">
-            <a:avLst/>
-          </a:prstGeom>
-          <a:noFill/>
-        </p:spPr>
-        <p:txBody>
-          <a:bodyPr wrap="square" lIns="0" tIns="0" rIns="0" bIns="0">
-            <a:spAutoFit/>
-          </a:bodyPr>
-          <a:lstStyle/>
-          <a:p>
+          <a:bodyPr rtlCol="0" anchor="ctr" wrap="square"/>
+          <a:lstStyle/>
+          <a:p>
+            <a:pPr algn="ctr">
+              <a:defRPr sz="1800" b="1">
+                <a:solidFill>
+                  <a:srgbClr val="00F0FF"/>
+                </a:solidFill>
+              </a:defRPr>
+            </a:pPr>
+            <a:r>
+              <a:t>Approval and Publishing</a:t>
+            </a:r>
+          </a:p>
+          <a:p>
+            <a:br/>
             <a:pPr>
-              <a:defRPr sz="1100" b="1">
-                <a:solidFill>
-                  <a:srgbClr val="00F0FF"/>
-                </a:solidFill>
-                <a:latin typeface="Segoe UI"/>
+              <a:defRPr sz="1400">
+                <a:solidFill>
+                  <a:srgbClr val="A0A5B9"/>
+                </a:solidFill>
               </a:defRPr>
             </a:pPr>
             <a:r>
-              <a:t>COMPETITIVE ADVANTAGE • REAL-WORLD MOAT</a:t>
-            </a:r>
-          </a:p>
-        </p:txBody>
-      </p:sp>
-      <p:sp>
-        <p:nvSpPr>
-          <p:cNvPr id="4" name="TextBox 3"/>
-          <p:cNvSpPr txBox="1"/>
-          <p:nvPr/>
-        </p:nvSpPr>
-        <p:spPr>
-          <a:xfrm>
-            <a:off x="731520" y="685800"/>
-            <a:ext cx="10698480" cy="594360"/>
-          </a:xfrm>
-          <a:prstGeom prst="rect">
-            <a:avLst/>
-          </a:prstGeom>
-          <a:noFill/>
-        </p:spPr>
-        <p:txBody>
-          <a:bodyPr wrap="square" lIns="0" tIns="0" rIns="0" bIns="0">
-            <a:spAutoFit/>
-          </a:bodyPr>
-          <a:lstStyle/>
-          <a:p>
-            <a:pPr>
-              <a:defRPr sz="2600" b="1">
-                <a:solidFill>
-                  <a:srgbClr val="FFFFFF"/>
-                </a:solidFill>
-                <a:latin typeface="Segoe UI"/>
-              </a:defRPr>
-            </a:pPr>
-            <a:r>
-              <a:t>Why ViralFlow AI Wins Against Existing Tools</a:t>
-            </a:r>
-          </a:p>
-        </p:txBody>
-      </p:sp>
-      <p:sp>
-        <p:nvSpPr>
-          <p:cNvPr id="5" name="Rounded Rectangle 4"/>
-          <p:cNvSpPr/>
-          <p:nvPr/>
-        </p:nvSpPr>
-        <p:spPr>
-          <a:xfrm>
-            <a:off x="731520" y="1645920"/>
-            <a:ext cx="3383280" cy="4389120"/>
-          </a:xfrm>
-          <a:prstGeom prst="roundRect">
-            <a:avLst/>
-          </a:prstGeom>
-          <a:solidFill>
-            <a:srgbClr val="141824"/>
-          </a:solidFill>
-          <a:ln>
-            <a:solidFill>
-              <a:srgbClr val="262E44"/>
-            </a:solidFill>
-          </a:ln>
-        </p:spPr>
-        <p:style>
-          <a:lnRef idx="1">
-            <a:schemeClr val="accent1"/>
-          </a:lnRef>
-          <a:fillRef idx="3">
-            <a:schemeClr val="accent1"/>
-          </a:fillRef>
-          <a:effectRef idx="2">
-            <a:schemeClr val="accent1"/>
-          </a:effectRef>
-          <a:fontRef idx="minor">
-            <a:schemeClr val="lt1"/>
-          </a:fontRef>
-        </p:style>
-        <p:txBody>
-          <a:bodyPr rtlCol="0" anchor="ctr" wrap="square"/>
-          <a:lstStyle/>
-          <a:p>
-            <a:pPr algn="ctr">
-              <a:defRPr sz="1100" b="1">
-                <a:solidFill>
-                  <a:srgbClr val="FFE600"/>
-                </a:solidFill>
-              </a:defRPr>
-            </a:pPr>
-            <a:r>
-              <a:t>SLOW &amp; EXPENSIVE</a:t>
-            </a:r>
-          </a:p>
-          <a:p>
-            <a:pPr>
-              <a:spcBef>
-                <a:spcPts val="400"/>
-              </a:spcBef>
-              <a:defRPr sz="1700" b="1">
-                <a:solidFill>
-                  <a:srgbClr val="FFFFFF"/>
-                </a:solidFill>
-              </a:defRPr>
-            </a:pPr>
-            <a:r>
-              <a:t>Manual Production (CapCut / Premiere)</a:t>
-            </a:r>
-          </a:p>
-          <a:p>
-            <a:pPr>
-              <a:spcBef>
-                <a:spcPts val="1200"/>
-              </a:spcBef>
-              <a:defRPr sz="1300">
-                <a:solidFill>
-                  <a:srgbClr val="94A3B8"/>
-                </a:solidFill>
-              </a:defRPr>
-            </a:pPr>
-            <a:r>
-              <a:t>• Requires 4-6 hours per short-form video</a:t>
-            </a:r>
-            <a:br/>
-            <a:r>
-              <a:t>• High software learning curve &amp; rendering fatigue</a:t>
-            </a:r>
-            <a:br/>
-            <a:r>
-              <a:t>• Inconsistent brand voice &amp; frequent editing delays</a:t>
-            </a:r>
-            <a:br/>
-            <a:r>
-              <a:t>• Zero built-in research or fact-checking intelligence</a:t>
-            </a:r>
-          </a:p>
-        </p:txBody>
-      </p:sp>
-      <p:sp>
-        <p:nvSpPr>
-          <p:cNvPr id="6" name="Rounded Rectangle 5"/>
-          <p:cNvSpPr/>
-          <p:nvPr/>
-        </p:nvSpPr>
-        <p:spPr>
-          <a:xfrm>
-            <a:off x="4389120" y="1645920"/>
-            <a:ext cx="3383280" cy="4389120"/>
-          </a:xfrm>
-          <a:prstGeom prst="roundRect">
-            <a:avLst/>
-          </a:prstGeom>
-          <a:solidFill>
-            <a:srgbClr val="141824"/>
-          </a:solidFill>
-          <a:ln>
-            <a:solidFill>
-              <a:srgbClr val="262E44"/>
-            </a:solidFill>
-          </a:ln>
-        </p:spPr>
-        <p:style>
-          <a:lnRef idx="1">
-            <a:schemeClr val="accent1"/>
-          </a:lnRef>
-          <a:fillRef idx="3">
-            <a:schemeClr val="accent1"/>
-          </a:fillRef>
-          <a:effectRef idx="2">
-            <a:schemeClr val="accent1"/>
-          </a:effectRef>
-          <a:fontRef idx="minor">
-            <a:schemeClr val="lt1"/>
-          </a:fontRef>
-        </p:style>
-        <p:txBody>
-          <a:bodyPr rtlCol="0" anchor="ctr" wrap="square"/>
-          <a:lstStyle/>
-          <a:p>
-            <a:pPr algn="ctr">
-              <a:defRPr sz="1100" b="1">
-                <a:solidFill>
-                  <a:srgbClr val="FFE600"/>
-                </a:solidFill>
-              </a:defRPr>
-            </a:pPr>
-            <a:r>
-              <a:t>GENERIC &amp; UNVERIFIED</a:t>
-            </a:r>
-          </a:p>
-          <a:p>
-            <a:pPr>
-              <a:spcBef>
-                <a:spcPts val="400"/>
-              </a:spcBef>
-              <a:defRPr sz="1700" b="1">
-                <a:solidFill>
-                  <a:srgbClr val="FFFFFF"/>
-                </a:solidFill>
-              </a:defRPr>
-            </a:pPr>
-            <a:r>
-              <a:t>Generic AI Tools (InVideo / HeyGen)</a:t>
-            </a:r>
-          </a:p>
-          <a:p>
-            <a:pPr>
-              <a:spcBef>
-                <a:spcPts val="1200"/>
-              </a:spcBef>
-              <a:defRPr sz="1300">
-                <a:solidFill>
-                  <a:srgbClr val="94A3B8"/>
-                </a:solidFill>
-              </a:defRPr>
-            </a:pPr>
-            <a:r>
-              <a:t>• Repetitive, generic template stock clips</a:t>
-            </a:r>
-            <a:br/>
-            <a:r>
-              <a:t>• Severe hallucination risks without verification</a:t>
-            </a:r>
-            <a:br/>
-            <a:r>
-              <a:t>• Robotic voices and stiff, non-engaging pacing</a:t>
-            </a:r>
-            <a:br/>
-            <a:r>
-              <a:t>• No creator brand personalization or viral radar</a:t>
-            </a:r>
-          </a:p>
-        </p:txBody>
-      </p:sp>
-      <p:sp>
-        <p:nvSpPr>
-          <p:cNvPr id="7" name="Rounded Rectangle 6"/>
-          <p:cNvSpPr/>
-          <p:nvPr/>
-        </p:nvSpPr>
-        <p:spPr>
-          <a:xfrm>
-            <a:off x="8046720" y="1645920"/>
-            <a:ext cx="3383280" cy="4389120"/>
-          </a:xfrm>
-          <a:prstGeom prst="roundRect">
-            <a:avLst/>
-          </a:prstGeom>
-          <a:solidFill>
-            <a:srgbClr val="1A2030"/>
-          </a:solidFill>
-          <a:ln>
-            <a:solidFill>
-              <a:srgbClr val="00F0FF"/>
-            </a:solidFill>
-          </a:ln>
-        </p:spPr>
-        <p:style>
-          <a:lnRef idx="1">
-            <a:schemeClr val="accent1"/>
-          </a:lnRef>
-          <a:fillRef idx="3">
-            <a:schemeClr val="accent1"/>
-          </a:fillRef>
-          <a:effectRef idx="2">
-            <a:schemeClr val="accent1"/>
-          </a:effectRef>
-          <a:fontRef idx="minor">
-            <a:schemeClr val="lt1"/>
-          </a:fontRef>
-        </p:style>
-        <p:txBody>
-          <a:bodyPr rtlCol="0" anchor="ctr" wrap="square"/>
-          <a:lstStyle/>
-          <a:p>
-            <a:pPr algn="ctr">
-              <a:defRPr sz="1100" b="1">
-                <a:solidFill>
-                  <a:srgbClr val="00FFA3"/>
-                </a:solidFill>
-              </a:defRPr>
-            </a:pPr>
-            <a:r>
-              <a:t>6-SEC VERIFIED VELOCITY</a:t>
-            </a:r>
-          </a:p>
-          <a:p>
-            <a:pPr>
-              <a:spcBef>
-                <a:spcPts val="400"/>
-              </a:spcBef>
-              <a:defRPr sz="1700" b="1">
-                <a:solidFill>
-                  <a:srgbClr val="00F0FF"/>
-                </a:solidFill>
-              </a:defRPr>
-            </a:pPr>
-            <a:r>
-              <a:t>ViralFlow AI 2.0 (Our Swarm Engine)</a:t>
-            </a:r>
-          </a:p>
-          <a:p>
-            <a:pPr>
-              <a:spcBef>
-                <a:spcPts val="1200"/>
-              </a:spcBef>
-              <a:defRPr sz="1300">
-                <a:solidFill>
-                  <a:srgbClr val="FFFFFF"/>
-                </a:solidFill>
-              </a:defRPr>
-            </a:pPr>
-            <a:r>
-              <a:t>✓ 6-second autonomous pipeline from topic to video</a:t>
-            </a:r>
-            <a:br/>
-            <a:r>
-              <a:t>✓ Creator DNA voice alignment &amp; retention hooks</a:t>
-            </a:r>
-            <a:br/>
-            <a:r>
-              <a:t>✓ Strict Factual Guardrails (Zero hallucination)</a:t>
-            </a:r>
-            <a:br/>
-            <a:r>
-              <a:t>✓ Native kinetic pop captions &amp; HUD motion graphics</a:t>
+              <a:t>Live 9:16 vertical video playback preview with automated publishing rules.</a:t>
             </a:r>
           </a:p>
         </p:txBody>
@@ -5802,10 +4792,12 @@
             <a:avLst/>
           </a:prstGeom>
           <a:solidFill>
-            <a:srgbClr val="0A0C12"/>
+            <a:srgbClr val="0A0A0F"/>
           </a:solidFill>
           <a:ln>
-            <a:noFill/>
+            <a:solidFill>
+              <a:srgbClr val="0A0A0F"/>
+            </a:solidFill>
           </a:ln>
         </p:spPr>
         <p:style>
@@ -5839,7 +4831,7 @@
         <p:spPr>
           <a:xfrm>
             <a:off x="731520" y="365760"/>
-            <a:ext cx="10698480" cy="320040"/>
+            <a:ext cx="10058400" cy="365760"/>
           </a:xfrm>
           <a:prstGeom prst="rect">
             <a:avLst/>
@@ -5847,7 +4839,7 @@
           <a:noFill/>
         </p:spPr>
         <p:txBody>
-          <a:bodyPr wrap="square" lIns="0" tIns="0" rIns="0" bIns="0">
+          <a:bodyPr wrap="none">
             <a:spAutoFit/>
           </a:bodyPr>
           <a:lstStyle/>
@@ -5857,11 +4849,10 @@
                 <a:solidFill>
                   <a:srgbClr val="00F0FF"/>
                 </a:solidFill>
-                <a:latin typeface="Segoe UI"/>
               </a:defRPr>
             </a:pPr>
             <a:r>
-              <a:t>ROADMAP • FUTURE HORIZON</a:t>
+              <a:t>VIRALFLOW AI — HACKATHON FINAL</a:t>
             </a:r>
           </a:p>
         </p:txBody>
@@ -5874,8 +4865,8 @@
         </p:nvSpPr>
         <p:spPr>
           <a:xfrm>
-            <a:off x="731520" y="685800"/>
-            <a:ext cx="10698480" cy="594360"/>
+            <a:off x="731520" y="640080"/>
+            <a:ext cx="10058400" cy="731520"/>
           </a:xfrm>
           <a:prstGeom prst="rect">
             <a:avLst/>
@@ -5883,21 +4874,20 @@
           <a:noFill/>
         </p:spPr>
         <p:txBody>
-          <a:bodyPr wrap="square" lIns="0" tIns="0" rIns="0" bIns="0">
+          <a:bodyPr wrap="none">
             <a:spAutoFit/>
           </a:bodyPr>
           <a:lstStyle/>
           <a:p>
             <a:pPr>
-              <a:defRPr sz="2600" b="1">
+              <a:defRPr sz="2800" b="1">
                 <a:solidFill>
                   <a:srgbClr val="FFFFFF"/>
                 </a:solidFill>
-                <a:latin typeface="Segoe UI"/>
               </a:defRPr>
             </a:pPr>
             <a:r>
-              <a:t>What We Are Building Next</a:t>
+              <a:t>READY TO DEMO AND PRESENT</a:t>
             </a:r>
           </a:p>
         </p:txBody>
@@ -5910,14 +4900,14 @@
         </p:nvSpPr>
         <p:spPr>
           <a:xfrm>
-            <a:off x="731520" y="1645920"/>
-            <a:ext cx="10698480" cy="1325880"/>
+            <a:off x="1371600" y="1645920"/>
+            <a:ext cx="9418320" cy="4389120"/>
           </a:xfrm>
           <a:prstGeom prst="roundRect">
             <a:avLst/>
           </a:prstGeom>
           <a:solidFill>
-            <a:srgbClr val="141824"/>
+            <a:srgbClr val="161823"/>
           </a:solidFill>
           <a:ln>
             <a:solidFill>
@@ -5944,465 +4934,52 @@
           <a:lstStyle/>
           <a:p>
             <a:pPr algn="ctr">
-              <a:defRPr sz="1500" b="1">
+              <a:defRPr sz="2200" b="1">
+                <a:solidFill>
+                  <a:srgbClr val="CCFF00"/>
+                </a:solidFill>
+              </a:defRPr>
+            </a:pPr>
+            <a:r>
+              <a:t>ViralFlow AI turns live web trends into ready-to-publish short-form videos automatically.</a:t>
+            </a:r>
+          </a:p>
+          <a:p>
+            <a:br/>
+            <a:pPr>
+              <a:defRPr sz="1800" b="1">
                 <a:solidFill>
                   <a:srgbClr val="00F0FF"/>
                 </a:solidFill>
               </a:defRPr>
             </a:pPr>
             <a:r>
-              <a:t>PHASE 1 (COMPLETED)  |  Autonomous Engine &amp; Live Player</a:t>
+              <a:t>Live Application URL: https://my-viralflow-ai.vercel.app</a:t>
             </a:r>
           </a:p>
           <a:p>
             <a:pPr>
-              <a:spcBef>
-                <a:spcPts val="400"/>
-              </a:spcBef>
-              <a:defRPr sz="1200">
+              <a:defRPr sz="1800" b="1">
                 <a:solidFill>
                   <a:srgbClr val="FFFFFF"/>
                 </a:solidFill>
               </a:defRPr>
             </a:pPr>
             <a:r>
-              <a:t>• Next.js 16 Web Studio with real-time HUD video player</a:t>
-            </a:r>
+              <a:t>GitHub Repository: https://github.com/Ibrahim2637/ViralFlow.Ai</a:t>
+            </a:r>
+          </a:p>
+          <a:p>
             <a:br/>
-            <a:r>
-              <a:t>• 40-Node n8n autonomous webhook workflow</a:t>
-            </a:r>
-            <a:br/>
-            <a:r>
-              <a:t>• Scene-by-scene dynamic B-roll &amp; kinetic captions</a:t>
-            </a:r>
-            <a:br/>
-            <a:r>
-              <a:t>• Guardrail fact-checking scorecard verification</a:t>
-            </a:r>
-          </a:p>
-        </p:txBody>
-      </p:sp>
-      <p:sp>
-        <p:nvSpPr>
-          <p:cNvPr id="6" name="Rounded Rectangle 5"/>
-          <p:cNvSpPr/>
-          <p:nvPr/>
-        </p:nvSpPr>
-        <p:spPr>
-          <a:xfrm>
-            <a:off x="731520" y="3154680"/>
-            <a:ext cx="10698480" cy="1325880"/>
-          </a:xfrm>
-          <a:prstGeom prst="roundRect">
-            <a:avLst/>
-          </a:prstGeom>
-          <a:solidFill>
-            <a:srgbClr val="141824"/>
-          </a:solidFill>
-          <a:ln>
-            <a:solidFill>
-              <a:srgbClr val="262E44"/>
-            </a:solidFill>
-          </a:ln>
-        </p:spPr>
-        <p:style>
-          <a:lnRef idx="1">
-            <a:schemeClr val="accent1"/>
-          </a:lnRef>
-          <a:fillRef idx="3">
-            <a:schemeClr val="accent1"/>
-          </a:fillRef>
-          <a:effectRef idx="2">
-            <a:schemeClr val="accent1"/>
-          </a:effectRef>
-          <a:fontRef idx="minor">
-            <a:schemeClr val="lt1"/>
-          </a:fontRef>
-        </p:style>
-        <p:txBody>
-          <a:bodyPr rtlCol="0" anchor="ctr" wrap="square"/>
-          <a:lstStyle/>
-          <a:p>
-            <a:pPr algn="ctr">
-              <a:defRPr sz="1500" b="1">
-                <a:solidFill>
-                  <a:srgbClr val="FFE600"/>
+            <a:pPr>
+              <a:defRPr sz="2000" b="1">
+                <a:solidFill>
+                  <a:srgbClr val="CCFF00"/>
                 </a:solidFill>
               </a:defRPr>
             </a:pPr>
             <a:r>
-              <a:t>PHASE 2 (NEXT 60 DAYS)  |  1-Click Multi-Platform Publishing</a:t>
-            </a:r>
-          </a:p>
-          <a:p>
-            <a:pPr>
-              <a:spcBef>
-                <a:spcPts val="400"/>
-              </a:spcBef>
-              <a:defRPr sz="1200">
-                <a:solidFill>
-                  <a:srgbClr val="FFFFFF"/>
-                </a:solidFill>
-              </a:defRPr>
-            </a:pPr>
-            <a:r>
-              <a:t>• Native API integration for YouTube Shorts, TikTok, and Reels</a:t>
-            </a:r>
-            <a:br/>
-            <a:r>
-              <a:t>• Creator voice cloning pipeline via ElevenLabs</a:t>
-            </a:r>
-            <a:br/>
-            <a:r>
-              <a:t>• Scheduled automated daily publishing queues</a:t>
-            </a:r>
-            <a:br/>
-            <a:r>
-              <a:t>• Discord / Slack notification bots on viral opportunity alerts</a:t>
-            </a:r>
-          </a:p>
-        </p:txBody>
-      </p:sp>
-      <p:sp>
-        <p:nvSpPr>
-          <p:cNvPr id="7" name="Rounded Rectangle 6"/>
-          <p:cNvSpPr/>
-          <p:nvPr/>
-        </p:nvSpPr>
-        <p:spPr>
-          <a:xfrm>
-            <a:off x="731520" y="4663440"/>
-            <a:ext cx="10698480" cy="1325880"/>
-          </a:xfrm>
-          <a:prstGeom prst="roundRect">
-            <a:avLst/>
-          </a:prstGeom>
-          <a:solidFill>
-            <a:srgbClr val="141824"/>
-          </a:solidFill>
-          <a:ln>
-            <a:solidFill>
-              <a:srgbClr val="262E44"/>
-            </a:solidFill>
-          </a:ln>
-        </p:spPr>
-        <p:style>
-          <a:lnRef idx="1">
-            <a:schemeClr val="accent1"/>
-          </a:lnRef>
-          <a:fillRef idx="3">
-            <a:schemeClr val="accent1"/>
-          </a:fillRef>
-          <a:effectRef idx="2">
-            <a:schemeClr val="accent1"/>
-          </a:effectRef>
-          <a:fontRef idx="minor">
-            <a:schemeClr val="lt1"/>
-          </a:fontRef>
-        </p:style>
-        <p:txBody>
-          <a:bodyPr rtlCol="0" anchor="ctr" wrap="square"/>
-          <a:lstStyle/>
-          <a:p>
-            <a:pPr algn="ctr">
-              <a:defRPr sz="1500" b="1">
-                <a:solidFill>
-                  <a:srgbClr val="FFE600"/>
-                </a:solidFill>
-              </a:defRPr>
-            </a:pPr>
-            <a:r>
-              <a:t>PHASE 3 (LONG-TERM VISION)  |  Self-Evolving Retention Feedback Loop</a:t>
-            </a:r>
-          </a:p>
-          <a:p>
-            <a:pPr>
-              <a:spcBef>
-                <a:spcPts val="400"/>
-              </a:spcBef>
-              <a:defRPr sz="1200">
-                <a:solidFill>
-                  <a:srgbClr val="FFFFFF"/>
-                </a:solidFill>
-              </a:defRPr>
-            </a:pPr>
-            <a:r>
-              <a:t>• Agents ingest live viewer retention analytics &amp; watch time</a:t>
-            </a:r>
-            <a:br/>
-            <a:r>
-              <a:t>• Autonomous A/B testing of alternate hooks</a:t>
-            </a:r>
-            <a:br/>
-            <a:r>
-              <a:t>• Self-tuning Creator DNA based on video performance data</a:t>
-            </a:r>
-            <a:br/>
-            <a:r>
-              <a:t>• Automated localized multi-language video dubbing</a:t>
-            </a:r>
-          </a:p>
-        </p:txBody>
-      </p:sp>
-    </p:spTree>
-  </p:cSld>
-  <p:clrMapOvr>
-    <a:masterClrMapping/>
-  </p:clrMapOvr>
-</p:sld>
-</file>
-
-<file path=ppt/slides/slide8.xml><?xml version="1.0" encoding="utf-8"?>
-<p:sld xmlns:a="http://schemas.openxmlformats.org/drawingml/2006/main" xmlns:p="http://schemas.openxmlformats.org/presentationml/2006/main" xmlns:r="http://schemas.openxmlformats.org/officeDocument/2006/relationships">
-  <p:cSld>
-    <p:spTree>
-      <p:nvGrpSpPr>
-        <p:cNvPr id="1" name=""/>
-        <p:cNvGrpSpPr/>
-        <p:nvPr/>
-      </p:nvGrpSpPr>
-      <p:grpSpPr/>
-      <p:sp>
-        <p:nvSpPr>
-          <p:cNvPr id="2" name="Rectangle 1"/>
-          <p:cNvSpPr/>
-          <p:nvPr/>
-        </p:nvSpPr>
-        <p:spPr>
-          <a:xfrm>
-            <a:off x="0" y="0"/>
-            <a:ext cx="12191695" cy="6858000"/>
-          </a:xfrm>
-          <a:prstGeom prst="rect">
-            <a:avLst/>
-          </a:prstGeom>
-          <a:solidFill>
-            <a:srgbClr val="0A0C12"/>
-          </a:solidFill>
-          <a:ln>
-            <a:noFill/>
-          </a:ln>
-        </p:spPr>
-        <p:style>
-          <a:lnRef idx="1">
-            <a:schemeClr val="accent1"/>
-          </a:lnRef>
-          <a:fillRef idx="3">
-            <a:schemeClr val="accent1"/>
-          </a:fillRef>
-          <a:effectRef idx="2">
-            <a:schemeClr val="accent1"/>
-          </a:effectRef>
-          <a:fontRef idx="minor">
-            <a:schemeClr val="lt1"/>
-          </a:fontRef>
-        </p:style>
-        <p:txBody>
-          <a:bodyPr rtlCol="0" anchor="ctr"/>
-          <a:lstStyle/>
-          <a:p>
-            <a:pPr algn="ctr"/>
-          </a:p>
-        </p:txBody>
-      </p:sp>
-      <p:sp>
-        <p:nvSpPr>
-          <p:cNvPr id="3" name="TextBox 2"/>
-          <p:cNvSpPr txBox="1"/>
-          <p:nvPr/>
-        </p:nvSpPr>
-        <p:spPr>
-          <a:xfrm>
-            <a:off x="731520" y="365760"/>
-            <a:ext cx="10698480" cy="320040"/>
-          </a:xfrm>
-          <a:prstGeom prst="rect">
-            <a:avLst/>
-          </a:prstGeom>
-          <a:noFill/>
-        </p:spPr>
-        <p:txBody>
-          <a:bodyPr wrap="square" lIns="0" tIns="0" rIns="0" bIns="0">
-            <a:spAutoFit/>
-          </a:bodyPr>
-          <a:lstStyle/>
-          <a:p>
-            <a:pPr>
-              <a:defRPr sz="1100" b="1">
-                <a:solidFill>
-                  <a:srgbClr val="00F0FF"/>
-                </a:solidFill>
-                <a:latin typeface="Segoe UI"/>
-              </a:defRPr>
-            </a:pPr>
-            <a:r>
-              <a:t>LIVE DEMO • CONCLUSION</a:t>
-            </a:r>
-          </a:p>
-        </p:txBody>
-      </p:sp>
-      <p:sp>
-        <p:nvSpPr>
-          <p:cNvPr id="4" name="TextBox 3"/>
-          <p:cNvSpPr txBox="1"/>
-          <p:nvPr/>
-        </p:nvSpPr>
-        <p:spPr>
-          <a:xfrm>
-            <a:off x="731520" y="685800"/>
-            <a:ext cx="10698480" cy="594360"/>
-          </a:xfrm>
-          <a:prstGeom prst="rect">
-            <a:avLst/>
-          </a:prstGeom>
-          <a:noFill/>
-        </p:spPr>
-        <p:txBody>
-          <a:bodyPr wrap="square" lIns="0" tIns="0" rIns="0" bIns="0">
-            <a:spAutoFit/>
-          </a:bodyPr>
-          <a:lstStyle/>
-          <a:p>
-            <a:pPr>
-              <a:defRPr sz="2600" b="1">
-                <a:solidFill>
-                  <a:srgbClr val="FFFFFF"/>
-                </a:solidFill>
-                <a:latin typeface="Segoe UI"/>
-              </a:defRPr>
-            </a:pPr>
-            <a:r>
-              <a:t>Ready to Experience ViralFlow AI Live</a:t>
-            </a:r>
-          </a:p>
-        </p:txBody>
-      </p:sp>
-      <p:sp>
-        <p:nvSpPr>
-          <p:cNvPr id="5" name="Rounded Rectangle 4"/>
-          <p:cNvSpPr/>
-          <p:nvPr/>
-        </p:nvSpPr>
-        <p:spPr>
-          <a:xfrm>
-            <a:off x="731520" y="1645920"/>
-            <a:ext cx="10698480" cy="4389120"/>
-          </a:xfrm>
-          <a:prstGeom prst="roundRect">
-            <a:avLst/>
-          </a:prstGeom>
-          <a:solidFill>
-            <a:srgbClr val="141824"/>
-          </a:solidFill>
-          <a:ln>
-            <a:solidFill>
-              <a:srgbClr val="00F0FF"/>
-            </a:solidFill>
-          </a:ln>
-        </p:spPr>
-        <p:style>
-          <a:lnRef idx="1">
-            <a:schemeClr val="accent1"/>
-          </a:lnRef>
-          <a:fillRef idx="3">
-            <a:schemeClr val="accent1"/>
-          </a:fillRef>
-          <a:effectRef idx="2">
-            <a:schemeClr val="accent1"/>
-          </a:effectRef>
-          <a:fontRef idx="minor">
-            <a:schemeClr val="lt1"/>
-          </a:fontRef>
-        </p:style>
-        <p:txBody>
-          <a:bodyPr rtlCol="0" anchor="ctr" wrap="square"/>
-          <a:lstStyle/>
-          <a:p>
-            <a:pPr algn="ctr">
-              <a:defRPr sz="2200" b="1">
-                <a:solidFill>
-                  <a:srgbClr val="FFE600"/>
-                </a:solidFill>
-              </a:defRPr>
-            </a:pPr>
-            <a:r>
-              <a:t>ViralFlow AI: Transforming Trends into Broadcast-Ready Content in 6 Seconds.</a:t>
-            </a:r>
-          </a:p>
-          <a:p>
-            <a:pPr>
-              <a:spcBef>
-                <a:spcPts val="1000"/>
-              </a:spcBef>
-              <a:defRPr sz="1500">
-                <a:solidFill>
-                  <a:srgbClr val="94A3B8"/>
-                </a:solidFill>
-              </a:defRPr>
-            </a:pPr>
-            <a:r>
-              <a:t>We invite judges and mentors to test our live deployment and review our open codebase:</a:t>
-            </a:r>
-          </a:p>
-          <a:p>
-            <a:pPr>
-              <a:spcBef>
-                <a:spcPts val="1400"/>
-              </a:spcBef>
-              <a:defRPr sz="1800" b="1">
-                <a:solidFill>
-                  <a:srgbClr val="00F0FF"/>
-                </a:solidFill>
-              </a:defRPr>
-            </a:pPr>
-            <a:r>
-              <a:t>🚀 Live Web App: https://my-viralflow-ai.vercel.app</a:t>
-            </a:r>
-          </a:p>
-          <a:p>
-            <a:pPr>
-              <a:spcBef>
-                <a:spcPts val="800"/>
-              </a:spcBef>
-              <a:defRPr sz="1800" b="1">
-                <a:solidFill>
-                  <a:srgbClr val="FFFFFF"/>
-                </a:solidFill>
-              </a:defRPr>
-            </a:pPr>
-            <a:r>
-              <a:t>💻 GitHub Repository: https://github.com/Ibrahim2637/ViralFlow.Ai</a:t>
-            </a:r>
-          </a:p>
-          <a:p>
-            <a:pPr>
-              <a:spcBef>
-                <a:spcPts val="800"/>
-              </a:spcBef>
-              <a:defRPr sz="1500">
-                <a:solidFill>
-                  <a:srgbClr val="00FFA3"/>
-                </a:solidFill>
-              </a:defRPr>
-            </a:pPr>
-            <a:r>
-              <a:t>⚡ n8n Webhook: https://primary-production-675a3.up.railway.app/webhook/viralflow-produce</a:t>
-            </a:r>
-          </a:p>
-          <a:p>
-            <a:pPr>
-              <a:spcBef>
-                <a:spcPts val="2000"/>
-              </a:spcBef>
-              <a:defRPr sz="2000" b="1">
-                <a:solidFill>
-                  <a:srgbClr val="FFE600"/>
-                </a:solidFill>
-              </a:defRPr>
-            </a:pPr>
-            <a:r>
-              <a:t>Thank you! We're ready for Questions &amp; Live Interactive Demo.</a:t>
+              <a:t>Thank you for evaluating ViralFlow AI!</a:t>
             </a:r>
           </a:p>
         </p:txBody>

</xml_diff>